<commit_message>
Rename grill-me to grill-me-for-research, add QR code to slides, add prompts.md
</commit_message>
<xml_diff>
--- a/Levels of Using AI in Research.pptx
+++ b/Levels of Using AI in Research.pptx
@@ -11540,6 +11540,64 @@
           </a:prstGeom>
         </p:spPr>
       </p:pic>
+      <p:pic>
+        <p:nvPicPr>
+          <p:cNvPr id="11" name="Picture 10" descr="repo_qr.png"/>
+          <p:cNvPicPr>
+            <a:picLocks noChangeAspect="1"/>
+          </p:cNvPicPr>
+          <p:nvPr/>
+        </p:nvPicPr>
+        <p:blipFill>
+          <a:blip r:embed="rId5"/>
+          <a:stretch>
+            <a:fillRect/>
+          </a:stretch>
+        </p:blipFill>
+        <p:spPr>
+          <a:xfrm>
+            <a:off x="11186160" y="5193792"/>
+            <a:ext cx="777240" cy="777240"/>
+          </a:xfrm>
+          <a:prstGeom prst="rect">
+            <a:avLst/>
+          </a:prstGeom>
+        </p:spPr>
+      </p:pic>
+      <p:sp>
+        <p:nvSpPr>
+          <p:cNvPr id="12" name="TextBox 11"/>
+          <p:cNvSpPr txBox="1"/>
+          <p:nvPr/>
+        </p:nvSpPr>
+        <p:spPr>
+          <a:xfrm>
+            <a:off x="10957560" y="5989320"/>
+            <a:ext cx="1234440" cy="292608"/>
+          </a:xfrm>
+          <a:prstGeom prst="rect">
+            <a:avLst/>
+          </a:prstGeom>
+          <a:noFill/>
+        </p:spPr>
+        <p:txBody>
+          <a:bodyPr wrap="square">
+            <a:spAutoFit/>
+          </a:bodyPr>
+          <a:lstStyle/>
+          <a:p>
+            <a:pPr algn="ctr"/>
+            <a:r>
+              <a:rPr sz="700">
+                <a:solidFill>
+                  <a:srgbClr val="595959"/>
+                </a:solidFill>
+              </a:rPr>
+              <a:t>github.com/Aptamer1/ai-research-day-08092026</a:t>
+            </a:r>
+          </a:p>
+        </p:txBody>
+      </p:sp>
     </p:spTree>
   </p:cSld>
   <p:clrMapOvr>
@@ -12956,6 +13014,64 @@
           </a:prstGeom>
         </p:spPr>
       </p:pic>
+      <p:pic>
+        <p:nvPicPr>
+          <p:cNvPr id="39" name="Picture 38" descr="repo_qr.png"/>
+          <p:cNvPicPr>
+            <a:picLocks noChangeAspect="1"/>
+          </p:cNvPicPr>
+          <p:nvPr/>
+        </p:nvPicPr>
+        <p:blipFill>
+          <a:blip r:embed="rId4"/>
+          <a:stretch>
+            <a:fillRect/>
+          </a:stretch>
+        </p:blipFill>
+        <p:spPr>
+          <a:xfrm>
+            <a:off x="11186160" y="5193792"/>
+            <a:ext cx="777240" cy="777240"/>
+          </a:xfrm>
+          <a:prstGeom prst="rect">
+            <a:avLst/>
+          </a:prstGeom>
+        </p:spPr>
+      </p:pic>
+      <p:sp>
+        <p:nvSpPr>
+          <p:cNvPr id="40" name="TextBox 39"/>
+          <p:cNvSpPr txBox="1"/>
+          <p:nvPr/>
+        </p:nvSpPr>
+        <p:spPr>
+          <a:xfrm>
+            <a:off x="10957560" y="5989320"/>
+            <a:ext cx="1234440" cy="292608"/>
+          </a:xfrm>
+          <a:prstGeom prst="rect">
+            <a:avLst/>
+          </a:prstGeom>
+          <a:noFill/>
+        </p:spPr>
+        <p:txBody>
+          <a:bodyPr wrap="square">
+            <a:spAutoFit/>
+          </a:bodyPr>
+          <a:lstStyle/>
+          <a:p>
+            <a:pPr algn="ctr"/>
+            <a:r>
+              <a:rPr sz="700">
+                <a:solidFill>
+                  <a:srgbClr val="595959"/>
+                </a:solidFill>
+              </a:rPr>
+              <a:t>github.com/Aptamer1/ai-research-day-08092026</a:t>
+            </a:r>
+          </a:p>
+        </p:txBody>
+      </p:sp>
     </p:spTree>
   </p:cSld>
   <p:clrMapOvr>

</xml_diff>

<commit_message>
Trim skill-body attribution to README, fix QR consistency across slides
</commit_message>
<xml_diff>
--- a/Levels of Using AI in Research.pptx
+++ b/Levels of Using AI in Research.pptx
@@ -3877,6 +3877,148 @@
           </a:prstGeom>
         </p:spPr>
       </p:pic>
+      <p:pic>
+        <p:nvPicPr>
+          <p:cNvPr id="11" name="Picture 10" descr="repo_qr.png">
+            <a:extLst>
+              <a:ext uri="{FF2B5EF4-FFF2-40B4-BE49-F238E27FC236}">
+                <a16:creationId xmlns:a16="http://schemas.microsoft.com/office/drawing/2014/main" id="{8EC4A624-B474-9426-ADF9-BBAB6AF298E3}"/>
+              </a:ext>
+            </a:extLst>
+          </p:cNvPr>
+          <p:cNvPicPr>
+            <a:picLocks noChangeAspect="1"/>
+          </p:cNvPicPr>
+          <p:nvPr/>
+        </p:nvPicPr>
+        <p:blipFill>
+          <a:blip r:embed="rId4"/>
+          <a:stretch>
+            <a:fillRect/>
+          </a:stretch>
+        </p:blipFill>
+        <p:spPr>
+          <a:xfrm>
+            <a:off x="10316279" y="4644180"/>
+            <a:ext cx="1542331" cy="1542331"/>
+          </a:xfrm>
+          <a:prstGeom prst="rect">
+            <a:avLst/>
+          </a:prstGeom>
+        </p:spPr>
+      </p:pic>
+      <p:sp>
+        <p:nvSpPr>
+          <p:cNvPr id="13" name="TextBox 12">
+            <a:extLst>
+              <a:ext uri="{FF2B5EF4-FFF2-40B4-BE49-F238E27FC236}">
+                <a16:creationId xmlns:a16="http://schemas.microsoft.com/office/drawing/2014/main" id="{3204A97D-8C88-C0C2-70C5-A734A16B0343}"/>
+              </a:ext>
+            </a:extLst>
+          </p:cNvPr>
+          <p:cNvSpPr txBox="1"/>
+          <p:nvPr/>
+        </p:nvSpPr>
+        <p:spPr>
+          <a:xfrm>
+            <a:off x="10304592" y="6308467"/>
+            <a:ext cx="1554018" cy="307777"/>
+          </a:xfrm>
+          <a:prstGeom prst="rect">
+            <a:avLst/>
+          </a:prstGeom>
+          <a:noFill/>
+        </p:spPr>
+        <p:txBody>
+          <a:bodyPr wrap="square">
+            <a:spAutoFit/>
+          </a:bodyPr>
+          <a:lstStyle/>
+          <a:p>
+            <a:pPr algn="ctr"/>
+            <a:r>
+              <a:rPr sz="700" dirty="0">
+                <a:solidFill>
+                  <a:srgbClr val="595959"/>
+                </a:solidFill>
+              </a:rPr>
+              <a:t>github.com/Aptamer1/ai-research-day-08092026</a:t>
+            </a:r>
+          </a:p>
+        </p:txBody>
+      </p:sp>
+      <p:sp>
+        <p:nvSpPr>
+          <p:cNvPr id="16" name="TextBox 15">
+            <a:extLst>
+              <a:ext uri="{FF2B5EF4-FFF2-40B4-BE49-F238E27FC236}">
+                <a16:creationId xmlns:a16="http://schemas.microsoft.com/office/drawing/2014/main" id="{E9AF2C96-C343-A0B2-8CDC-61282D8E4AC0}"/>
+              </a:ext>
+            </a:extLst>
+          </p:cNvPr>
+          <p:cNvSpPr txBox="1"/>
+          <p:nvPr/>
+        </p:nvSpPr>
+        <p:spPr>
+          <a:xfrm>
+            <a:off x="9907682" y="4049673"/>
+            <a:ext cx="2359524" cy="523220"/>
+          </a:xfrm>
+          <a:prstGeom prst="rect">
+            <a:avLst/>
+          </a:prstGeom>
+          <a:noFill/>
+        </p:spPr>
+        <p:txBody>
+          <a:bodyPr wrap="square" rtlCol="0">
+            <a:spAutoFit/>
+          </a:bodyPr>
+          <a:lstStyle/>
+          <a:p>
+            <a:pPr algn="ctr"/>
+            <a:r>
+              <a:rPr lang="nl-BE" sz="1400" dirty="0">
+                <a:solidFill>
+                  <a:schemeClr val="accent1"/>
+                </a:solidFill>
+              </a:rPr>
+              <a:t>Want </a:t>
+            </a:r>
+            <a:r>
+              <a:rPr lang="nl-BE" sz="1400" dirty="0" err="1">
+                <a:solidFill>
+                  <a:schemeClr val="accent1"/>
+                </a:solidFill>
+              </a:rPr>
+              <a:t>to</a:t>
+            </a:r>
+            <a:r>
+              <a:rPr lang="nl-BE" sz="1400" dirty="0">
+                <a:solidFill>
+                  <a:schemeClr val="accent1"/>
+                </a:solidFill>
+              </a:rPr>
+              <a:t> follow </a:t>
+            </a:r>
+            <a:r>
+              <a:rPr lang="nl-BE" sz="1400" dirty="0" err="1">
+                <a:solidFill>
+                  <a:schemeClr val="accent1"/>
+                </a:solidFill>
+              </a:rPr>
+              <a:t>along</a:t>
+            </a:r>
+            <a:r>
+              <a:rPr lang="nl-BE" sz="1400" dirty="0">
+                <a:solidFill>
+                  <a:schemeClr val="accent1"/>
+                </a:solidFill>
+              </a:rPr>
+              <a:t> / access resources?:</a:t>
+            </a:r>
+          </a:p>
+        </p:txBody>
+      </p:sp>
     </p:spTree>
   </p:cSld>
   <p:clrMapOvr>
@@ -4786,6 +4928,30 @@
           <a:xfrm>
             <a:off x="5074920" y="6519672"/>
             <a:ext cx="771579" cy="182880"/>
+          </a:xfrm>
+          <a:prstGeom prst="rect">
+            <a:avLst/>
+          </a:prstGeom>
+        </p:spPr>
+      </p:pic>
+      <p:pic>
+        <p:nvPicPr>
+          <p:cNvPr id="24" name="Picture 23" descr="image.png"/>
+          <p:cNvPicPr>
+            <a:picLocks noChangeAspect="1"/>
+          </p:cNvPicPr>
+          <p:nvPr/>
+        </p:nvPicPr>
+        <p:blipFill>
+          <a:blip r:embed="rId5"/>
+          <a:stretch>
+            <a:fillRect/>
+          </a:stretch>
+        </p:blipFill>
+        <p:spPr>
+          <a:xfrm>
+            <a:off x="10807293" y="201168"/>
+            <a:ext cx="1051560" cy="1051560"/>
           </a:xfrm>
           <a:prstGeom prst="rect">
             <a:avLst/>
@@ -6077,6 +6243,30 @@
           </a:prstGeom>
         </p:spPr>
       </p:pic>
+      <p:pic>
+        <p:nvPicPr>
+          <p:cNvPr id="29" name="Picture 28" descr="image.png"/>
+          <p:cNvPicPr>
+            <a:picLocks noChangeAspect="1"/>
+          </p:cNvPicPr>
+          <p:nvPr/>
+        </p:nvPicPr>
+        <p:blipFill>
+          <a:blip r:embed="rId4"/>
+          <a:stretch>
+            <a:fillRect/>
+          </a:stretch>
+        </p:blipFill>
+        <p:spPr>
+          <a:xfrm>
+            <a:off x="11183112" y="4320540"/>
+            <a:ext cx="640080" cy="640080"/>
+          </a:xfrm>
+          <a:prstGeom prst="rect">
+            <a:avLst/>
+          </a:prstGeom>
+        </p:spPr>
+      </p:pic>
     </p:spTree>
   </p:cSld>
   <p:clrMapOvr>
@@ -7239,6 +7429,30 @@
           <a:xfrm>
             <a:off x="5074920" y="6519672"/>
             <a:ext cx="771579" cy="182880"/>
+          </a:xfrm>
+          <a:prstGeom prst="rect">
+            <a:avLst/>
+          </a:prstGeom>
+        </p:spPr>
+      </p:pic>
+      <p:pic>
+        <p:nvPicPr>
+          <p:cNvPr id="30" name="Picture 29" descr="image.png"/>
+          <p:cNvPicPr>
+            <a:picLocks noChangeAspect="1"/>
+          </p:cNvPicPr>
+          <p:nvPr/>
+        </p:nvPicPr>
+        <p:blipFill>
+          <a:blip r:embed="rId4"/>
+          <a:stretch>
+            <a:fillRect/>
+          </a:stretch>
+        </p:blipFill>
+        <p:spPr>
+          <a:xfrm>
+            <a:off x="10807293" y="201168"/>
+            <a:ext cx="1051560" cy="1051560"/>
           </a:xfrm>
           <a:prstGeom prst="rect">
             <a:avLst/>
@@ -11359,7 +11573,7 @@
         </p:nvSpPr>
         <p:spPr>
           <a:xfrm>
-            <a:off x="731520" y="5148072"/>
+            <a:off x="829654" y="3799332"/>
             <a:ext cx="10424160" cy="896112"/>
           </a:xfrm>
           <a:prstGeom prst="roundRect">
@@ -11540,64 +11754,6 @@
           </a:prstGeom>
         </p:spPr>
       </p:pic>
-      <p:pic>
-        <p:nvPicPr>
-          <p:cNvPr id="11" name="Picture 10" descr="repo_qr.png"/>
-          <p:cNvPicPr>
-            <a:picLocks noChangeAspect="1"/>
-          </p:cNvPicPr>
-          <p:nvPr/>
-        </p:nvPicPr>
-        <p:blipFill>
-          <a:blip r:embed="rId5"/>
-          <a:stretch>
-            <a:fillRect/>
-          </a:stretch>
-        </p:blipFill>
-        <p:spPr>
-          <a:xfrm>
-            <a:off x="11186160" y="5193792"/>
-            <a:ext cx="777240" cy="777240"/>
-          </a:xfrm>
-          <a:prstGeom prst="rect">
-            <a:avLst/>
-          </a:prstGeom>
-        </p:spPr>
-      </p:pic>
-      <p:sp>
-        <p:nvSpPr>
-          <p:cNvPr id="12" name="TextBox 11"/>
-          <p:cNvSpPr txBox="1"/>
-          <p:nvPr/>
-        </p:nvSpPr>
-        <p:spPr>
-          <a:xfrm>
-            <a:off x="10957560" y="5989320"/>
-            <a:ext cx="1234440" cy="292608"/>
-          </a:xfrm>
-          <a:prstGeom prst="rect">
-            <a:avLst/>
-          </a:prstGeom>
-          <a:noFill/>
-        </p:spPr>
-        <p:txBody>
-          <a:bodyPr wrap="square">
-            <a:spAutoFit/>
-          </a:bodyPr>
-          <a:lstStyle/>
-          <a:p>
-            <a:pPr algn="ctr"/>
-            <a:r>
-              <a:rPr sz="700">
-                <a:solidFill>
-                  <a:srgbClr val="595959"/>
-                </a:solidFill>
-              </a:rPr>
-              <a:t>github.com/Aptamer1/ai-research-day-08092026</a:t>
-            </a:r>
-          </a:p>
-        </p:txBody>
-      </p:sp>
     </p:spTree>
   </p:cSld>
   <p:clrMapOvr>
@@ -11639,7 +11795,7 @@
         </p:blipFill>
         <p:spPr>
           <a:xfrm>
-            <a:off x="169333" y="76200"/>
+            <a:off x="365600" y="182936"/>
             <a:ext cx="11826400" cy="6687200"/>
           </a:xfrm>
           <a:prstGeom prst="rect">
@@ -13014,64 +13170,6 @@
           </a:prstGeom>
         </p:spPr>
       </p:pic>
-      <p:pic>
-        <p:nvPicPr>
-          <p:cNvPr id="39" name="Picture 38" descr="repo_qr.png"/>
-          <p:cNvPicPr>
-            <a:picLocks noChangeAspect="1"/>
-          </p:cNvPicPr>
-          <p:nvPr/>
-        </p:nvPicPr>
-        <p:blipFill>
-          <a:blip r:embed="rId4"/>
-          <a:stretch>
-            <a:fillRect/>
-          </a:stretch>
-        </p:blipFill>
-        <p:spPr>
-          <a:xfrm>
-            <a:off x="11186160" y="5193792"/>
-            <a:ext cx="777240" cy="777240"/>
-          </a:xfrm>
-          <a:prstGeom prst="rect">
-            <a:avLst/>
-          </a:prstGeom>
-        </p:spPr>
-      </p:pic>
-      <p:sp>
-        <p:nvSpPr>
-          <p:cNvPr id="40" name="TextBox 39"/>
-          <p:cNvSpPr txBox="1"/>
-          <p:nvPr/>
-        </p:nvSpPr>
-        <p:spPr>
-          <a:xfrm>
-            <a:off x="10957560" y="5989320"/>
-            <a:ext cx="1234440" cy="292608"/>
-          </a:xfrm>
-          <a:prstGeom prst="rect">
-            <a:avLst/>
-          </a:prstGeom>
-          <a:noFill/>
-        </p:spPr>
-        <p:txBody>
-          <a:bodyPr wrap="square">
-            <a:spAutoFit/>
-          </a:bodyPr>
-          <a:lstStyle/>
-          <a:p>
-            <a:pPr algn="ctr"/>
-            <a:r>
-              <a:rPr sz="700">
-                <a:solidFill>
-                  <a:srgbClr val="595959"/>
-                </a:solidFill>
-              </a:rPr>
-              <a:t>github.com/Aptamer1/ai-research-day-08092026</a:t>
-            </a:r>
-          </a:p>
-        </p:txBody>
-      </p:sp>
     </p:spTree>
   </p:cSld>
   <p:clrMapOvr>
@@ -19995,6 +20093,30 @@
           <a:xfrm>
             <a:off x="5074920" y="6519672"/>
             <a:ext cx="771579" cy="182880"/>
+          </a:xfrm>
+          <a:prstGeom prst="rect">
+            <a:avLst/>
+          </a:prstGeom>
+        </p:spPr>
+      </p:pic>
+      <p:pic>
+        <p:nvPicPr>
+          <p:cNvPr id="24" name="Picture 23" descr="image.png"/>
+          <p:cNvPicPr>
+            <a:picLocks noChangeAspect="1"/>
+          </p:cNvPicPr>
+          <p:nvPr/>
+        </p:nvPicPr>
+        <p:blipFill>
+          <a:blip r:embed="rId5"/>
+          <a:stretch>
+            <a:fillRect/>
+          </a:stretch>
+        </p:blipFill>
+        <p:spPr>
+          <a:xfrm>
+            <a:off x="10807293" y="201168"/>
+            <a:ext cx="1051560" cy="1051560"/>
           </a:xfrm>
           <a:prstGeom prst="rect">
             <a:avLst/>

</xml_diff>

<commit_message>
Rename folder to 'research skills and prompts templates', add skill-library recap slide
</commit_message>
<xml_diff>
--- a/Levels of Using AI in Research.pptx
+++ b/Levels of Using AI in Research.pptx
@@ -5,7 +5,7 @@
     <p:sldMasterId id="2147483648" r:id="rId1"/>
   </p:sldMasterIdLst>
   <p:notesMasterIdLst>
-    <p:notesMasterId r:id="rId19"/>
+    <p:notesMasterId r:id="rId20"/>
   </p:notesMasterIdLst>
   <p:sldIdLst>
     <p:sldId id="256" r:id="rId2"/>
@@ -20,11 +20,12 @@
     <p:sldId id="264" r:id="rId11"/>
     <p:sldId id="265" r:id="rId12"/>
     <p:sldId id="266" r:id="rId13"/>
-    <p:sldId id="267" r:id="rId14"/>
-    <p:sldId id="268" r:id="rId15"/>
-    <p:sldId id="269" r:id="rId16"/>
-    <p:sldId id="270" r:id="rId17"/>
-    <p:sldId id="272" r:id="rId18"/>
+    <p:sldId id="273" r:id="rId14"/>
+    <p:sldId id="267" r:id="rId15"/>
+    <p:sldId id="268" r:id="rId16"/>
+    <p:sldId id="269" r:id="rId17"/>
+    <p:sldId id="270" r:id="rId18"/>
+    <p:sldId id="272" r:id="rId19"/>
   </p:sldIdLst>
   <p:sldSz cx="12192000" cy="6858000"/>
   <p:notesSz cx="6858000" cy="9144000"/>
@@ -7486,7 +7487,7 @@
       </p:grpSpPr>
       <p:pic>
         <p:nvPicPr>
-          <p:cNvPr id="21" name="Picture 20" descr="border_clean.png"/>
+          <p:cNvPr id="22" name="Picture 21" descr="border_clean.png"/>
           <p:cNvPicPr>
             <a:picLocks noChangeAspect="1"/>
           </p:cNvPicPr>
@@ -7537,7 +7538,7 @@
                 </a:solidFill>
                 <a:latin typeface="Segoe UI Semibold"/>
               </a:rPr>
-              <a:t>LEVEL 5 · MULTIPLE MODELS</a:t>
+              <a:t>LEVEL 4 · SKILL LIBRARY</a:t>
             </a:r>
           </a:p>
         </p:txBody>
@@ -7571,32 +7572,102 @@
                 </a:solidFill>
                 <a:latin typeface="Segoe UI Semibold"/>
               </a:rPr>
-              <a:t>One model writes, another reviews</a:t>
-            </a:r>
-          </a:p>
-        </p:txBody>
-      </p:sp>
-      <p:sp>
-        <p:nvSpPr>
-          <p:cNvPr id="4" name="Rounded Rectangle 3"/>
+              <a:t>All 9 skills, in one place</a:t>
+            </a:r>
+          </a:p>
+        </p:txBody>
+      </p:sp>
+      <p:sp>
+        <p:nvSpPr>
+          <p:cNvPr id="4" name="TextBox 3"/>
+          <p:cNvSpPr txBox="1"/>
+          <p:nvPr/>
+        </p:nvSpPr>
+        <p:spPr>
+          <a:xfrm>
+            <a:off x="731520" y="1325880"/>
+            <a:ext cx="10424160" cy="400110"/>
+          </a:xfrm>
+          <a:prstGeom prst="rect">
+            <a:avLst/>
+          </a:prstGeom>
+          <a:noFill/>
+        </p:spPr>
+        <p:txBody>
+          <a:bodyPr wrap="square" lIns="0" tIns="0" rIns="0" bIns="0">
+            <a:spAutoFit/>
+          </a:bodyPr>
+          <a:lstStyle/>
+          <a:p>
+            <a:r>
+              <a:rPr sz="1300" b="0" dirty="0">
+                <a:solidFill>
+                  <a:srgbClr val="898781"/>
+                </a:solidFill>
+                <a:latin typeface="Segoe UI"/>
+              </a:rPr>
+              <a:t>Everything from Level 4, listed with what each one does — install any of them, or copy the prompt straight from the repo.</a:t>
+            </a:r>
+          </a:p>
+        </p:txBody>
+      </p:sp>
+      <p:sp>
+        <p:nvSpPr>
+          <p:cNvPr id="5" name="TextBox 4"/>
+          <p:cNvSpPr txBox="1"/>
+          <p:nvPr/>
+        </p:nvSpPr>
+        <p:spPr>
+          <a:xfrm>
+            <a:off x="731520" y="1965960"/>
+            <a:ext cx="5029200" cy="184666"/>
+          </a:xfrm>
+          <a:prstGeom prst="rect">
+            <a:avLst/>
+          </a:prstGeom>
+          <a:noFill/>
+        </p:spPr>
+        <p:txBody>
+          <a:bodyPr wrap="square" lIns="0" tIns="0" rIns="0" bIns="0">
+            <a:spAutoFit/>
+          </a:bodyPr>
+          <a:lstStyle/>
+          <a:p>
+            <a:r>
+              <a:rPr sz="1200" b="1" dirty="0">
+                <a:solidFill>
+                  <a:srgbClr val="2A78D6"/>
+                </a:solidFill>
+                <a:latin typeface="Segoe UI Semibold"/>
+              </a:rPr>
+              <a:t>SKILLS 1–5</a:t>
+            </a:r>
+          </a:p>
+        </p:txBody>
+      </p:sp>
+      <p:sp>
+        <p:nvSpPr>
+          <p:cNvPr id="6" name="Rounded Rectangle 5"/>
           <p:cNvSpPr/>
           <p:nvPr/>
         </p:nvSpPr>
         <p:spPr>
           <a:xfrm>
-            <a:off x="822960" y="2560320"/>
-            <a:ext cx="3063240" cy="1554480"/>
+            <a:off x="731520" y="2331720"/>
+            <a:ext cx="5029200" cy="3657600"/>
           </a:xfrm>
           <a:prstGeom prst="roundRect">
             <a:avLst>
-              <a:gd name="adj" fmla="val 10000"/>
+              <a:gd name="adj" fmla="val 4000"/>
             </a:avLst>
           </a:prstGeom>
           <a:solidFill>
-            <a:srgbClr val="CDE2FB"/>
+            <a:srgbClr val="F0EFEC"/>
           </a:solidFill>
-          <a:ln>
-            <a:noFill/>
+          <a:ln w="9525">
+            <a:solidFill>
+              <a:srgbClr val="E1E0D9"/>
+            </a:solidFill>
           </a:ln>
           <a:effectLst/>
         </p:spPr>
@@ -7615,134 +7686,146 @@
           </a:fontRef>
         </p:style>
         <p:txBody>
-          <a:bodyPr wrap="square" tIns="54864" bIns="54864" rtlCol="0" anchor="ctr"/>
-          <a:lstStyle/>
-          <a:p>
-            <a:pPr algn="ctr"/>
-            <a:r>
-              <a:rPr sz="1600" b="1">
+          <a:bodyPr wrap="square" lIns="182880" tIns="137160" rIns="182880" bIns="137160" rtlCol="0" anchor="t"/>
+          <a:lstStyle/>
+          <a:p>
+            <a:pPr algn="just">
+              <a:lnSpc>
+                <a:spcPct val="110000"/>
+              </a:lnSpc>
+              <a:spcAft>
+                <a:spcPts val="700"/>
+              </a:spcAft>
+            </a:pPr>
+            <a:r>
+              <a:rPr sz="1100" b="1">
                 <a:solidFill>
                   <a:srgbClr val="0B0B0B"/>
                 </a:solidFill>
-                <a:latin typeface="Segoe UI Semibold"/>
-              </a:rPr>
-              <a:t>Model A</a:t>
-            </a:r>
-          </a:p>
-          <a:p>
-            <a:pPr algn="ctr"/>
-            <a:r>
-              <a:rPr sz="1200" b="0" i="1">
+                <a:latin typeface="Consolas"/>
+              </a:rPr>
+              <a:t>/grant-evaluator [funder]</a:t>
+            </a:r>
+            <a:r>
+              <a:rPr sz="1100" b="0">
                 <a:solidFill>
                   <a:srgbClr val="0B0B0B"/>
                 </a:solidFill>
-                <a:latin typeface="Segoe UI"/>
-              </a:rPr>
-              <a:t>drafts the proposal
-section</a:t>
-            </a:r>
-          </a:p>
-        </p:txBody>
-      </p:sp>
-      <p:sp>
-        <p:nvSpPr>
-          <p:cNvPr id="5" name="TextBox 4"/>
-          <p:cNvSpPr txBox="1"/>
-          <p:nvPr/>
-        </p:nvSpPr>
-        <p:spPr>
-          <a:xfrm>
-            <a:off x="3886200" y="3154679"/>
-            <a:ext cx="502920" cy="365760"/>
-          </a:xfrm>
-          <a:prstGeom prst="rect">
-            <a:avLst/>
-          </a:prstGeom>
-          <a:noFill/>
-        </p:spPr>
-        <p:txBody>
-          <a:bodyPr wrap="square" lIns="0" tIns="0" rIns="0" bIns="0" anchor="ctr">
-            <a:spAutoFit/>
-          </a:bodyPr>
-          <a:lstStyle/>
-          <a:p>
-            <a:pPr algn="ctr"/>
-            <a:r>
-              <a:rPr sz="1800" b="0">
-                <a:solidFill>
-                  <a:srgbClr val="898781"/>
-                </a:solidFill>
-                <a:latin typeface="Segoe UI"/>
-              </a:rPr>
-              <a:t>→</a:t>
-            </a:r>
-          </a:p>
-        </p:txBody>
-      </p:sp>
-      <p:sp>
-        <p:nvSpPr>
-          <p:cNvPr id="6" name="Rounded Rectangle 5"/>
-          <p:cNvSpPr/>
-          <p:nvPr/>
-        </p:nvSpPr>
-        <p:spPr>
-          <a:xfrm>
-            <a:off x="4389120" y="2560320"/>
-            <a:ext cx="3063240" cy="1554480"/>
-          </a:xfrm>
-          <a:prstGeom prst="roundRect">
-            <a:avLst>
-              <a:gd name="adj" fmla="val 10000"/>
-            </a:avLst>
-          </a:prstGeom>
-          <a:solidFill>
-            <a:srgbClr val="F9DACC"/>
-          </a:solidFill>
-          <a:ln>
-            <a:noFill/>
-          </a:ln>
-          <a:effectLst/>
-        </p:spPr>
-        <p:style>
-          <a:lnRef idx="1">
-            <a:schemeClr val="accent1"/>
-          </a:lnRef>
-          <a:fillRef idx="3">
-            <a:schemeClr val="accent1"/>
-          </a:fillRef>
-          <a:effectRef idx="2">
-            <a:schemeClr val="accent1"/>
-          </a:effectRef>
-          <a:fontRef idx="minor">
-            <a:schemeClr val="lt1"/>
-          </a:fontRef>
-        </p:style>
-        <p:txBody>
-          <a:bodyPr wrap="square" tIns="54864" bIns="54864" rtlCol="0" anchor="ctr"/>
-          <a:lstStyle/>
-          <a:p>
-            <a:pPr algn="ctr"/>
-            <a:r>
-              <a:rPr sz="1600" b="1">
+                <a:latin typeface="Consolas"/>
+              </a:rPr>
+              <a:t>  Strict funder-style critique of a proposal section (default Horizon Europe).</a:t>
+            </a:r>
+          </a:p>
+          <a:p>
+            <a:pPr>
+              <a:lnSpc>
+                <a:spcPct val="110000"/>
+              </a:lnSpc>
+              <a:spcAft>
+                <a:spcPts val="700"/>
+              </a:spcAft>
+            </a:pPr>
+            <a:r>
+              <a:rPr sz="1100" b="1">
                 <a:solidFill>
                   <a:srgbClr val="0B0B0B"/>
                 </a:solidFill>
-                <a:latin typeface="Segoe UI Semibold"/>
-              </a:rPr>
-              <a:t>Model B</a:t>
-            </a:r>
-          </a:p>
-          <a:p>
-            <a:pPr algn="ctr"/>
-            <a:r>
-              <a:rPr sz="1200" b="0" i="1">
+                <a:latin typeface="Consolas"/>
+              </a:rPr>
+              <a:t>/bias-omission-check</a:t>
+            </a:r>
+            <a:r>
+              <a:rPr sz="1100" b="0">
                 <a:solidFill>
                   <a:srgbClr val="0B0B0B"/>
                 </a:solidFill>
-                <a:latin typeface="Segoe UI"/>
-              </a:rPr>
-              <a:t>critiques it,
-independently</a:t>
+                <a:latin typeface="Consolas"/>
+              </a:rPr>
+              <a:t>  Flags blind spots, inclusivity gaps, underrepresented stakeholders.</a:t>
+            </a:r>
+          </a:p>
+          <a:p>
+            <a:pPr>
+              <a:lnSpc>
+                <a:spcPct val="110000"/>
+              </a:lnSpc>
+              <a:spcAft>
+                <a:spcPts val="700"/>
+              </a:spcAft>
+            </a:pPr>
+            <a:r>
+              <a:rPr sz="1100" b="1">
+                <a:solidFill>
+                  <a:srgbClr val="0B0B0B"/>
+                </a:solidFill>
+                <a:latin typeface="Consolas"/>
+              </a:rPr>
+              <a:t>/grill-me-for-research [n]</a:t>
+            </a:r>
+            <a:r>
+              <a:rPr sz="1100" b="0">
+                <a:solidFill>
+                  <a:srgbClr val="0B0B0B"/>
+                </a:solidFill>
+                <a:latin typeface="Consolas"/>
+              </a:rPr>
+              <a:t>  Skeptical senior PI interrogates the proposal one question at a time.</a:t>
+            </a:r>
+          </a:p>
+          <a:p>
+            <a:pPr>
+              <a:lnSpc>
+                <a:spcPct val="110000"/>
+              </a:lnSpc>
+              <a:spcAft>
+                <a:spcPts val="700"/>
+              </a:spcAft>
+            </a:pPr>
+            <a:r>
+              <a:rPr sz="1100" b="1">
+                <a:solidFill>
+                  <a:srgbClr val="0B0B0B"/>
+                </a:solidFill>
+                <a:latin typeface="Consolas"/>
+              </a:rPr>
+              <a:t>/deconstruct-call [topic]</a:t>
+            </a:r>
+            <a:r>
+              <a:rPr sz="1100" b="0">
+                <a:solidFill>
+                  <a:srgbClr val="0B0B0B"/>
+                </a:solidFill>
+                <a:latin typeface="Consolas"/>
+              </a:rPr>
+              <a:t>  Turns a funding call text into a compliance &amp; KPI checklist.</a:t>
+            </a:r>
+          </a:p>
+          <a:p>
+            <a:pPr>
+              <a:lnSpc>
+                <a:spcPct val="110000"/>
+              </a:lnSpc>
+              <a:spcAft>
+                <a:spcPts val="700"/>
+              </a:spcAft>
+            </a:pPr>
+            <a:r>
+              <a:rPr sz="1100" b="1">
+                <a:solidFill>
+                  <a:srgbClr val="0B0B0B"/>
+                </a:solidFill>
+                <a:latin typeface="Consolas"/>
+              </a:rPr>
+              <a:t>/plain-language-polish</a:t>
+            </a:r>
+            <a:r>
+              <a:rPr sz="1100" b="0">
+                <a:solidFill>
+                  <a:srgbClr val="0B0B0B"/>
+                </a:solidFill>
+                <a:latin typeface="Consolas"/>
+              </a:rPr>
+              <a:t>  Rewrites jargon for a diverse evaluation board.</a:t>
             </a:r>
           </a:p>
         </p:txBody>
@@ -7755,111 +7838,8 @@
         </p:nvSpPr>
         <p:spPr>
           <a:xfrm>
-            <a:off x="7452360" y="3154679"/>
-            <a:ext cx="502920" cy="365760"/>
-          </a:xfrm>
-          <a:prstGeom prst="rect">
-            <a:avLst/>
-          </a:prstGeom>
-          <a:noFill/>
-        </p:spPr>
-        <p:txBody>
-          <a:bodyPr wrap="square" lIns="0" tIns="0" rIns="0" bIns="0" anchor="ctr">
-            <a:spAutoFit/>
-          </a:bodyPr>
-          <a:lstStyle/>
-          <a:p>
-            <a:pPr algn="ctr"/>
-            <a:r>
-              <a:rPr sz="1800" b="0">
-                <a:solidFill>
-                  <a:srgbClr val="898781"/>
-                </a:solidFill>
-                <a:latin typeface="Segoe UI"/>
-              </a:rPr>
-              <a:t>→</a:t>
-            </a:r>
-          </a:p>
-        </p:txBody>
-      </p:sp>
-      <p:sp>
-        <p:nvSpPr>
-          <p:cNvPr id="8" name="Rounded Rectangle 7"/>
-          <p:cNvSpPr/>
-          <p:nvPr/>
-        </p:nvSpPr>
-        <p:spPr>
-          <a:xfrm>
-            <a:off x="7955280" y="2560320"/>
-            <a:ext cx="3063240" cy="1554480"/>
-          </a:xfrm>
-          <a:prstGeom prst="roundRect">
-            <a:avLst>
-              <a:gd name="adj" fmla="val 10000"/>
-            </a:avLst>
-          </a:prstGeom>
-          <a:solidFill>
-            <a:srgbClr val="EB6834"/>
-          </a:solidFill>
-          <a:ln>
-            <a:noFill/>
-          </a:ln>
-          <a:effectLst/>
-        </p:spPr>
-        <p:style>
-          <a:lnRef idx="1">
-            <a:schemeClr val="accent1"/>
-          </a:lnRef>
-          <a:fillRef idx="3">
-            <a:schemeClr val="accent1"/>
-          </a:fillRef>
-          <a:effectRef idx="2">
-            <a:schemeClr val="accent1"/>
-          </a:effectRef>
-          <a:fontRef idx="minor">
-            <a:schemeClr val="lt1"/>
-          </a:fontRef>
-        </p:style>
-        <p:txBody>
-          <a:bodyPr wrap="square" tIns="54864" bIns="54864" rtlCol="0" anchor="ctr"/>
-          <a:lstStyle/>
-          <a:p>
-            <a:pPr algn="ctr"/>
-            <a:r>
-              <a:rPr sz="1600" b="1">
-                <a:solidFill>
-                  <a:srgbClr val="FFFFFF"/>
-                </a:solidFill>
-                <a:latin typeface="Segoe UI Semibold"/>
-              </a:rPr>
-              <a:t>Revised draft</a:t>
-            </a:r>
-          </a:p>
-          <a:p>
-            <a:pPr algn="ctr"/>
-            <a:r>
-              <a:rPr sz="1200" b="0" i="1">
-                <a:solidFill>
-                  <a:srgbClr val="FFFFFF"/>
-                </a:solidFill>
-                <a:latin typeface="Segoe UI"/>
-              </a:rPr>
-              <a:t>stronger for having
-survived a second opinion</a:t>
-            </a:r>
-          </a:p>
-        </p:txBody>
-      </p:sp>
-      <p:sp>
-        <p:nvSpPr>
-          <p:cNvPr id="9" name="TextBox 8"/>
-          <p:cNvSpPr txBox="1"/>
-          <p:nvPr/>
-        </p:nvSpPr>
-        <p:spPr>
-          <a:xfrm>
-            <a:off x="731520" y="4617720"/>
-            <a:ext cx="10424160" cy="1097280"/>
+            <a:off x="6126480" y="1965960"/>
+            <a:ext cx="5029199" cy="320040"/>
           </a:xfrm>
           <a:prstGeom prst="rect">
             <a:avLst/>
@@ -7872,37 +7852,21 @@
           </a:bodyPr>
           <a:lstStyle/>
           <a:p>
-            <a:pPr marL="320040" indent="-320040">
-              <a:spcAft>
-                <a:spcPts val="1400"/>
-              </a:spcAft>
-              <a:buFont typeface="Arial"/>
-              <a:buChar char="—  "/>
-            </a:pPr>
-            <a:r>
-              <a:rPr sz="1800" b="1">
-                <a:solidFill>
-                  <a:srgbClr val="0B0B0B"/>
-                </a:solidFill>
-                <a:latin typeface="Segoe UI"/>
-              </a:rPr>
-              <a:t>Different vendors, different blind spots — </a:t>
-            </a:r>
-            <a:r>
-              <a:rPr sz="1800" b="0">
-                <a:solidFill>
-                  <a:srgbClr val="52514E"/>
-                </a:solidFill>
-                <a:latin typeface="Segoe UI"/>
-              </a:rPr>
-              <a:t>a second opinion catches what the first model's own bias would miss.</a:t>
-            </a:r>
-          </a:p>
-        </p:txBody>
-      </p:sp>
-      <p:sp>
-        <p:nvSpPr>
-          <p:cNvPr id="10" name="TextBox 9"/>
+            <a:r>
+              <a:rPr sz="1200" b="1">
+                <a:solidFill>
+                  <a:srgbClr val="2A78D6"/>
+                </a:solidFill>
+                <a:latin typeface="Segoe UI Semibold"/>
+              </a:rPr>
+              <a:t>SKILLS 6–9</a:t>
+            </a:r>
+          </a:p>
+        </p:txBody>
+      </p:sp>
+      <p:sp>
+        <p:nvSpPr>
+          <p:cNvPr id="9" name="TextBox 8"/>
           <p:cNvSpPr txBox="1"/>
           <p:nvPr/>
         </p:nvSpPr>
@@ -7936,7 +7900,7 @@
       </p:sp>
       <p:sp>
         <p:nvSpPr>
-          <p:cNvPr id="11" name="TextBox 10"/>
+          <p:cNvPr id="10" name="TextBox 9"/>
           <p:cNvSpPr txBox="1"/>
           <p:nvPr/>
         </p:nvSpPr>
@@ -7958,7 +7922,7 @@
           <a:p>
             <a:pPr algn="r"/>
             <a:r>
-              <a:rPr sz="1000" b="0">
+              <a:rPr sz="1100" b="0">
                 <a:solidFill>
                   <a:srgbClr val="898781"/>
                 </a:solidFill>
@@ -7971,7 +7935,7 @@
       </p:sp>
       <p:cxnSp>
         <p:nvCxnSpPr>
-          <p:cNvPr id="12" name="Connector 11"/>
+          <p:cNvPr id="11" name="Connector 10"/>
           <p:cNvCxnSpPr/>
           <p:nvPr/>
         </p:nvCxnSpPr>
@@ -8006,7 +7970,7 @@
       </p:cxnSp>
       <p:sp>
         <p:nvSpPr>
-          <p:cNvPr id="13" name="Rounded Rectangle 12"/>
+          <p:cNvPr id="12" name="Rounded Rectangle 11"/>
           <p:cNvSpPr/>
           <p:nvPr/>
         </p:nvSpPr>
@@ -8052,7 +8016,7 @@
       </p:sp>
       <p:sp>
         <p:nvSpPr>
-          <p:cNvPr id="14" name="Rounded Rectangle 13"/>
+          <p:cNvPr id="13" name="Rounded Rectangle 12"/>
           <p:cNvSpPr/>
           <p:nvPr/>
         </p:nvSpPr>
@@ -8098,7 +8062,7 @@
       </p:sp>
       <p:sp>
         <p:nvSpPr>
-          <p:cNvPr id="15" name="Rounded Rectangle 14"/>
+          <p:cNvPr id="14" name="Rounded Rectangle 13"/>
           <p:cNvSpPr/>
           <p:nvPr/>
         </p:nvSpPr>
@@ -8144,7 +8108,7 @@
       </p:sp>
       <p:sp>
         <p:nvSpPr>
-          <p:cNvPr id="16" name="Rounded Rectangle 15"/>
+          <p:cNvPr id="15" name="Rounded Rectangle 14"/>
           <p:cNvSpPr/>
           <p:nvPr/>
         </p:nvSpPr>
@@ -8190,59 +8154,13 @@
       </p:sp>
       <p:sp>
         <p:nvSpPr>
-          <p:cNvPr id="17" name="Rounded Rectangle 16"/>
+          <p:cNvPr id="16" name="Rounded Rectangle 15"/>
           <p:cNvSpPr/>
           <p:nvPr/>
         </p:nvSpPr>
         <p:spPr>
           <a:xfrm>
             <a:off x="10826496" y="6583680"/>
-            <a:ext cx="201168" cy="91440"/>
-          </a:xfrm>
-          <a:prstGeom prst="roundRect">
-            <a:avLst>
-              <a:gd name="adj" fmla="val 50000"/>
-            </a:avLst>
-          </a:prstGeom>
-          <a:solidFill>
-            <a:srgbClr val="2A78D6"/>
-          </a:solidFill>
-          <a:ln>
-            <a:noFill/>
-          </a:ln>
-        </p:spPr>
-        <p:style>
-          <a:lnRef idx="1">
-            <a:schemeClr val="accent1"/>
-          </a:lnRef>
-          <a:fillRef idx="3">
-            <a:schemeClr val="accent1"/>
-          </a:fillRef>
-          <a:effectRef idx="2">
-            <a:schemeClr val="accent1"/>
-          </a:effectRef>
-          <a:fontRef idx="minor">
-            <a:schemeClr val="lt1"/>
-          </a:fontRef>
-        </p:style>
-        <p:txBody>
-          <a:bodyPr rtlCol="0" anchor="ctr"/>
-          <a:lstStyle/>
-          <a:p>
-            <a:pPr algn="ctr"/>
-            <a:endParaRPr/>
-          </a:p>
-        </p:txBody>
-      </p:sp>
-      <p:sp>
-        <p:nvSpPr>
-          <p:cNvPr id="18" name="Rounded Rectangle 17"/>
-          <p:cNvSpPr/>
-          <p:nvPr/>
-        </p:nvSpPr>
-        <p:spPr>
-          <a:xfrm>
-            <a:off x="11073384" y="6583680"/>
             <a:ext cx="201168" cy="91440"/>
           </a:xfrm>
           <a:prstGeom prst="roundRect">
@@ -8282,13 +8200,13 @@
       </p:sp>
       <p:sp>
         <p:nvSpPr>
-          <p:cNvPr id="19" name="Rounded Rectangle 18"/>
+          <p:cNvPr id="17" name="Rounded Rectangle 16"/>
           <p:cNvSpPr/>
           <p:nvPr/>
         </p:nvSpPr>
         <p:spPr>
           <a:xfrm>
-            <a:off x="11320272" y="6583680"/>
+            <a:off x="11073384" y="6583680"/>
             <a:ext cx="201168" cy="91440"/>
           </a:xfrm>
           <a:prstGeom prst="roundRect">
@@ -8328,7 +8246,53 @@
       </p:sp>
       <p:sp>
         <p:nvSpPr>
-          <p:cNvPr id="20" name="TextBox 19"/>
+          <p:cNvPr id="18" name="Rounded Rectangle 17"/>
+          <p:cNvSpPr/>
+          <p:nvPr/>
+        </p:nvSpPr>
+        <p:spPr>
+          <a:xfrm>
+            <a:off x="11320272" y="6583680"/>
+            <a:ext cx="201168" cy="91440"/>
+          </a:xfrm>
+          <a:prstGeom prst="roundRect">
+            <a:avLst>
+              <a:gd name="adj" fmla="val 50000"/>
+            </a:avLst>
+          </a:prstGeom>
+          <a:solidFill>
+            <a:srgbClr val="E1E0D9"/>
+          </a:solidFill>
+          <a:ln>
+            <a:noFill/>
+          </a:ln>
+        </p:spPr>
+        <p:style>
+          <a:lnRef idx="1">
+            <a:schemeClr val="accent1"/>
+          </a:lnRef>
+          <a:fillRef idx="3">
+            <a:schemeClr val="accent1"/>
+          </a:fillRef>
+          <a:effectRef idx="2">
+            <a:schemeClr val="accent1"/>
+          </a:effectRef>
+          <a:fontRef idx="minor">
+            <a:schemeClr val="lt1"/>
+          </a:fontRef>
+        </p:style>
+        <p:txBody>
+          <a:bodyPr rtlCol="0" anchor="ctr"/>
+          <a:lstStyle/>
+          <a:p>
+            <a:pPr algn="ctr"/>
+            <a:endParaRPr/>
+          </a:p>
+        </p:txBody>
+      </p:sp>
+      <p:sp>
+        <p:nvSpPr>
+          <p:cNvPr id="19" name="TextBox 18"/>
           <p:cNvSpPr txBox="1"/>
           <p:nvPr/>
         </p:nvSpPr>
@@ -8356,14 +8320,14 @@
                 </a:solidFill>
                 <a:latin typeface="Segoe UI"/>
               </a:rPr>
-              <a:t>LEVEL 5 / 7</a:t>
+              <a:t>LEVEL 4 / 7</a:t>
             </a:r>
           </a:p>
         </p:txBody>
       </p:sp>
       <p:pic>
         <p:nvPicPr>
-          <p:cNvPr id="22" name="Picture 21" descr="cris_title_shape59.png"/>
+          <p:cNvPr id="23" name="Picture 22" descr="cris_title_shape59.png"/>
           <p:cNvPicPr>
             <a:picLocks noChangeAspect="1"/>
           </p:cNvPicPr>
@@ -8385,7 +8349,191 @@
           </a:prstGeom>
         </p:spPr>
       </p:pic>
+      <p:pic>
+        <p:nvPicPr>
+          <p:cNvPr id="24" name="Picture 23" descr="image.png"/>
+          <p:cNvPicPr>
+            <a:picLocks noChangeAspect="1"/>
+          </p:cNvPicPr>
+          <p:nvPr/>
+        </p:nvPicPr>
+        <p:blipFill>
+          <a:blip r:embed="rId4"/>
+          <a:stretch>
+            <a:fillRect/>
+          </a:stretch>
+        </p:blipFill>
+        <p:spPr>
+          <a:xfrm>
+            <a:off x="10807293" y="201168"/>
+            <a:ext cx="1051560" cy="1051560"/>
+          </a:xfrm>
+          <a:prstGeom prst="rect">
+            <a:avLst/>
+          </a:prstGeom>
+        </p:spPr>
+      </p:pic>
+      <p:sp>
+        <p:nvSpPr>
+          <p:cNvPr id="25" name="Rounded Rectangle 24"/>
+          <p:cNvSpPr/>
+          <p:nvPr/>
+        </p:nvSpPr>
+        <p:spPr>
+          <a:xfrm>
+            <a:off x="6126480" y="2331720"/>
+            <a:ext cx="5029200" cy="3657600"/>
+          </a:xfrm>
+          <a:prstGeom prst="roundRect">
+            <a:avLst/>
+          </a:prstGeom>
+          <a:solidFill>
+            <a:srgbClr val="F0EFEC"/>
+          </a:solidFill>
+          <a:ln w="9525">
+            <a:solidFill>
+              <a:srgbClr val="E1E0D9"/>
+            </a:solidFill>
+          </a:ln>
+          <a:effectLst/>
+        </p:spPr>
+        <p:style>
+          <a:lnRef idx="1">
+            <a:schemeClr val="accent1"/>
+          </a:lnRef>
+          <a:fillRef idx="3">
+            <a:schemeClr val="accent1"/>
+          </a:fillRef>
+          <a:effectRef idx="2">
+            <a:schemeClr val="accent1"/>
+          </a:effectRef>
+          <a:fontRef idx="minor">
+            <a:schemeClr val="lt1"/>
+          </a:fontRef>
+        </p:style>
+        <p:txBody>
+          <a:bodyPr wrap="square" lIns="182880" tIns="137160" rIns="182880" bIns="137160" rtlCol="0" anchor="t"/>
+          <a:lstStyle/>
+          <a:p>
+            <a:pPr algn="l">
+              <a:lnSpc>
+                <a:spcPct val="110000"/>
+              </a:lnSpc>
+              <a:spcAft>
+                <a:spcPts val="700"/>
+              </a:spcAft>
+            </a:pPr>
+            <a:r>
+              <a:rPr sz="1100" b="1">
+                <a:solidFill>
+                  <a:srgbClr val="0B0B0B"/>
+                </a:solidFill>
+                <a:latin typeface="Consolas"/>
+              </a:rPr>
+              <a:t>/consistency-check [style]</a:t>
+            </a:r>
+            <a:r>
+              <a:rPr sz="1100" b="0">
+                <a:solidFill>
+                  <a:srgbClr val="0B0B0B"/>
+                </a:solidFill>
+                <a:latin typeface="Consolas"/>
+              </a:rPr>
+              <a:t>  Checks formatting and citation-style consistency.</a:t>
+            </a:r>
+          </a:p>
+          <a:p>
+            <a:pPr algn="l">
+              <a:lnSpc>
+                <a:spcPct val="110000"/>
+              </a:lnSpc>
+              <a:spcAft>
+                <a:spcPts val="700"/>
+              </a:spcAft>
+            </a:pPr>
+            <a:r>
+              <a:rPr sz="1100" b="1">
+                <a:solidFill>
+                  <a:srgbClr val="0B0B0B"/>
+                </a:solidFill>
+                <a:latin typeface="Consolas"/>
+              </a:rPr>
+              <a:t>/fwo-admissibility-check</a:t>
+            </a:r>
+            <a:r>
+              <a:rPr sz="1100" b="0">
+                <a:solidFill>
+                  <a:srgbClr val="0B0B0B"/>
+                </a:solidFill>
+                <a:latin typeface="Consolas"/>
+              </a:rPr>
+              <a:t>  FWO's own official eligibility rules for Fundamental Research Projects.</a:t>
+            </a:r>
+          </a:p>
+          <a:p>
+            <a:pPr algn="l">
+              <a:lnSpc>
+                <a:spcPct val="110000"/>
+              </a:lnSpc>
+              <a:spcAft>
+                <a:spcPts val="700"/>
+              </a:spcAft>
+            </a:pPr>
+            <a:r>
+              <a:rPr sz="1100" b="1">
+                <a:solidFill>
+                  <a:srgbClr val="0B0B0B"/>
+                </a:solidFill>
+                <a:latin typeface="Consolas"/>
+              </a:rPr>
+              <a:t>/fwo-reviewer [INTDIS]</a:t>
+            </a:r>
+            <a:r>
+              <a:rPr sz="1100" b="0">
+                <a:solidFill>
+                  <a:srgbClr val="0B0B0B"/>
+                </a:solidFill>
+                <a:latin typeface="Consolas"/>
+              </a:rPr>
+              <a:t>  Simulates an FWO panel review scored against FWO's real scoring grid.</a:t>
+            </a:r>
+          </a:p>
+          <a:p>
+            <a:pPr algn="l">
+              <a:lnSpc>
+                <a:spcPct val="110000"/>
+              </a:lnSpc>
+              <a:spcAft>
+                <a:spcPts val="700"/>
+              </a:spcAft>
+            </a:pPr>
+            <a:r>
+              <a:rPr sz="1100" b="1">
+                <a:solidFill>
+                  <a:srgbClr val="0B0B0B"/>
+                </a:solidFill>
+                <a:latin typeface="Consolas"/>
+              </a:rPr>
+              <a:t>/llm-wiki [ingest|query|lint]</a:t>
+            </a:r>
+            <a:r>
+              <a:rPr sz="1100" b="0">
+                <a:solidFill>
+                  <a:srgbClr val="0B0B0B"/>
+                </a:solidFill>
+                <a:latin typeface="Consolas"/>
+              </a:rPr>
+              <a:t>  Persistent markdown knowledge wiki instead of re-searching raw sources.</a:t>
+            </a:r>
+          </a:p>
+        </p:txBody>
+      </p:sp>
     </p:spTree>
+    <p:extLst>
+      <p:ext uri="{BB962C8B-B14F-4D97-AF65-F5344CB8AC3E}">
+        <p14:creationId xmlns:p14="http://schemas.microsoft.com/office/powerpoint/2010/main" val="1918847219"/>
+      </p:ext>
+    </p:extLst>
   </p:cSld>
   <p:clrMapOvr>
     <a:masterClrMapping/>
@@ -8412,7 +8560,7 @@
       </p:grpSpPr>
       <p:pic>
         <p:nvPicPr>
-          <p:cNvPr id="28" name="Picture 27" descr="border_clean.png"/>
+          <p:cNvPr id="21" name="Picture 20" descr="border_clean.png"/>
           <p:cNvPicPr>
             <a:picLocks noChangeAspect="1"/>
           </p:cNvPicPr>
@@ -8463,7 +8611,7 @@
                 </a:solidFill>
                 <a:latin typeface="Segoe UI Semibold"/>
               </a:rPr>
-              <a:t>LEVEL 6 · LOOPS</a:t>
+              <a:t>LEVEL 5 · MULTIPLE MODELS</a:t>
             </a:r>
           </a:p>
         </p:txBody>
@@ -8477,7 +8625,7 @@
         <p:spPr>
           <a:xfrm>
             <a:off x="640080" y="502920"/>
-            <a:ext cx="10881360" cy="461665"/>
+            <a:ext cx="10881360" cy="822960"/>
           </a:xfrm>
           <a:prstGeom prst="rect">
             <a:avLst/>
@@ -8491,107 +8639,27 @@
           <a:lstStyle/>
           <a:p>
             <a:r>
-              <a:rPr lang="nl-BE" sz="3000" b="1" dirty="0">
+              <a:rPr sz="3000" b="1">
                 <a:solidFill>
                   <a:srgbClr val="0B0B0B"/>
                 </a:solidFill>
                 <a:latin typeface="Segoe UI Semibold"/>
               </a:rPr>
-              <a:t>A</a:t>
-            </a:r>
-            <a:r>
-              <a:rPr sz="3000" b="1" dirty="0">
-                <a:solidFill>
-                  <a:srgbClr val="0B0B0B"/>
-                </a:solidFill>
-                <a:latin typeface="Segoe UI Semibold"/>
-              </a:rPr>
-              <a:t>gent</a:t>
-            </a:r>
-            <a:r>
-              <a:rPr lang="nl-BE" sz="3000" b="1" dirty="0">
-                <a:solidFill>
-                  <a:srgbClr val="0B0B0B"/>
-                </a:solidFill>
-                <a:latin typeface="Segoe UI Semibold"/>
-              </a:rPr>
-              <a:t>(s)</a:t>
-            </a:r>
-            <a:r>
-              <a:rPr sz="3000" b="1" dirty="0">
-                <a:solidFill>
-                  <a:srgbClr val="0B0B0B"/>
-                </a:solidFill>
-                <a:latin typeface="Segoe UI Semibold"/>
-              </a:rPr>
-              <a:t> looping, or several working together</a:t>
-            </a:r>
-          </a:p>
-        </p:txBody>
-      </p:sp>
-      <p:sp>
-        <p:nvSpPr>
-          <p:cNvPr id="4" name="TextBox 3"/>
-          <p:cNvSpPr txBox="1"/>
-          <p:nvPr/>
-        </p:nvSpPr>
-        <p:spPr>
-          <a:xfrm>
-            <a:off x="640080" y="1791558"/>
-            <a:ext cx="4754880" cy="246221"/>
-          </a:xfrm>
-          <a:prstGeom prst="rect">
-            <a:avLst/>
-          </a:prstGeom>
-          <a:noFill/>
-        </p:spPr>
-        <p:txBody>
-          <a:bodyPr wrap="square" lIns="0" tIns="0" rIns="0" bIns="0">
-            <a:spAutoFit/>
-          </a:bodyPr>
-          <a:lstStyle/>
-          <a:p>
-            <a:pPr algn="ctr"/>
-            <a:r>
-              <a:rPr sz="1600" b="1" dirty="0">
-                <a:solidFill>
-                  <a:srgbClr val="0B0B0B"/>
-                </a:solidFill>
-                <a:latin typeface="Segoe UI Semibold"/>
-              </a:rPr>
-              <a:t>One</a:t>
-            </a:r>
-            <a:r>
-              <a:rPr lang="nl-BE" sz="1600" b="1" dirty="0">
-                <a:solidFill>
-                  <a:srgbClr val="0B0B0B"/>
-                </a:solidFill>
-                <a:latin typeface="Segoe UI Semibold"/>
-              </a:rPr>
-              <a:t>/multiple</a:t>
-            </a:r>
-            <a:r>
-              <a:rPr sz="1600" b="1" dirty="0">
-                <a:solidFill>
-                  <a:srgbClr val="0B0B0B"/>
-                </a:solidFill>
-                <a:latin typeface="Segoe UI Semibold"/>
-              </a:rPr>
-              <a:t> agent, self-loop</a:t>
-            </a:r>
-          </a:p>
-        </p:txBody>
-      </p:sp>
-      <p:sp>
-        <p:nvSpPr>
-          <p:cNvPr id="5" name="Rounded Rectangle 4"/>
+              <a:t>One model writes, another reviews</a:t>
+            </a:r>
+          </a:p>
+        </p:txBody>
+      </p:sp>
+      <p:sp>
+        <p:nvSpPr>
+          <p:cNvPr id="4" name="Rounded Rectangle 3"/>
           <p:cNvSpPr/>
           <p:nvPr/>
         </p:nvSpPr>
         <p:spPr>
           <a:xfrm>
-            <a:off x="1645920" y="2541366"/>
-            <a:ext cx="2743200" cy="1188720"/>
+            <a:off x="822960" y="2560320"/>
+            <a:ext cx="3063240" cy="1554480"/>
           </a:xfrm>
           <a:prstGeom prst="roundRect">
             <a:avLst>
@@ -8626,39 +8694,83 @@
           <a:p>
             <a:pPr algn="ctr"/>
             <a:r>
-              <a:rPr sz="1400" b="1">
+              <a:rPr sz="1600" b="1">
                 <a:solidFill>
                   <a:srgbClr val="0B0B0B"/>
                 </a:solidFill>
                 <a:latin typeface="Segoe UI Semibold"/>
               </a:rPr>
-              <a:t>Draft → Review → Revise</a:t>
-            </a:r>
-          </a:p>
-        </p:txBody>
-      </p:sp>
-      <p:sp>
-        <p:nvSpPr>
-          <p:cNvPr id="6" name="Circular Arrow 5"/>
+              <a:t>Model A</a:t>
+            </a:r>
+          </a:p>
+          <a:p>
+            <a:pPr algn="ctr"/>
+            <a:r>
+              <a:rPr sz="1200" b="0" i="1">
+                <a:solidFill>
+                  <a:srgbClr val="0B0B0B"/>
+                </a:solidFill>
+                <a:latin typeface="Segoe UI"/>
+              </a:rPr>
+              <a:t>drafts the proposal
+section</a:t>
+            </a:r>
+          </a:p>
+        </p:txBody>
+      </p:sp>
+      <p:sp>
+        <p:nvSpPr>
+          <p:cNvPr id="5" name="TextBox 4"/>
+          <p:cNvSpPr txBox="1"/>
+          <p:nvPr/>
+        </p:nvSpPr>
+        <p:spPr>
+          <a:xfrm>
+            <a:off x="3886200" y="3154679"/>
+            <a:ext cx="502920" cy="365760"/>
+          </a:xfrm>
+          <a:prstGeom prst="rect">
+            <a:avLst/>
+          </a:prstGeom>
+          <a:noFill/>
+        </p:spPr>
+        <p:txBody>
+          <a:bodyPr wrap="square" lIns="0" tIns="0" rIns="0" bIns="0" anchor="ctr">
+            <a:spAutoFit/>
+          </a:bodyPr>
+          <a:lstStyle/>
+          <a:p>
+            <a:pPr algn="ctr"/>
+            <a:r>
+              <a:rPr sz="1800" b="0">
+                <a:solidFill>
+                  <a:srgbClr val="898781"/>
+                </a:solidFill>
+                <a:latin typeface="Segoe UI"/>
+              </a:rPr>
+              <a:t>→</a:t>
+            </a:r>
+          </a:p>
+        </p:txBody>
+      </p:sp>
+      <p:sp>
+        <p:nvSpPr>
+          <p:cNvPr id="6" name="Rounded Rectangle 5"/>
           <p:cNvSpPr/>
           <p:nvPr/>
         </p:nvSpPr>
         <p:spPr>
-          <a:xfrm rot="5400000">
-            <a:off x="3954780" y="2052163"/>
-            <a:ext cx="868680" cy="868680"/>
-          </a:xfrm>
-          <a:prstGeom prst="circularArrow">
+          <a:xfrm>
+            <a:off x="4389120" y="2560320"/>
+            <a:ext cx="3063240" cy="1554480"/>
+          </a:xfrm>
+          <a:prstGeom prst="roundRect">
             <a:avLst>
-              <a:gd name="adj1" fmla="val 12500"/>
-              <a:gd name="adj2" fmla="val 1142319"/>
-              <a:gd name="adj3" fmla="val 20457681"/>
-              <a:gd name="adj4" fmla="val 5151147"/>
-              <a:gd name="adj5" fmla="val 12500"/>
+              <a:gd name="adj" fmla="val 10000"/>
             </a:avLst>
           </a:prstGeom>
           <a:solidFill>
-            <a:srgbClr val="898781"/>
+            <a:srgbClr val="F9DACC"/>
           </a:solidFill>
           <a:ln>
             <a:noFill/>
@@ -8680,11 +8792,32 @@
           </a:fontRef>
         </p:style>
         <p:txBody>
-          <a:bodyPr rtlCol="0" anchor="ctr"/>
+          <a:bodyPr wrap="square" tIns="54864" bIns="54864" rtlCol="0" anchor="ctr"/>
           <a:lstStyle/>
           <a:p>
             <a:pPr algn="ctr"/>
-            <a:endParaRPr/>
+            <a:r>
+              <a:rPr sz="1600" b="1">
+                <a:solidFill>
+                  <a:srgbClr val="0B0B0B"/>
+                </a:solidFill>
+                <a:latin typeface="Segoe UI Semibold"/>
+              </a:rPr>
+              <a:t>Model B</a:t>
+            </a:r>
+          </a:p>
+          <a:p>
+            <a:pPr algn="ctr"/>
+            <a:r>
+              <a:rPr sz="1200" b="0" i="1">
+                <a:solidFill>
+                  <a:srgbClr val="0B0B0B"/>
+                </a:solidFill>
+                <a:latin typeface="Segoe UI"/>
+              </a:rPr>
+              <a:t>critiques it,
+independently</a:t>
+            </a:r>
           </a:p>
         </p:txBody>
       </p:sp>
@@ -8696,8 +8829,8 @@
         </p:nvSpPr>
         <p:spPr>
           <a:xfrm>
-            <a:off x="640080" y="3912966"/>
-            <a:ext cx="4754880" cy="365760"/>
+            <a:off x="7452360" y="3154679"/>
+            <a:ext cx="502920" cy="365760"/>
           </a:xfrm>
           <a:prstGeom prst="rect">
             <a:avLst/>
@@ -8705,69 +8838,34 @@
           <a:noFill/>
         </p:spPr>
         <p:txBody>
-          <a:bodyPr wrap="square" lIns="0" tIns="0" rIns="0" bIns="0">
+          <a:bodyPr wrap="square" lIns="0" tIns="0" rIns="0" bIns="0" anchor="ctr">
             <a:spAutoFit/>
           </a:bodyPr>
           <a:lstStyle/>
           <a:p>
             <a:pPr algn="ctr"/>
             <a:r>
-              <a:rPr sz="1250" b="0">
+              <a:rPr sz="1800" b="0">
                 <a:solidFill>
                   <a:srgbClr val="898781"/>
                 </a:solidFill>
                 <a:latin typeface="Segoe UI"/>
               </a:rPr>
-              <a:t>repeats until the exit condition is met</a:t>
-            </a:r>
-          </a:p>
-        </p:txBody>
-      </p:sp>
-      <p:sp>
-        <p:nvSpPr>
-          <p:cNvPr id="8" name="TextBox 7"/>
-          <p:cNvSpPr txBox="1"/>
-          <p:nvPr/>
-        </p:nvSpPr>
-        <p:spPr>
-          <a:xfrm>
-            <a:off x="6492240" y="1792225"/>
-            <a:ext cx="4754880" cy="365760"/>
-          </a:xfrm>
-          <a:prstGeom prst="rect">
-            <a:avLst/>
-          </a:prstGeom>
-          <a:noFill/>
-        </p:spPr>
-        <p:txBody>
-          <a:bodyPr wrap="square" lIns="0" tIns="0" rIns="0" bIns="0">
-            <a:spAutoFit/>
-          </a:bodyPr>
-          <a:lstStyle/>
-          <a:p>
-            <a:pPr algn="ctr"/>
-            <a:r>
-              <a:rPr sz="1600" b="1">
-                <a:solidFill>
-                  <a:srgbClr val="0B0B0B"/>
-                </a:solidFill>
-                <a:latin typeface="Segoe UI Semibold"/>
-              </a:rPr>
-              <a:t>Multiple agents, specialised</a:t>
-            </a:r>
-          </a:p>
-        </p:txBody>
-      </p:sp>
-      <p:sp>
-        <p:nvSpPr>
-          <p:cNvPr id="9" name="Rounded Rectangle 8"/>
+              <a:t>→</a:t>
+            </a:r>
+          </a:p>
+        </p:txBody>
+      </p:sp>
+      <p:sp>
+        <p:nvSpPr>
+          <p:cNvPr id="8" name="Rounded Rectangle 7"/>
           <p:cNvSpPr/>
           <p:nvPr/>
         </p:nvSpPr>
         <p:spPr>
           <a:xfrm>
-            <a:off x="7955279" y="2295145"/>
-            <a:ext cx="1828800" cy="685800"/>
+            <a:off x="7955280" y="2560320"/>
+            <a:ext cx="3063240" cy="1554480"/>
           </a:xfrm>
           <a:prstGeom prst="roundRect">
             <a:avLst>
@@ -8802,32 +8900,164 @@
           <a:p>
             <a:pPr algn="ctr"/>
             <a:r>
-              <a:rPr sz="1300" b="1">
+              <a:rPr sz="1600" b="1">
                 <a:solidFill>
                   <a:srgbClr val="FFFFFF"/>
                 </a:solidFill>
                 <a:latin typeface="Segoe UI Semibold"/>
               </a:rPr>
-              <a:t>Orchestrator</a:t>
+              <a:t>Revised draft</a:t>
+            </a:r>
+          </a:p>
+          <a:p>
+            <a:pPr algn="ctr"/>
+            <a:r>
+              <a:rPr sz="1200" b="0" i="1">
+                <a:solidFill>
+                  <a:srgbClr val="FFFFFF"/>
+                </a:solidFill>
+                <a:latin typeface="Segoe UI"/>
+              </a:rPr>
+              <a:t>stronger for having
+survived a second opinion</a:t>
+            </a:r>
+          </a:p>
+        </p:txBody>
+      </p:sp>
+      <p:sp>
+        <p:nvSpPr>
+          <p:cNvPr id="9" name="TextBox 8"/>
+          <p:cNvSpPr txBox="1"/>
+          <p:nvPr/>
+        </p:nvSpPr>
+        <p:spPr>
+          <a:xfrm>
+            <a:off x="731520" y="4617720"/>
+            <a:ext cx="10424160" cy="1097280"/>
+          </a:xfrm>
+          <a:prstGeom prst="rect">
+            <a:avLst/>
+          </a:prstGeom>
+          <a:noFill/>
+        </p:spPr>
+        <p:txBody>
+          <a:bodyPr wrap="square" lIns="0" tIns="0" rIns="0" bIns="0">
+            <a:spAutoFit/>
+          </a:bodyPr>
+          <a:lstStyle/>
+          <a:p>
+            <a:pPr marL="320040" indent="-320040">
+              <a:spcAft>
+                <a:spcPts val="1400"/>
+              </a:spcAft>
+              <a:buFont typeface="Arial"/>
+              <a:buChar char="—  "/>
+            </a:pPr>
+            <a:r>
+              <a:rPr sz="1800" b="1">
+                <a:solidFill>
+                  <a:srgbClr val="0B0B0B"/>
+                </a:solidFill>
+                <a:latin typeface="Segoe UI"/>
+              </a:rPr>
+              <a:t>Different vendors, different blind spots — </a:t>
+            </a:r>
+            <a:r>
+              <a:rPr sz="1800" b="0">
+                <a:solidFill>
+                  <a:srgbClr val="52514E"/>
+                </a:solidFill>
+                <a:latin typeface="Segoe UI"/>
+              </a:rPr>
+              <a:t>a second opinion catches what the first model's own bias would miss.</a:t>
+            </a:r>
+          </a:p>
+        </p:txBody>
+      </p:sp>
+      <p:sp>
+        <p:nvSpPr>
+          <p:cNvPr id="10" name="TextBox 9"/>
+          <p:cNvSpPr txBox="1"/>
+          <p:nvPr/>
+        </p:nvSpPr>
+        <p:spPr>
+          <a:xfrm>
+            <a:off x="457200" y="6473952"/>
+            <a:ext cx="8229600" cy="320040"/>
+          </a:xfrm>
+          <a:prstGeom prst="rect">
+            <a:avLst/>
+          </a:prstGeom>
+          <a:noFill/>
+        </p:spPr>
+        <p:txBody>
+          <a:bodyPr wrap="square" lIns="0" tIns="0" rIns="0" bIns="0">
+            <a:spAutoFit/>
+          </a:bodyPr>
+          <a:lstStyle/>
+          <a:p>
+            <a:r>
+              <a:rPr sz="1000" b="0">
+                <a:solidFill>
+                  <a:srgbClr val="898781"/>
+                </a:solidFill>
+                <a:latin typeface="Segoe UI"/>
+              </a:rPr>
+              <a:t>Levels of Using AI in Research</a:t>
+            </a:r>
+          </a:p>
+        </p:txBody>
+      </p:sp>
+      <p:sp>
+        <p:nvSpPr>
+          <p:cNvPr id="11" name="TextBox 10"/>
+          <p:cNvSpPr txBox="1"/>
+          <p:nvPr/>
+        </p:nvSpPr>
+        <p:spPr>
+          <a:xfrm>
+            <a:off x="11430000" y="6473952"/>
+            <a:ext cx="457200" cy="320040"/>
+          </a:xfrm>
+          <a:prstGeom prst="rect">
+            <a:avLst/>
+          </a:prstGeom>
+          <a:noFill/>
+        </p:spPr>
+        <p:txBody>
+          <a:bodyPr wrap="square" lIns="0" tIns="0" rIns="0" bIns="0">
+            <a:spAutoFit/>
+          </a:bodyPr>
+          <a:lstStyle/>
+          <a:p>
+            <a:pPr algn="r"/>
+            <a:r>
+              <a:rPr sz="1000" b="0">
+                <a:solidFill>
+                  <a:srgbClr val="898781"/>
+                </a:solidFill>
+                <a:latin typeface="Segoe UI"/>
+              </a:rPr>
+              <a:t>14</a:t>
             </a:r>
           </a:p>
         </p:txBody>
       </p:sp>
       <p:cxnSp>
         <p:nvCxnSpPr>
-          <p:cNvPr id="10" name="Connector 9"/>
+          <p:cNvPr id="12" name="Connector 11"/>
           <p:cNvCxnSpPr/>
           <p:nvPr/>
         </p:nvCxnSpPr>
         <p:spPr>
-          <a:xfrm flipH="1">
-            <a:off x="7269479" y="2980945"/>
-            <a:ext cx="1600201" cy="502919"/>
+          <a:xfrm>
+            <a:off x="457200" y="6419088"/>
+            <a:ext cx="11274552" cy="0"/>
           </a:xfrm>
           <a:prstGeom prst="line">
             <a:avLst/>
           </a:prstGeom>
-          <a:ln w="15875">
+          <a:ln w="9525">
             <a:solidFill>
               <a:srgbClr val="E1E0D9"/>
             </a:solidFill>
@@ -8850,450 +9080,7 @@
       </p:cxnSp>
       <p:sp>
         <p:nvSpPr>
-          <p:cNvPr id="11" name="Rounded Rectangle 10"/>
-          <p:cNvSpPr/>
-          <p:nvPr/>
-        </p:nvSpPr>
-        <p:spPr>
-          <a:xfrm>
-            <a:off x="6583679" y="3483864"/>
-            <a:ext cx="1371600" cy="685800"/>
-          </a:xfrm>
-          <a:prstGeom prst="roundRect">
-            <a:avLst>
-              <a:gd name="adj" fmla="val 10000"/>
-            </a:avLst>
-          </a:prstGeom>
-          <a:solidFill>
-            <a:srgbClr val="CDE2FB"/>
-          </a:solidFill>
-          <a:ln>
-            <a:noFill/>
-          </a:ln>
-          <a:effectLst/>
-        </p:spPr>
-        <p:style>
-          <a:lnRef idx="1">
-            <a:schemeClr val="accent1"/>
-          </a:lnRef>
-          <a:fillRef idx="3">
-            <a:schemeClr val="accent1"/>
-          </a:fillRef>
-          <a:effectRef idx="2">
-            <a:schemeClr val="accent1"/>
-          </a:effectRef>
-          <a:fontRef idx="minor">
-            <a:schemeClr val="lt1"/>
-          </a:fontRef>
-        </p:style>
-        <p:txBody>
-          <a:bodyPr wrap="square" tIns="54864" bIns="54864" rtlCol="0" anchor="ctr"/>
-          <a:lstStyle/>
-          <a:p>
-            <a:pPr algn="ctr"/>
-            <a:r>
-              <a:rPr sz="1200" b="1">
-                <a:solidFill>
-                  <a:srgbClr val="0B0B0B"/>
-                </a:solidFill>
-                <a:latin typeface="Segoe UI Semibold"/>
-              </a:rPr>
-              <a:t>Writer</a:t>
-            </a:r>
-          </a:p>
-        </p:txBody>
-      </p:sp>
-      <p:cxnSp>
-        <p:nvCxnSpPr>
-          <p:cNvPr id="12" name="Connector 11"/>
-          <p:cNvCxnSpPr/>
-          <p:nvPr/>
-        </p:nvCxnSpPr>
-        <p:spPr>
-          <a:xfrm>
-            <a:off x="8869680" y="2980945"/>
-            <a:ext cx="0" cy="502919"/>
-          </a:xfrm>
-          <a:prstGeom prst="line">
-            <a:avLst/>
-          </a:prstGeom>
-          <a:ln w="15875">
-            <a:solidFill>
-              <a:srgbClr val="E1E0D9"/>
-            </a:solidFill>
-          </a:ln>
-        </p:spPr>
-        <p:style>
-          <a:lnRef idx="2">
-            <a:schemeClr val="accent1"/>
-          </a:lnRef>
-          <a:fillRef idx="0">
-            <a:schemeClr val="accent1"/>
-          </a:fillRef>
-          <a:effectRef idx="1">
-            <a:schemeClr val="accent1"/>
-          </a:effectRef>
-          <a:fontRef idx="minor">
-            <a:schemeClr val="tx1"/>
-          </a:fontRef>
-        </p:style>
-      </p:cxnSp>
-      <p:sp>
-        <p:nvSpPr>
           <p:cNvPr id="13" name="Rounded Rectangle 12"/>
-          <p:cNvSpPr/>
-          <p:nvPr/>
-        </p:nvSpPr>
-        <p:spPr>
-          <a:xfrm>
-            <a:off x="8183879" y="3483864"/>
-            <a:ext cx="1371600" cy="685800"/>
-          </a:xfrm>
-          <a:prstGeom prst="roundRect">
-            <a:avLst>
-              <a:gd name="adj" fmla="val 10000"/>
-            </a:avLst>
-          </a:prstGeom>
-          <a:solidFill>
-            <a:srgbClr val="CDE2FB"/>
-          </a:solidFill>
-          <a:ln>
-            <a:noFill/>
-          </a:ln>
-          <a:effectLst/>
-        </p:spPr>
-        <p:style>
-          <a:lnRef idx="1">
-            <a:schemeClr val="accent1"/>
-          </a:lnRef>
-          <a:fillRef idx="3">
-            <a:schemeClr val="accent1"/>
-          </a:fillRef>
-          <a:effectRef idx="2">
-            <a:schemeClr val="accent1"/>
-          </a:effectRef>
-          <a:fontRef idx="minor">
-            <a:schemeClr val="lt1"/>
-          </a:fontRef>
-        </p:style>
-        <p:txBody>
-          <a:bodyPr wrap="square" tIns="54864" bIns="54864" rtlCol="0" anchor="ctr"/>
-          <a:lstStyle/>
-          <a:p>
-            <a:pPr algn="ctr"/>
-            <a:r>
-              <a:rPr sz="1200" b="1">
-                <a:solidFill>
-                  <a:srgbClr val="0B0B0B"/>
-                </a:solidFill>
-                <a:latin typeface="Segoe UI Semibold"/>
-              </a:rPr>
-              <a:t>Reviewer</a:t>
-            </a:r>
-          </a:p>
-        </p:txBody>
-      </p:sp>
-      <p:cxnSp>
-        <p:nvCxnSpPr>
-          <p:cNvPr id="14" name="Connector 13"/>
-          <p:cNvCxnSpPr/>
-          <p:nvPr/>
-        </p:nvCxnSpPr>
-        <p:spPr>
-          <a:xfrm>
-            <a:off x="8869680" y="2980945"/>
-            <a:ext cx="1600200" cy="502919"/>
-          </a:xfrm>
-          <a:prstGeom prst="line">
-            <a:avLst/>
-          </a:prstGeom>
-          <a:ln w="15875">
-            <a:solidFill>
-              <a:srgbClr val="E1E0D9"/>
-            </a:solidFill>
-          </a:ln>
-        </p:spPr>
-        <p:style>
-          <a:lnRef idx="2">
-            <a:schemeClr val="accent1"/>
-          </a:lnRef>
-          <a:fillRef idx="0">
-            <a:schemeClr val="accent1"/>
-          </a:fillRef>
-          <a:effectRef idx="1">
-            <a:schemeClr val="accent1"/>
-          </a:effectRef>
-          <a:fontRef idx="minor">
-            <a:schemeClr val="tx1"/>
-          </a:fontRef>
-        </p:style>
-      </p:cxnSp>
-      <p:sp>
-        <p:nvSpPr>
-          <p:cNvPr id="15" name="Rounded Rectangle 14"/>
-          <p:cNvSpPr/>
-          <p:nvPr/>
-        </p:nvSpPr>
-        <p:spPr>
-          <a:xfrm>
-            <a:off x="9784080" y="3483864"/>
-            <a:ext cx="1371600" cy="685800"/>
-          </a:xfrm>
-          <a:prstGeom prst="roundRect">
-            <a:avLst>
-              <a:gd name="adj" fmla="val 10000"/>
-            </a:avLst>
-          </a:prstGeom>
-          <a:solidFill>
-            <a:srgbClr val="CDE2FB"/>
-          </a:solidFill>
-          <a:ln>
-            <a:noFill/>
-          </a:ln>
-          <a:effectLst/>
-        </p:spPr>
-        <p:style>
-          <a:lnRef idx="1">
-            <a:schemeClr val="accent1"/>
-          </a:lnRef>
-          <a:fillRef idx="3">
-            <a:schemeClr val="accent1"/>
-          </a:fillRef>
-          <a:effectRef idx="2">
-            <a:schemeClr val="accent1"/>
-          </a:effectRef>
-          <a:fontRef idx="minor">
-            <a:schemeClr val="lt1"/>
-          </a:fontRef>
-        </p:style>
-        <p:txBody>
-          <a:bodyPr wrap="square" tIns="54864" bIns="54864" rtlCol="0" anchor="ctr"/>
-          <a:lstStyle/>
-          <a:p>
-            <a:pPr algn="ctr"/>
-            <a:r>
-              <a:rPr sz="1200" b="1">
-                <a:solidFill>
-                  <a:srgbClr val="0B0B0B"/>
-                </a:solidFill>
-                <a:latin typeface="Segoe UI Semibold"/>
-              </a:rPr>
-              <a:t>Fact-checker</a:t>
-            </a:r>
-          </a:p>
-        </p:txBody>
-      </p:sp>
-      <p:sp>
-        <p:nvSpPr>
-          <p:cNvPr id="16" name="TextBox 15"/>
-          <p:cNvSpPr txBox="1"/>
-          <p:nvPr/>
-        </p:nvSpPr>
-        <p:spPr>
-          <a:xfrm>
-            <a:off x="731520" y="4750000"/>
-            <a:ext cx="10424160" cy="1550000"/>
-          </a:xfrm>
-          <a:prstGeom prst="rect">
-            <a:avLst/>
-          </a:prstGeom>
-          <a:noFill/>
-        </p:spPr>
-        <p:txBody>
-          <a:bodyPr wrap="square" lIns="0" tIns="0" rIns="0" bIns="0">
-            <a:spAutoFit/>
-          </a:bodyPr>
-          <a:lstStyle/>
-          <a:p>
-            <a:pPr marL="320040" indent="-320040">
-              <a:spcAft>
-                <a:spcPts val="600"/>
-              </a:spcAft>
-              <a:buFont typeface="Arial"/>
-              <a:buChar char="—  "/>
-            </a:pPr>
-            <a:r>
-              <a:rPr sz="1500" b="1">
-                <a:solidFill>
-                  <a:srgbClr val="0B0B0B"/>
-                </a:solidFill>
-                <a:latin typeface="Segoe UI"/>
-              </a:rPr>
-              <a:t>Multiple, not just one: </a:t>
-            </a:r>
-            <a:r>
-              <a:rPr sz="1500" b="0">
-                <a:solidFill>
-                  <a:srgbClr val="52514E"/>
-                </a:solidFill>
-                <a:latin typeface="Segoe UI"/>
-              </a:rPr>
-              <a:t>brief several reviewer agents with different expertise (methodology, ethics, funder priorities) and let them debate the same draft in the loop.</a:t>
-            </a:r>
-          </a:p>
-          <a:p>
-            <a:pPr marL="320040" indent="-320040">
-              <a:spcAft>
-                <a:spcPts val="600"/>
-              </a:spcAft>
-              <a:buFont typeface="Arial"/>
-              <a:buChar char="—  "/>
-            </a:pPr>
-            <a:r>
-              <a:rPr sz="1500" b="1">
-                <a:solidFill>
-                  <a:srgbClr val="0B0B0B"/>
-                </a:solidFill>
-                <a:latin typeface="Segoe UI"/>
-              </a:rPr>
-              <a:t>Fully unattended: </a:t>
-            </a:r>
-            <a:r>
-              <a:rPr sz="1500" b="0">
-                <a:solidFill>
-                  <a:srgbClr val="52514E"/>
-                </a:solidFill>
-                <a:latin typeface="Segoe UI"/>
-              </a:rPr>
-              <a:t>a scheduled job (e.g. a cron job) can run the whole loop with no human until it's done.</a:t>
-            </a:r>
-          </a:p>
-          <a:p>
-            <a:pPr marL="320040" indent="-320040">
-              <a:spcAft>
-                <a:spcPts val="600"/>
-              </a:spcAft>
-              <a:buFont typeface="Arial"/>
-              <a:buChar char="—  "/>
-            </a:pPr>
-            <a:r>
-              <a:rPr sz="1500" b="1">
-                <a:solidFill>
-                  <a:srgbClr val="0B0B0B"/>
-                </a:solidFill>
-                <a:latin typeface="Segoe UI"/>
-              </a:rPr>
-              <a:t>Either way, a human sets the exit condition — </a:t>
-            </a:r>
-            <a:r>
-              <a:rPr sz="1500" b="0">
-                <a:solidFill>
-                  <a:srgbClr val="52514E"/>
-                </a:solidFill>
-                <a:latin typeface="Segoe UI"/>
-              </a:rPr>
-              <a:t>automation compounds small errors just as fast as small improvements.</a:t>
-            </a:r>
-          </a:p>
-        </p:txBody>
-      </p:sp>
-      <p:sp>
-        <p:nvSpPr>
-          <p:cNvPr id="17" name="TextBox 16"/>
-          <p:cNvSpPr txBox="1"/>
-          <p:nvPr/>
-        </p:nvSpPr>
-        <p:spPr>
-          <a:xfrm>
-            <a:off x="457200" y="6473952"/>
-            <a:ext cx="8229600" cy="320040"/>
-          </a:xfrm>
-          <a:prstGeom prst="rect">
-            <a:avLst/>
-          </a:prstGeom>
-          <a:noFill/>
-        </p:spPr>
-        <p:txBody>
-          <a:bodyPr wrap="square" lIns="0" tIns="0" rIns="0" bIns="0">
-            <a:spAutoFit/>
-          </a:bodyPr>
-          <a:lstStyle/>
-          <a:p>
-            <a:r>
-              <a:rPr sz="1000" b="0">
-                <a:solidFill>
-                  <a:srgbClr val="898781"/>
-                </a:solidFill>
-                <a:latin typeface="Segoe UI"/>
-              </a:rPr>
-              <a:t>Levels of Using AI in Research</a:t>
-            </a:r>
-          </a:p>
-        </p:txBody>
-      </p:sp>
-      <p:sp>
-        <p:nvSpPr>
-          <p:cNvPr id="18" name="TextBox 17"/>
-          <p:cNvSpPr txBox="1"/>
-          <p:nvPr/>
-        </p:nvSpPr>
-        <p:spPr>
-          <a:xfrm>
-            <a:off x="11430000" y="6473952"/>
-            <a:ext cx="457200" cy="320040"/>
-          </a:xfrm>
-          <a:prstGeom prst="rect">
-            <a:avLst/>
-          </a:prstGeom>
-          <a:noFill/>
-        </p:spPr>
-        <p:txBody>
-          <a:bodyPr wrap="square" lIns="0" tIns="0" rIns="0" bIns="0">
-            <a:spAutoFit/>
-          </a:bodyPr>
-          <a:lstStyle/>
-          <a:p>
-            <a:pPr algn="r"/>
-            <a:r>
-              <a:rPr sz="1000" b="0">
-                <a:solidFill>
-                  <a:srgbClr val="898781"/>
-                </a:solidFill>
-                <a:latin typeface="Segoe UI"/>
-              </a:rPr>
-              <a:t>14</a:t>
-            </a:r>
-          </a:p>
-        </p:txBody>
-      </p:sp>
-      <p:cxnSp>
-        <p:nvCxnSpPr>
-          <p:cNvPr id="19" name="Connector 18"/>
-          <p:cNvCxnSpPr/>
-          <p:nvPr/>
-        </p:nvCxnSpPr>
-        <p:spPr>
-          <a:xfrm>
-            <a:off x="457200" y="6419088"/>
-            <a:ext cx="11274552" cy="0"/>
-          </a:xfrm>
-          <a:prstGeom prst="line">
-            <a:avLst/>
-          </a:prstGeom>
-          <a:ln w="9525">
-            <a:solidFill>
-              <a:srgbClr val="E1E0D9"/>
-            </a:solidFill>
-          </a:ln>
-        </p:spPr>
-        <p:style>
-          <a:lnRef idx="2">
-            <a:schemeClr val="accent1"/>
-          </a:lnRef>
-          <a:fillRef idx="0">
-            <a:schemeClr val="accent1"/>
-          </a:fillRef>
-          <a:effectRef idx="1">
-            <a:schemeClr val="accent1"/>
-          </a:effectRef>
-          <a:fontRef idx="minor">
-            <a:schemeClr val="tx1"/>
-          </a:fontRef>
-        </p:style>
-      </p:cxnSp>
-      <p:sp>
-        <p:nvSpPr>
-          <p:cNvPr id="20" name="Rounded Rectangle 19"/>
           <p:cNvSpPr/>
           <p:nvPr/>
         </p:nvSpPr>
@@ -9339,7 +9126,7 @@
       </p:sp>
       <p:sp>
         <p:nvSpPr>
-          <p:cNvPr id="21" name="Rounded Rectangle 20"/>
+          <p:cNvPr id="14" name="Rounded Rectangle 13"/>
           <p:cNvSpPr/>
           <p:nvPr/>
         </p:nvSpPr>
@@ -9385,7 +9172,7 @@
       </p:sp>
       <p:sp>
         <p:nvSpPr>
-          <p:cNvPr id="22" name="Rounded Rectangle 21"/>
+          <p:cNvPr id="15" name="Rounded Rectangle 14"/>
           <p:cNvSpPr/>
           <p:nvPr/>
         </p:nvSpPr>
@@ -9431,7 +9218,7 @@
       </p:sp>
       <p:sp>
         <p:nvSpPr>
-          <p:cNvPr id="23" name="Rounded Rectangle 22"/>
+          <p:cNvPr id="16" name="Rounded Rectangle 15"/>
           <p:cNvSpPr/>
           <p:nvPr/>
         </p:nvSpPr>
@@ -9477,7 +9264,7 @@
       </p:sp>
       <p:sp>
         <p:nvSpPr>
-          <p:cNvPr id="24" name="Rounded Rectangle 23"/>
+          <p:cNvPr id="17" name="Rounded Rectangle 16"/>
           <p:cNvSpPr/>
           <p:nvPr/>
         </p:nvSpPr>
@@ -9523,59 +9310,13 @@
       </p:sp>
       <p:sp>
         <p:nvSpPr>
-          <p:cNvPr id="25" name="Rounded Rectangle 24"/>
+          <p:cNvPr id="18" name="Rounded Rectangle 17"/>
           <p:cNvSpPr/>
           <p:nvPr/>
         </p:nvSpPr>
         <p:spPr>
           <a:xfrm>
             <a:off x="11073384" y="6583680"/>
-            <a:ext cx="201168" cy="91440"/>
-          </a:xfrm>
-          <a:prstGeom prst="roundRect">
-            <a:avLst>
-              <a:gd name="adj" fmla="val 50000"/>
-            </a:avLst>
-          </a:prstGeom>
-          <a:solidFill>
-            <a:srgbClr val="2A78D6"/>
-          </a:solidFill>
-          <a:ln>
-            <a:noFill/>
-          </a:ln>
-        </p:spPr>
-        <p:style>
-          <a:lnRef idx="1">
-            <a:schemeClr val="accent1"/>
-          </a:lnRef>
-          <a:fillRef idx="3">
-            <a:schemeClr val="accent1"/>
-          </a:fillRef>
-          <a:effectRef idx="2">
-            <a:schemeClr val="accent1"/>
-          </a:effectRef>
-          <a:fontRef idx="minor">
-            <a:schemeClr val="lt1"/>
-          </a:fontRef>
-        </p:style>
-        <p:txBody>
-          <a:bodyPr rtlCol="0" anchor="ctr"/>
-          <a:lstStyle/>
-          <a:p>
-            <a:pPr algn="ctr"/>
-            <a:endParaRPr/>
-          </a:p>
-        </p:txBody>
-      </p:sp>
-      <p:sp>
-        <p:nvSpPr>
-          <p:cNvPr id="26" name="Rounded Rectangle 25"/>
-          <p:cNvSpPr/>
-          <p:nvPr/>
-        </p:nvSpPr>
-        <p:spPr>
-          <a:xfrm>
-            <a:off x="11320272" y="6583680"/>
             <a:ext cx="201168" cy="91440"/>
           </a:xfrm>
           <a:prstGeom prst="roundRect">
@@ -9615,7 +9356,53 @@
       </p:sp>
       <p:sp>
         <p:nvSpPr>
-          <p:cNvPr id="27" name="TextBox 26"/>
+          <p:cNvPr id="19" name="Rounded Rectangle 18"/>
+          <p:cNvSpPr/>
+          <p:nvPr/>
+        </p:nvSpPr>
+        <p:spPr>
+          <a:xfrm>
+            <a:off x="11320272" y="6583680"/>
+            <a:ext cx="201168" cy="91440"/>
+          </a:xfrm>
+          <a:prstGeom prst="roundRect">
+            <a:avLst>
+              <a:gd name="adj" fmla="val 50000"/>
+            </a:avLst>
+          </a:prstGeom>
+          <a:solidFill>
+            <a:srgbClr val="E1E0D9"/>
+          </a:solidFill>
+          <a:ln>
+            <a:noFill/>
+          </a:ln>
+        </p:spPr>
+        <p:style>
+          <a:lnRef idx="1">
+            <a:schemeClr val="accent1"/>
+          </a:lnRef>
+          <a:fillRef idx="3">
+            <a:schemeClr val="accent1"/>
+          </a:fillRef>
+          <a:effectRef idx="2">
+            <a:schemeClr val="accent1"/>
+          </a:effectRef>
+          <a:fontRef idx="minor">
+            <a:schemeClr val="lt1"/>
+          </a:fontRef>
+        </p:style>
+        <p:txBody>
+          <a:bodyPr rtlCol="0" anchor="ctr"/>
+          <a:lstStyle/>
+          <a:p>
+            <a:pPr algn="ctr"/>
+            <a:endParaRPr/>
+          </a:p>
+        </p:txBody>
+      </p:sp>
+      <p:sp>
+        <p:nvSpPr>
+          <p:cNvPr id="20" name="TextBox 19"/>
           <p:cNvSpPr txBox="1"/>
           <p:nvPr/>
         </p:nvSpPr>
@@ -9643,14 +9430,14 @@
                 </a:solidFill>
                 <a:latin typeface="Segoe UI"/>
               </a:rPr>
-              <a:t>LEVEL 6 / 7</a:t>
+              <a:t>LEVEL 5 / 7</a:t>
             </a:r>
           </a:p>
         </p:txBody>
       </p:sp>
       <p:pic>
         <p:nvPicPr>
-          <p:cNvPr id="29" name="Picture 28" descr="cris_title_shape59.png"/>
+          <p:cNvPr id="22" name="Picture 21" descr="cris_title_shape59.png"/>
           <p:cNvPicPr>
             <a:picLocks noChangeAspect="1"/>
           </p:cNvPicPr>
@@ -9699,7 +9486,7 @@
       </p:grpSpPr>
       <p:pic>
         <p:nvPicPr>
-          <p:cNvPr id="19" name="Picture 18" descr="border_clean.png"/>
+          <p:cNvPr id="28" name="Picture 27" descr="border_clean.png"/>
           <p:cNvPicPr>
             <a:picLocks noChangeAspect="1"/>
           </p:cNvPicPr>
@@ -9750,7 +9537,7 @@
                 </a:solidFill>
                 <a:latin typeface="Segoe UI Semibold"/>
               </a:rPr>
-              <a:t>LEVEL 7 · FULL CONTROL</a:t>
+              <a:t>LEVEL 6 · LOOPS</a:t>
             </a:r>
           </a:p>
         </p:txBody>
@@ -9764,7 +9551,7 @@
         <p:spPr>
           <a:xfrm>
             <a:off x="640080" y="502920"/>
-            <a:ext cx="10881360" cy="822960"/>
+            <a:ext cx="10881360" cy="461665"/>
           </a:xfrm>
           <a:prstGeom prst="rect">
             <a:avLst/>
@@ -9778,27 +9565,107 @@
           <a:lstStyle/>
           <a:p>
             <a:r>
-              <a:rPr sz="3000" b="1">
+              <a:rPr lang="nl-BE" sz="3000" b="1" dirty="0">
                 <a:solidFill>
                   <a:srgbClr val="0B0B0B"/>
                 </a:solidFill>
                 <a:latin typeface="Segoe UI Semibold"/>
               </a:rPr>
-              <a:t>Some models you can run yourself</a:t>
-            </a:r>
-          </a:p>
-        </p:txBody>
-      </p:sp>
-      <p:sp>
-        <p:nvSpPr>
-          <p:cNvPr id="4" name="Rounded Rectangle 3"/>
+              <a:t>A</a:t>
+            </a:r>
+            <a:r>
+              <a:rPr sz="3000" b="1" dirty="0">
+                <a:solidFill>
+                  <a:srgbClr val="0B0B0B"/>
+                </a:solidFill>
+                <a:latin typeface="Segoe UI Semibold"/>
+              </a:rPr>
+              <a:t>gent</a:t>
+            </a:r>
+            <a:r>
+              <a:rPr lang="nl-BE" sz="3000" b="1" dirty="0">
+                <a:solidFill>
+                  <a:srgbClr val="0B0B0B"/>
+                </a:solidFill>
+                <a:latin typeface="Segoe UI Semibold"/>
+              </a:rPr>
+              <a:t>(s)</a:t>
+            </a:r>
+            <a:r>
+              <a:rPr sz="3000" b="1" dirty="0">
+                <a:solidFill>
+                  <a:srgbClr val="0B0B0B"/>
+                </a:solidFill>
+                <a:latin typeface="Segoe UI Semibold"/>
+              </a:rPr>
+              <a:t> looping, or several working together</a:t>
+            </a:r>
+          </a:p>
+        </p:txBody>
+      </p:sp>
+      <p:sp>
+        <p:nvSpPr>
+          <p:cNvPr id="4" name="TextBox 3"/>
+          <p:cNvSpPr txBox="1"/>
+          <p:nvPr/>
+        </p:nvSpPr>
+        <p:spPr>
+          <a:xfrm>
+            <a:off x="640080" y="1791558"/>
+            <a:ext cx="4754880" cy="246221"/>
+          </a:xfrm>
+          <a:prstGeom prst="rect">
+            <a:avLst/>
+          </a:prstGeom>
+          <a:noFill/>
+        </p:spPr>
+        <p:txBody>
+          <a:bodyPr wrap="square" lIns="0" tIns="0" rIns="0" bIns="0">
+            <a:spAutoFit/>
+          </a:bodyPr>
+          <a:lstStyle/>
+          <a:p>
+            <a:pPr algn="ctr"/>
+            <a:r>
+              <a:rPr sz="1600" b="1" dirty="0">
+                <a:solidFill>
+                  <a:srgbClr val="0B0B0B"/>
+                </a:solidFill>
+                <a:latin typeface="Segoe UI Semibold"/>
+              </a:rPr>
+              <a:t>One</a:t>
+            </a:r>
+            <a:r>
+              <a:rPr lang="nl-BE" sz="1600" b="1" dirty="0">
+                <a:solidFill>
+                  <a:srgbClr val="0B0B0B"/>
+                </a:solidFill>
+                <a:latin typeface="Segoe UI Semibold"/>
+              </a:rPr>
+              <a:t>/multiple</a:t>
+            </a:r>
+            <a:r>
+              <a:rPr sz="1600" b="1" dirty="0">
+                <a:solidFill>
+                  <a:srgbClr val="0B0B0B"/>
+                </a:solidFill>
+                <a:latin typeface="Segoe UI Semibold"/>
+              </a:rPr>
+              <a:t> agent, self-loop</a:t>
+            </a:r>
+          </a:p>
+        </p:txBody>
+      </p:sp>
+      <p:sp>
+        <p:nvSpPr>
+          <p:cNvPr id="5" name="Rounded Rectangle 4"/>
           <p:cNvSpPr/>
           <p:nvPr/>
         </p:nvSpPr>
         <p:spPr>
           <a:xfrm>
-            <a:off x="822960" y="2377440"/>
-            <a:ext cx="4937760" cy="2011680"/>
+            <a:off x="1645920" y="2541366"/>
+            <a:ext cx="2743200" cy="1188720"/>
           </a:xfrm>
           <a:prstGeom prst="roundRect">
             <a:avLst>
@@ -9833,48 +9700,39 @@
           <a:p>
             <a:pPr algn="ctr"/>
             <a:r>
-              <a:rPr sz="1600" b="1">
+              <a:rPr sz="1400" b="1">
                 <a:solidFill>
                   <a:srgbClr val="0B0B0B"/>
                 </a:solidFill>
                 <a:latin typeface="Segoe UI Semibold"/>
               </a:rPr>
-              <a:t>Cloud (frontier models)</a:t>
-            </a:r>
-          </a:p>
-          <a:p>
-            <a:pPr algn="ctr"/>
-            <a:r>
-              <a:rPr sz="1250" b="0">
-                <a:solidFill>
-                  <a:srgbClr val="52514E"/>
-                </a:solidFill>
-                <a:latin typeface="Segoe UI"/>
-              </a:rPr>
-              <a:t>Best all-round quality, zero setup.
-Your data leaves your machine.</a:t>
-            </a:r>
-          </a:p>
-        </p:txBody>
-      </p:sp>
-      <p:sp>
-        <p:nvSpPr>
-          <p:cNvPr id="5" name="Rounded Rectangle 4"/>
+              <a:t>Draft → Review → Revise</a:t>
+            </a:r>
+          </a:p>
+        </p:txBody>
+      </p:sp>
+      <p:sp>
+        <p:nvSpPr>
+          <p:cNvPr id="6" name="Circular Arrow 5"/>
           <p:cNvSpPr/>
           <p:nvPr/>
         </p:nvSpPr>
         <p:spPr>
-          <a:xfrm>
-            <a:off x="6309360" y="2377440"/>
-            <a:ext cx="4937760" cy="2011680"/>
-          </a:xfrm>
-          <a:prstGeom prst="roundRect">
+          <a:xfrm rot="5400000">
+            <a:off x="3954780" y="2052163"/>
+            <a:ext cx="868680" cy="868680"/>
+          </a:xfrm>
+          <a:prstGeom prst="circularArrow">
             <a:avLst>
-              <a:gd name="adj" fmla="val 10000"/>
+              <a:gd name="adj1" fmla="val 12500"/>
+              <a:gd name="adj2" fmla="val 1142319"/>
+              <a:gd name="adj3" fmla="val 20457681"/>
+              <a:gd name="adj4" fmla="val 5151147"/>
+              <a:gd name="adj5" fmla="val 12500"/>
             </a:avLst>
           </a:prstGeom>
           <a:solidFill>
-            <a:srgbClr val="F9DACC"/>
+            <a:srgbClr val="898781"/>
           </a:solidFill>
           <a:ln>
             <a:noFill/>
@@ -9896,82 +9754,24 @@
           </a:fontRef>
         </p:style>
         <p:txBody>
-          <a:bodyPr wrap="square" tIns="54864" bIns="54864" rtlCol="0" anchor="ctr"/>
+          <a:bodyPr rtlCol="0" anchor="ctr"/>
           <a:lstStyle/>
           <a:p>
             <a:pPr algn="ctr"/>
-            <a:r>
-              <a:rPr sz="1600" b="1">
-                <a:solidFill>
-                  <a:srgbClr val="0B0B0B"/>
-                </a:solidFill>
-                <a:latin typeface="Segoe UI Semibold"/>
-              </a:rPr>
-              <a:t>Local (open-source models)</a:t>
-            </a:r>
-          </a:p>
-          <a:p>
-            <a:pPr algn="ctr"/>
-            <a:r>
-              <a:rPr sz="1200" b="0">
-                <a:solidFill>
-                  <a:srgbClr val="52514E"/>
-                </a:solidFill>
-                <a:latin typeface="Segoe UI"/>
-              </a:rPr>
-              <a:t>Runs on a capable personal workstation —
-data never leaves it. Improving fast, and
-some specialised models now rival the
-frontier on focused tasks.</a:t>
-            </a:r>
-          </a:p>
-        </p:txBody>
-      </p:sp>
-      <p:sp>
-        <p:nvSpPr>
-          <p:cNvPr id="6" name="TextBox 5"/>
+            <a:endParaRPr/>
+          </a:p>
+        </p:txBody>
+      </p:sp>
+      <p:sp>
+        <p:nvSpPr>
+          <p:cNvPr id="7" name="TextBox 6"/>
           <p:cNvSpPr txBox="1"/>
           <p:nvPr/>
         </p:nvSpPr>
         <p:spPr>
           <a:xfrm>
-            <a:off x="5760720" y="3154680"/>
-            <a:ext cx="548640" cy="457200"/>
-          </a:xfrm>
-          <a:prstGeom prst="rect">
-            <a:avLst/>
-          </a:prstGeom>
-          <a:noFill/>
-        </p:spPr>
-        <p:txBody>
-          <a:bodyPr wrap="square" lIns="0" tIns="0" rIns="0" bIns="0" anchor="ctr">
-            <a:spAutoFit/>
-          </a:bodyPr>
-          <a:lstStyle/>
-          <a:p>
-            <a:pPr algn="ctr"/>
-            <a:r>
-              <a:rPr sz="1600" b="1">
-                <a:solidFill>
-                  <a:srgbClr val="898781"/>
-                </a:solidFill>
-                <a:latin typeface="Segoe UI Semibold"/>
-              </a:rPr>
-              <a:t>vs</a:t>
-            </a:r>
-          </a:p>
-        </p:txBody>
-      </p:sp>
-      <p:sp>
-        <p:nvSpPr>
-          <p:cNvPr id="8" name="TextBox 7"/>
-          <p:cNvSpPr txBox="1"/>
-          <p:nvPr/>
-        </p:nvSpPr>
-        <p:spPr>
-          <a:xfrm>
-            <a:off x="457200" y="6473952"/>
-            <a:ext cx="8229600" cy="320040"/>
+            <a:off x="640080" y="3912966"/>
+            <a:ext cx="4754880" cy="365760"/>
           </a:xfrm>
           <a:prstGeom prst="rect">
             <a:avLst/>
@@ -9984,28 +9784,29 @@
           </a:bodyPr>
           <a:lstStyle/>
           <a:p>
-            <a:r>
-              <a:rPr sz="1000" b="0">
+            <a:pPr algn="ctr"/>
+            <a:r>
+              <a:rPr sz="1250" b="0">
                 <a:solidFill>
                   <a:srgbClr val="898781"/>
                 </a:solidFill>
                 <a:latin typeface="Segoe UI"/>
               </a:rPr>
-              <a:t>Levels of Using AI in Research</a:t>
-            </a:r>
-          </a:p>
-        </p:txBody>
-      </p:sp>
-      <p:sp>
-        <p:nvSpPr>
-          <p:cNvPr id="9" name="TextBox 8"/>
+              <a:t>repeats until the exit condition is met</a:t>
+            </a:r>
+          </a:p>
+        </p:txBody>
+      </p:sp>
+      <p:sp>
+        <p:nvSpPr>
+          <p:cNvPr id="8" name="TextBox 7"/>
           <p:cNvSpPr txBox="1"/>
           <p:nvPr/>
         </p:nvSpPr>
         <p:spPr>
           <a:xfrm>
-            <a:off x="11430000" y="6473952"/>
-            <a:ext cx="457200" cy="320040"/>
+            <a:off x="6492240" y="1792225"/>
+            <a:ext cx="4754880" cy="365760"/>
           </a:xfrm>
           <a:prstGeom prst="rect">
             <a:avLst/>
@@ -10018,15 +9819,70 @@
           </a:bodyPr>
           <a:lstStyle/>
           <a:p>
-            <a:pPr algn="r"/>
-            <a:r>
-              <a:rPr sz="1000" b="0">
-                <a:solidFill>
-                  <a:srgbClr val="898781"/>
-                </a:solidFill>
-                <a:latin typeface="Segoe UI"/>
-              </a:rPr>
-              <a:t>15</a:t>
+            <a:pPr algn="ctr"/>
+            <a:r>
+              <a:rPr sz="1600" b="1">
+                <a:solidFill>
+                  <a:srgbClr val="0B0B0B"/>
+                </a:solidFill>
+                <a:latin typeface="Segoe UI Semibold"/>
+              </a:rPr>
+              <a:t>Multiple agents, specialised</a:t>
+            </a:r>
+          </a:p>
+        </p:txBody>
+      </p:sp>
+      <p:sp>
+        <p:nvSpPr>
+          <p:cNvPr id="9" name="Rounded Rectangle 8"/>
+          <p:cNvSpPr/>
+          <p:nvPr/>
+        </p:nvSpPr>
+        <p:spPr>
+          <a:xfrm>
+            <a:off x="7955279" y="2295145"/>
+            <a:ext cx="1828800" cy="685800"/>
+          </a:xfrm>
+          <a:prstGeom prst="roundRect">
+            <a:avLst>
+              <a:gd name="adj" fmla="val 10000"/>
+            </a:avLst>
+          </a:prstGeom>
+          <a:solidFill>
+            <a:srgbClr val="EB6834"/>
+          </a:solidFill>
+          <a:ln>
+            <a:noFill/>
+          </a:ln>
+          <a:effectLst/>
+        </p:spPr>
+        <p:style>
+          <a:lnRef idx="1">
+            <a:schemeClr val="accent1"/>
+          </a:lnRef>
+          <a:fillRef idx="3">
+            <a:schemeClr val="accent1"/>
+          </a:fillRef>
+          <a:effectRef idx="2">
+            <a:schemeClr val="accent1"/>
+          </a:effectRef>
+          <a:fontRef idx="minor">
+            <a:schemeClr val="lt1"/>
+          </a:fontRef>
+        </p:style>
+        <p:txBody>
+          <a:bodyPr wrap="square" tIns="54864" bIns="54864" rtlCol="0" anchor="ctr"/>
+          <a:lstStyle/>
+          <a:p>
+            <a:pPr algn="ctr"/>
+            <a:r>
+              <a:rPr sz="1300" b="1">
+                <a:solidFill>
+                  <a:srgbClr val="FFFFFF"/>
+                </a:solidFill>
+                <a:latin typeface="Segoe UI Semibold"/>
+              </a:rPr>
+              <a:t>Orchestrator</a:t>
             </a:r>
           </a:p>
         </p:txBody>
@@ -10038,14 +9894,14 @@
           <p:nvPr/>
         </p:nvCxnSpPr>
         <p:spPr>
-          <a:xfrm>
-            <a:off x="457200" y="6419088"/>
-            <a:ext cx="11274552" cy="0"/>
+          <a:xfrm flipH="1">
+            <a:off x="7269479" y="2980945"/>
+            <a:ext cx="1600201" cy="502919"/>
           </a:xfrm>
           <a:prstGeom prst="line">
             <a:avLst/>
           </a:prstGeom>
-          <a:ln w="9525">
+          <a:ln w="15875">
             <a:solidFill>
               <a:srgbClr val="E1E0D9"/>
             </a:solidFill>
@@ -10074,6 +9930,449 @@
         </p:nvSpPr>
         <p:spPr>
           <a:xfrm>
+            <a:off x="6583679" y="3483864"/>
+            <a:ext cx="1371600" cy="685800"/>
+          </a:xfrm>
+          <a:prstGeom prst="roundRect">
+            <a:avLst>
+              <a:gd name="adj" fmla="val 10000"/>
+            </a:avLst>
+          </a:prstGeom>
+          <a:solidFill>
+            <a:srgbClr val="CDE2FB"/>
+          </a:solidFill>
+          <a:ln>
+            <a:noFill/>
+          </a:ln>
+          <a:effectLst/>
+        </p:spPr>
+        <p:style>
+          <a:lnRef idx="1">
+            <a:schemeClr val="accent1"/>
+          </a:lnRef>
+          <a:fillRef idx="3">
+            <a:schemeClr val="accent1"/>
+          </a:fillRef>
+          <a:effectRef idx="2">
+            <a:schemeClr val="accent1"/>
+          </a:effectRef>
+          <a:fontRef idx="minor">
+            <a:schemeClr val="lt1"/>
+          </a:fontRef>
+        </p:style>
+        <p:txBody>
+          <a:bodyPr wrap="square" tIns="54864" bIns="54864" rtlCol="0" anchor="ctr"/>
+          <a:lstStyle/>
+          <a:p>
+            <a:pPr algn="ctr"/>
+            <a:r>
+              <a:rPr sz="1200" b="1">
+                <a:solidFill>
+                  <a:srgbClr val="0B0B0B"/>
+                </a:solidFill>
+                <a:latin typeface="Segoe UI Semibold"/>
+              </a:rPr>
+              <a:t>Writer</a:t>
+            </a:r>
+          </a:p>
+        </p:txBody>
+      </p:sp>
+      <p:cxnSp>
+        <p:nvCxnSpPr>
+          <p:cNvPr id="12" name="Connector 11"/>
+          <p:cNvCxnSpPr/>
+          <p:nvPr/>
+        </p:nvCxnSpPr>
+        <p:spPr>
+          <a:xfrm>
+            <a:off x="8869680" y="2980945"/>
+            <a:ext cx="0" cy="502919"/>
+          </a:xfrm>
+          <a:prstGeom prst="line">
+            <a:avLst/>
+          </a:prstGeom>
+          <a:ln w="15875">
+            <a:solidFill>
+              <a:srgbClr val="E1E0D9"/>
+            </a:solidFill>
+          </a:ln>
+        </p:spPr>
+        <p:style>
+          <a:lnRef idx="2">
+            <a:schemeClr val="accent1"/>
+          </a:lnRef>
+          <a:fillRef idx="0">
+            <a:schemeClr val="accent1"/>
+          </a:fillRef>
+          <a:effectRef idx="1">
+            <a:schemeClr val="accent1"/>
+          </a:effectRef>
+          <a:fontRef idx="minor">
+            <a:schemeClr val="tx1"/>
+          </a:fontRef>
+        </p:style>
+      </p:cxnSp>
+      <p:sp>
+        <p:nvSpPr>
+          <p:cNvPr id="13" name="Rounded Rectangle 12"/>
+          <p:cNvSpPr/>
+          <p:nvPr/>
+        </p:nvSpPr>
+        <p:spPr>
+          <a:xfrm>
+            <a:off x="8183879" y="3483864"/>
+            <a:ext cx="1371600" cy="685800"/>
+          </a:xfrm>
+          <a:prstGeom prst="roundRect">
+            <a:avLst>
+              <a:gd name="adj" fmla="val 10000"/>
+            </a:avLst>
+          </a:prstGeom>
+          <a:solidFill>
+            <a:srgbClr val="CDE2FB"/>
+          </a:solidFill>
+          <a:ln>
+            <a:noFill/>
+          </a:ln>
+          <a:effectLst/>
+        </p:spPr>
+        <p:style>
+          <a:lnRef idx="1">
+            <a:schemeClr val="accent1"/>
+          </a:lnRef>
+          <a:fillRef idx="3">
+            <a:schemeClr val="accent1"/>
+          </a:fillRef>
+          <a:effectRef idx="2">
+            <a:schemeClr val="accent1"/>
+          </a:effectRef>
+          <a:fontRef idx="minor">
+            <a:schemeClr val="lt1"/>
+          </a:fontRef>
+        </p:style>
+        <p:txBody>
+          <a:bodyPr wrap="square" tIns="54864" bIns="54864" rtlCol="0" anchor="ctr"/>
+          <a:lstStyle/>
+          <a:p>
+            <a:pPr algn="ctr"/>
+            <a:r>
+              <a:rPr sz="1200" b="1">
+                <a:solidFill>
+                  <a:srgbClr val="0B0B0B"/>
+                </a:solidFill>
+                <a:latin typeface="Segoe UI Semibold"/>
+              </a:rPr>
+              <a:t>Reviewer</a:t>
+            </a:r>
+          </a:p>
+        </p:txBody>
+      </p:sp>
+      <p:cxnSp>
+        <p:nvCxnSpPr>
+          <p:cNvPr id="14" name="Connector 13"/>
+          <p:cNvCxnSpPr/>
+          <p:nvPr/>
+        </p:nvCxnSpPr>
+        <p:spPr>
+          <a:xfrm>
+            <a:off x="8869680" y="2980945"/>
+            <a:ext cx="1600200" cy="502919"/>
+          </a:xfrm>
+          <a:prstGeom prst="line">
+            <a:avLst/>
+          </a:prstGeom>
+          <a:ln w="15875">
+            <a:solidFill>
+              <a:srgbClr val="E1E0D9"/>
+            </a:solidFill>
+          </a:ln>
+        </p:spPr>
+        <p:style>
+          <a:lnRef idx="2">
+            <a:schemeClr val="accent1"/>
+          </a:lnRef>
+          <a:fillRef idx="0">
+            <a:schemeClr val="accent1"/>
+          </a:fillRef>
+          <a:effectRef idx="1">
+            <a:schemeClr val="accent1"/>
+          </a:effectRef>
+          <a:fontRef idx="minor">
+            <a:schemeClr val="tx1"/>
+          </a:fontRef>
+        </p:style>
+      </p:cxnSp>
+      <p:sp>
+        <p:nvSpPr>
+          <p:cNvPr id="15" name="Rounded Rectangle 14"/>
+          <p:cNvSpPr/>
+          <p:nvPr/>
+        </p:nvSpPr>
+        <p:spPr>
+          <a:xfrm>
+            <a:off x="9784080" y="3483864"/>
+            <a:ext cx="1371600" cy="685800"/>
+          </a:xfrm>
+          <a:prstGeom prst="roundRect">
+            <a:avLst>
+              <a:gd name="adj" fmla="val 10000"/>
+            </a:avLst>
+          </a:prstGeom>
+          <a:solidFill>
+            <a:srgbClr val="CDE2FB"/>
+          </a:solidFill>
+          <a:ln>
+            <a:noFill/>
+          </a:ln>
+          <a:effectLst/>
+        </p:spPr>
+        <p:style>
+          <a:lnRef idx="1">
+            <a:schemeClr val="accent1"/>
+          </a:lnRef>
+          <a:fillRef idx="3">
+            <a:schemeClr val="accent1"/>
+          </a:fillRef>
+          <a:effectRef idx="2">
+            <a:schemeClr val="accent1"/>
+          </a:effectRef>
+          <a:fontRef idx="minor">
+            <a:schemeClr val="lt1"/>
+          </a:fontRef>
+        </p:style>
+        <p:txBody>
+          <a:bodyPr wrap="square" tIns="54864" bIns="54864" rtlCol="0" anchor="ctr"/>
+          <a:lstStyle/>
+          <a:p>
+            <a:pPr algn="ctr"/>
+            <a:r>
+              <a:rPr sz="1200" b="1">
+                <a:solidFill>
+                  <a:srgbClr val="0B0B0B"/>
+                </a:solidFill>
+                <a:latin typeface="Segoe UI Semibold"/>
+              </a:rPr>
+              <a:t>Fact-checker</a:t>
+            </a:r>
+          </a:p>
+        </p:txBody>
+      </p:sp>
+      <p:sp>
+        <p:nvSpPr>
+          <p:cNvPr id="16" name="TextBox 15"/>
+          <p:cNvSpPr txBox="1"/>
+          <p:nvPr/>
+        </p:nvSpPr>
+        <p:spPr>
+          <a:xfrm>
+            <a:off x="731520" y="4750000"/>
+            <a:ext cx="10424160" cy="1550000"/>
+          </a:xfrm>
+          <a:prstGeom prst="rect">
+            <a:avLst/>
+          </a:prstGeom>
+          <a:noFill/>
+        </p:spPr>
+        <p:txBody>
+          <a:bodyPr wrap="square" lIns="0" tIns="0" rIns="0" bIns="0">
+            <a:spAutoFit/>
+          </a:bodyPr>
+          <a:lstStyle/>
+          <a:p>
+            <a:pPr marL="320040" indent="-320040">
+              <a:spcAft>
+                <a:spcPts val="600"/>
+              </a:spcAft>
+              <a:buFont typeface="Arial"/>
+              <a:buChar char="—  "/>
+            </a:pPr>
+            <a:r>
+              <a:rPr sz="1500" b="1">
+                <a:solidFill>
+                  <a:srgbClr val="0B0B0B"/>
+                </a:solidFill>
+                <a:latin typeface="Segoe UI"/>
+              </a:rPr>
+              <a:t>Multiple, not just one: </a:t>
+            </a:r>
+            <a:r>
+              <a:rPr sz="1500" b="0">
+                <a:solidFill>
+                  <a:srgbClr val="52514E"/>
+                </a:solidFill>
+                <a:latin typeface="Segoe UI"/>
+              </a:rPr>
+              <a:t>brief several reviewer agents with different expertise (methodology, ethics, funder priorities) and let them debate the same draft in the loop.</a:t>
+            </a:r>
+          </a:p>
+          <a:p>
+            <a:pPr marL="320040" indent="-320040">
+              <a:spcAft>
+                <a:spcPts val="600"/>
+              </a:spcAft>
+              <a:buFont typeface="Arial"/>
+              <a:buChar char="—  "/>
+            </a:pPr>
+            <a:r>
+              <a:rPr sz="1500" b="1">
+                <a:solidFill>
+                  <a:srgbClr val="0B0B0B"/>
+                </a:solidFill>
+                <a:latin typeface="Segoe UI"/>
+              </a:rPr>
+              <a:t>Fully unattended: </a:t>
+            </a:r>
+            <a:r>
+              <a:rPr sz="1500" b="0">
+                <a:solidFill>
+                  <a:srgbClr val="52514E"/>
+                </a:solidFill>
+                <a:latin typeface="Segoe UI"/>
+              </a:rPr>
+              <a:t>a scheduled job (e.g. a cron job) can run the whole loop with no human until it's done.</a:t>
+            </a:r>
+          </a:p>
+          <a:p>
+            <a:pPr marL="320040" indent="-320040">
+              <a:spcAft>
+                <a:spcPts val="600"/>
+              </a:spcAft>
+              <a:buFont typeface="Arial"/>
+              <a:buChar char="—  "/>
+            </a:pPr>
+            <a:r>
+              <a:rPr sz="1500" b="1">
+                <a:solidFill>
+                  <a:srgbClr val="0B0B0B"/>
+                </a:solidFill>
+                <a:latin typeface="Segoe UI"/>
+              </a:rPr>
+              <a:t>Either way, a human sets the exit condition — </a:t>
+            </a:r>
+            <a:r>
+              <a:rPr sz="1500" b="0">
+                <a:solidFill>
+                  <a:srgbClr val="52514E"/>
+                </a:solidFill>
+                <a:latin typeface="Segoe UI"/>
+              </a:rPr>
+              <a:t>automation compounds small errors just as fast as small improvements.</a:t>
+            </a:r>
+          </a:p>
+        </p:txBody>
+      </p:sp>
+      <p:sp>
+        <p:nvSpPr>
+          <p:cNvPr id="17" name="TextBox 16"/>
+          <p:cNvSpPr txBox="1"/>
+          <p:nvPr/>
+        </p:nvSpPr>
+        <p:spPr>
+          <a:xfrm>
+            <a:off x="457200" y="6473952"/>
+            <a:ext cx="8229600" cy="320040"/>
+          </a:xfrm>
+          <a:prstGeom prst="rect">
+            <a:avLst/>
+          </a:prstGeom>
+          <a:noFill/>
+        </p:spPr>
+        <p:txBody>
+          <a:bodyPr wrap="square" lIns="0" tIns="0" rIns="0" bIns="0">
+            <a:spAutoFit/>
+          </a:bodyPr>
+          <a:lstStyle/>
+          <a:p>
+            <a:r>
+              <a:rPr sz="1000" b="0">
+                <a:solidFill>
+                  <a:srgbClr val="898781"/>
+                </a:solidFill>
+                <a:latin typeface="Segoe UI"/>
+              </a:rPr>
+              <a:t>Levels of Using AI in Research</a:t>
+            </a:r>
+          </a:p>
+        </p:txBody>
+      </p:sp>
+      <p:sp>
+        <p:nvSpPr>
+          <p:cNvPr id="18" name="TextBox 17"/>
+          <p:cNvSpPr txBox="1"/>
+          <p:nvPr/>
+        </p:nvSpPr>
+        <p:spPr>
+          <a:xfrm>
+            <a:off x="11430000" y="6473952"/>
+            <a:ext cx="457200" cy="320040"/>
+          </a:xfrm>
+          <a:prstGeom prst="rect">
+            <a:avLst/>
+          </a:prstGeom>
+          <a:noFill/>
+        </p:spPr>
+        <p:txBody>
+          <a:bodyPr wrap="square" lIns="0" tIns="0" rIns="0" bIns="0">
+            <a:spAutoFit/>
+          </a:bodyPr>
+          <a:lstStyle/>
+          <a:p>
+            <a:pPr algn="r"/>
+            <a:r>
+              <a:rPr sz="1000" b="0">
+                <a:solidFill>
+                  <a:srgbClr val="898781"/>
+                </a:solidFill>
+                <a:latin typeface="Segoe UI"/>
+              </a:rPr>
+              <a:t>15</a:t>
+            </a:r>
+          </a:p>
+        </p:txBody>
+      </p:sp>
+      <p:cxnSp>
+        <p:nvCxnSpPr>
+          <p:cNvPr id="19" name="Connector 18"/>
+          <p:cNvCxnSpPr/>
+          <p:nvPr/>
+        </p:nvCxnSpPr>
+        <p:spPr>
+          <a:xfrm>
+            <a:off x="457200" y="6419088"/>
+            <a:ext cx="11274552" cy="0"/>
+          </a:xfrm>
+          <a:prstGeom prst="line">
+            <a:avLst/>
+          </a:prstGeom>
+          <a:ln w="9525">
+            <a:solidFill>
+              <a:srgbClr val="E1E0D9"/>
+            </a:solidFill>
+          </a:ln>
+        </p:spPr>
+        <p:style>
+          <a:lnRef idx="2">
+            <a:schemeClr val="accent1"/>
+          </a:lnRef>
+          <a:fillRef idx="0">
+            <a:schemeClr val="accent1"/>
+          </a:fillRef>
+          <a:effectRef idx="1">
+            <a:schemeClr val="accent1"/>
+          </a:effectRef>
+          <a:fontRef idx="minor">
+            <a:schemeClr val="tx1"/>
+          </a:fontRef>
+        </p:style>
+      </p:cxnSp>
+      <p:sp>
+        <p:nvSpPr>
+          <p:cNvPr id="20" name="Rounded Rectangle 19"/>
+          <p:cNvSpPr/>
+          <p:nvPr/>
+        </p:nvSpPr>
+        <p:spPr>
+          <a:xfrm>
             <a:off x="9838944" y="6583680"/>
             <a:ext cx="201168" cy="91440"/>
           </a:xfrm>
@@ -10114,7 +10413,7 @@
       </p:sp>
       <p:sp>
         <p:nvSpPr>
-          <p:cNvPr id="12" name="Rounded Rectangle 11"/>
+          <p:cNvPr id="21" name="Rounded Rectangle 20"/>
           <p:cNvSpPr/>
           <p:nvPr/>
         </p:nvSpPr>
@@ -10160,7 +10459,7 @@
       </p:sp>
       <p:sp>
         <p:nvSpPr>
-          <p:cNvPr id="13" name="Rounded Rectangle 12"/>
+          <p:cNvPr id="22" name="Rounded Rectangle 21"/>
           <p:cNvSpPr/>
           <p:nvPr/>
         </p:nvSpPr>
@@ -10206,7 +10505,7 @@
       </p:sp>
       <p:sp>
         <p:nvSpPr>
-          <p:cNvPr id="14" name="Rounded Rectangle 13"/>
+          <p:cNvPr id="23" name="Rounded Rectangle 22"/>
           <p:cNvSpPr/>
           <p:nvPr/>
         </p:nvSpPr>
@@ -10252,7 +10551,7 @@
       </p:sp>
       <p:sp>
         <p:nvSpPr>
-          <p:cNvPr id="15" name="Rounded Rectangle 14"/>
+          <p:cNvPr id="24" name="Rounded Rectangle 23"/>
           <p:cNvSpPr/>
           <p:nvPr/>
         </p:nvSpPr>
@@ -10298,7 +10597,7 @@
       </p:sp>
       <p:sp>
         <p:nvSpPr>
-          <p:cNvPr id="16" name="Rounded Rectangle 15"/>
+          <p:cNvPr id="25" name="Rounded Rectangle 24"/>
           <p:cNvSpPr/>
           <p:nvPr/>
         </p:nvSpPr>
@@ -10344,7 +10643,7 @@
       </p:sp>
       <p:sp>
         <p:nvSpPr>
-          <p:cNvPr id="17" name="Rounded Rectangle 16"/>
+          <p:cNvPr id="26" name="Rounded Rectangle 25"/>
           <p:cNvSpPr/>
           <p:nvPr/>
         </p:nvSpPr>
@@ -10359,7 +10658,7 @@
             </a:avLst>
           </a:prstGeom>
           <a:solidFill>
-            <a:srgbClr val="2A78D6"/>
+            <a:srgbClr val="E1E0D9"/>
           </a:solidFill>
           <a:ln>
             <a:noFill/>
@@ -10390,7 +10689,7 @@
       </p:sp>
       <p:sp>
         <p:nvSpPr>
-          <p:cNvPr id="18" name="TextBox 17"/>
+          <p:cNvPr id="27" name="TextBox 26"/>
           <p:cNvSpPr txBox="1"/>
           <p:nvPr/>
         </p:nvSpPr>
@@ -10418,14 +10717,14 @@
                 </a:solidFill>
                 <a:latin typeface="Segoe UI"/>
               </a:rPr>
-              <a:t>LEVEL 7 / 7</a:t>
+              <a:t>LEVEL 6 / 7</a:t>
             </a:r>
           </a:p>
         </p:txBody>
       </p:sp>
       <p:pic>
         <p:nvPicPr>
-          <p:cNvPr id="20" name="Picture 19" descr="cris_title_shape59.png"/>
+          <p:cNvPr id="29" name="Picture 28" descr="cris_title_shape59.png"/>
           <p:cNvPicPr>
             <a:picLocks noChangeAspect="1"/>
           </p:cNvPicPr>
@@ -10474,7 +10773,7 @@
       </p:grpSpPr>
       <p:pic>
         <p:nvPicPr>
-          <p:cNvPr id="18" name="Picture 17" descr="border_clean.png"/>
+          <p:cNvPr id="19" name="Picture 18" descr="border_clean.png"/>
           <p:cNvPicPr>
             <a:picLocks noChangeAspect="1"/>
           </p:cNvPicPr>
@@ -10525,7 +10824,7 @@
                 </a:solidFill>
                 <a:latin typeface="Segoe UI Semibold"/>
               </a:rPr>
-              <a:t>WRAPPING UP</a:t>
+              <a:t>LEVEL 7 · FULL CONTROL</a:t>
             </a:r>
           </a:p>
         </p:txBody>
@@ -10559,21 +10858,194 @@
                 </a:solidFill>
                 <a:latin typeface="Segoe UI Semibold"/>
               </a:rPr>
-              <a:t>Takeaways</a:t>
-            </a:r>
-          </a:p>
-        </p:txBody>
-      </p:sp>
-      <p:sp>
-        <p:nvSpPr>
-          <p:cNvPr id="4" name="TextBox 3"/>
+              <a:t>Some models you can run yourself</a:t>
+            </a:r>
+          </a:p>
+        </p:txBody>
+      </p:sp>
+      <p:sp>
+        <p:nvSpPr>
+          <p:cNvPr id="4" name="Rounded Rectangle 3"/>
+          <p:cNvSpPr/>
+          <p:nvPr/>
+        </p:nvSpPr>
+        <p:spPr>
+          <a:xfrm>
+            <a:off x="822960" y="2377440"/>
+            <a:ext cx="4937760" cy="2011680"/>
+          </a:xfrm>
+          <a:prstGeom prst="roundRect">
+            <a:avLst>
+              <a:gd name="adj" fmla="val 10000"/>
+            </a:avLst>
+          </a:prstGeom>
+          <a:solidFill>
+            <a:srgbClr val="CDE2FB"/>
+          </a:solidFill>
+          <a:ln>
+            <a:noFill/>
+          </a:ln>
+          <a:effectLst/>
+        </p:spPr>
+        <p:style>
+          <a:lnRef idx="1">
+            <a:schemeClr val="accent1"/>
+          </a:lnRef>
+          <a:fillRef idx="3">
+            <a:schemeClr val="accent1"/>
+          </a:fillRef>
+          <a:effectRef idx="2">
+            <a:schemeClr val="accent1"/>
+          </a:effectRef>
+          <a:fontRef idx="minor">
+            <a:schemeClr val="lt1"/>
+          </a:fontRef>
+        </p:style>
+        <p:txBody>
+          <a:bodyPr wrap="square" tIns="54864" bIns="54864" rtlCol="0" anchor="ctr"/>
+          <a:lstStyle/>
+          <a:p>
+            <a:pPr algn="ctr"/>
+            <a:r>
+              <a:rPr sz="1600" b="1">
+                <a:solidFill>
+                  <a:srgbClr val="0B0B0B"/>
+                </a:solidFill>
+                <a:latin typeface="Segoe UI Semibold"/>
+              </a:rPr>
+              <a:t>Cloud (frontier models)</a:t>
+            </a:r>
+          </a:p>
+          <a:p>
+            <a:pPr algn="ctr"/>
+            <a:r>
+              <a:rPr sz="1250" b="0">
+                <a:solidFill>
+                  <a:srgbClr val="52514E"/>
+                </a:solidFill>
+                <a:latin typeface="Segoe UI"/>
+              </a:rPr>
+              <a:t>Best all-round quality, zero setup.
+Your data leaves your machine.</a:t>
+            </a:r>
+          </a:p>
+        </p:txBody>
+      </p:sp>
+      <p:sp>
+        <p:nvSpPr>
+          <p:cNvPr id="5" name="Rounded Rectangle 4"/>
+          <p:cNvSpPr/>
+          <p:nvPr/>
+        </p:nvSpPr>
+        <p:spPr>
+          <a:xfrm>
+            <a:off x="6309360" y="2377440"/>
+            <a:ext cx="4937760" cy="2011680"/>
+          </a:xfrm>
+          <a:prstGeom prst="roundRect">
+            <a:avLst>
+              <a:gd name="adj" fmla="val 10000"/>
+            </a:avLst>
+          </a:prstGeom>
+          <a:solidFill>
+            <a:srgbClr val="F9DACC"/>
+          </a:solidFill>
+          <a:ln>
+            <a:noFill/>
+          </a:ln>
+          <a:effectLst/>
+        </p:spPr>
+        <p:style>
+          <a:lnRef idx="1">
+            <a:schemeClr val="accent1"/>
+          </a:lnRef>
+          <a:fillRef idx="3">
+            <a:schemeClr val="accent1"/>
+          </a:fillRef>
+          <a:effectRef idx="2">
+            <a:schemeClr val="accent1"/>
+          </a:effectRef>
+          <a:fontRef idx="minor">
+            <a:schemeClr val="lt1"/>
+          </a:fontRef>
+        </p:style>
+        <p:txBody>
+          <a:bodyPr wrap="square" tIns="54864" bIns="54864" rtlCol="0" anchor="ctr"/>
+          <a:lstStyle/>
+          <a:p>
+            <a:pPr algn="ctr"/>
+            <a:r>
+              <a:rPr sz="1600" b="1">
+                <a:solidFill>
+                  <a:srgbClr val="0B0B0B"/>
+                </a:solidFill>
+                <a:latin typeface="Segoe UI Semibold"/>
+              </a:rPr>
+              <a:t>Local (open-source models)</a:t>
+            </a:r>
+          </a:p>
+          <a:p>
+            <a:pPr algn="ctr"/>
+            <a:r>
+              <a:rPr sz="1200" b="0">
+                <a:solidFill>
+                  <a:srgbClr val="52514E"/>
+                </a:solidFill>
+                <a:latin typeface="Segoe UI"/>
+              </a:rPr>
+              <a:t>Runs on a capable personal workstation —
+data never leaves it. Improving fast, and
+some specialised models now rival the
+frontier on focused tasks.</a:t>
+            </a:r>
+          </a:p>
+        </p:txBody>
+      </p:sp>
+      <p:sp>
+        <p:nvSpPr>
+          <p:cNvPr id="6" name="TextBox 5"/>
           <p:cNvSpPr txBox="1"/>
           <p:nvPr/>
         </p:nvSpPr>
         <p:spPr>
           <a:xfrm>
-            <a:off x="731520" y="1700000"/>
-            <a:ext cx="10424160" cy="3300000"/>
+            <a:off x="5760720" y="3154680"/>
+            <a:ext cx="548640" cy="457200"/>
+          </a:xfrm>
+          <a:prstGeom prst="rect">
+            <a:avLst/>
+          </a:prstGeom>
+          <a:noFill/>
+        </p:spPr>
+        <p:txBody>
+          <a:bodyPr wrap="square" lIns="0" tIns="0" rIns="0" bIns="0" anchor="ctr">
+            <a:spAutoFit/>
+          </a:bodyPr>
+          <a:lstStyle/>
+          <a:p>
+            <a:pPr algn="ctr"/>
+            <a:r>
+              <a:rPr sz="1600" b="1">
+                <a:solidFill>
+                  <a:srgbClr val="898781"/>
+                </a:solidFill>
+                <a:latin typeface="Segoe UI Semibold"/>
+              </a:rPr>
+              <a:t>vs</a:t>
+            </a:r>
+          </a:p>
+        </p:txBody>
+      </p:sp>
+      <p:sp>
+        <p:nvSpPr>
+          <p:cNvPr id="8" name="TextBox 7"/>
+          <p:cNvSpPr txBox="1"/>
+          <p:nvPr/>
+        </p:nvSpPr>
+        <p:spPr>
+          <a:xfrm>
+            <a:off x="457200" y="6473952"/>
+            <a:ext cx="8229600" cy="320040"/>
           </a:xfrm>
           <a:prstGeom prst="rect">
             <a:avLst/>
@@ -10586,125 +11058,28 @@
           </a:bodyPr>
           <a:lstStyle/>
           <a:p>
-            <a:pPr marL="320040" indent="-320040">
-              <a:spcAft>
-                <a:spcPts val="1400"/>
-              </a:spcAft>
-              <a:buFont typeface="Arial"/>
-              <a:buChar char="—  "/>
-            </a:pPr>
-            <a:r>
-              <a:rPr sz="1600" b="1" dirty="0">
-                <a:solidFill>
-                  <a:srgbClr val="0B0B0B"/>
+            <a:r>
+              <a:rPr sz="1000" b="0">
+                <a:solidFill>
+                  <a:srgbClr val="898781"/>
                 </a:solidFill>
                 <a:latin typeface="Segoe UI"/>
               </a:rPr>
-              <a:t>Every level narrows the same gap: </a:t>
-            </a:r>
-            <a:r>
-              <a:rPr sz="1600" b="0" dirty="0">
-                <a:solidFill>
-                  <a:srgbClr val="52514E"/>
-                </a:solidFill>
-                <a:latin typeface="Segoe UI"/>
-              </a:rPr>
-              <a:t>average to excellent — sometimes with context, sometimes with a skill, a second model, or a loop.</a:t>
-            </a:r>
-          </a:p>
-          <a:p>
-            <a:pPr marL="320040" indent="-320040">
-              <a:spcAft>
-                <a:spcPts val="1400"/>
-              </a:spcAft>
-              <a:buFont typeface="Arial"/>
-              <a:buChar char="—  "/>
-            </a:pPr>
-            <a:r>
-              <a:rPr sz="1600" b="1" dirty="0">
-                <a:solidFill>
-                  <a:srgbClr val="0B0B0B"/>
-                </a:solidFill>
-                <a:latin typeface="Segoe UI"/>
-              </a:rPr>
-              <a:t>Most people quit at Level 1's disappointing first impression — </a:t>
-            </a:r>
-            <a:r>
-              <a:rPr sz="1600" b="0" dirty="0">
-                <a:solidFill>
-                  <a:srgbClr val="52514E"/>
-                </a:solidFill>
-                <a:latin typeface="Segoe UI"/>
-              </a:rPr>
-              <a:t>Levels 2 and 3 alone already change the experience.</a:t>
-            </a:r>
-          </a:p>
-          <a:p>
-            <a:pPr marL="320040" indent="-320040">
-              <a:spcAft>
-                <a:spcPts val="1400"/>
-              </a:spcAft>
-              <a:buFont typeface="Arial"/>
-              <a:buChar char="—  "/>
-            </a:pPr>
-            <a:r>
-              <a:rPr sz="1600" b="1" dirty="0">
-                <a:solidFill>
-                  <a:srgbClr val="0B0B0B"/>
-                </a:solidFill>
-                <a:latin typeface="Segoe UI"/>
-              </a:rPr>
-              <a:t>Levels 4 to 6 are where research teams start actually delegating: </a:t>
-            </a:r>
-            <a:r>
-              <a:rPr sz="1600" b="0" dirty="0">
-                <a:solidFill>
-                  <a:srgbClr val="52514E"/>
-                </a:solidFill>
-                <a:latin typeface="Segoe UI"/>
-              </a:rPr>
-              <a:t>skills, second opinions, review loops.</a:t>
-            </a:r>
-          </a:p>
-          <a:p>
-            <a:pPr marL="320040" indent="-320040">
-              <a:spcAft>
-                <a:spcPts val="1400"/>
-              </a:spcAft>
-              <a:buFont typeface="Arial"/>
-              <a:buChar char="—  "/>
-            </a:pPr>
-            <a:r>
-              <a:rPr sz="1600" b="1" dirty="0">
-                <a:solidFill>
-                  <a:srgbClr val="0B0B0B"/>
-                </a:solidFill>
-                <a:latin typeface="Segoe UI"/>
-              </a:rPr>
-              <a:t>Level 7 is optional — </a:t>
-            </a:r>
-            <a:r>
-              <a:rPr sz="1600" b="0" dirty="0">
-                <a:solidFill>
-                  <a:srgbClr val="52514E"/>
-                </a:solidFill>
-                <a:latin typeface="Segoe UI"/>
-              </a:rPr>
-              <a:t>interesting, but not where most of the value is today.</a:t>
-            </a:r>
-          </a:p>
-        </p:txBody>
-      </p:sp>
-      <p:sp>
-        <p:nvSpPr>
-          <p:cNvPr id="5" name="TextBox 4"/>
+              <a:t>Levels of Using AI in Research</a:t>
+            </a:r>
+          </a:p>
+        </p:txBody>
+      </p:sp>
+      <p:sp>
+        <p:nvSpPr>
+          <p:cNvPr id="9" name="TextBox 8"/>
           <p:cNvSpPr txBox="1"/>
           <p:nvPr/>
         </p:nvSpPr>
         <p:spPr>
           <a:xfrm>
-            <a:off x="457200" y="6473952"/>
-            <a:ext cx="8229600" cy="320040"/>
+            <a:off x="11430000" y="6473952"/>
+            <a:ext cx="457200" cy="320040"/>
           </a:xfrm>
           <a:prstGeom prst="rect">
             <a:avLst/>
@@ -10717,40 +11092,6 @@
           </a:bodyPr>
           <a:lstStyle/>
           <a:p>
-            <a:r>
-              <a:rPr sz="1000" b="0">
-                <a:solidFill>
-                  <a:srgbClr val="898781"/>
-                </a:solidFill>
-                <a:latin typeface="Segoe UI"/>
-              </a:rPr>
-              <a:t>Levels of Using AI in Research</a:t>
-            </a:r>
-          </a:p>
-        </p:txBody>
-      </p:sp>
-      <p:sp>
-        <p:nvSpPr>
-          <p:cNvPr id="6" name="TextBox 5"/>
-          <p:cNvSpPr txBox="1"/>
-          <p:nvPr/>
-        </p:nvSpPr>
-        <p:spPr>
-          <a:xfrm>
-            <a:off x="11430000" y="6473952"/>
-            <a:ext cx="457200" cy="320040"/>
-          </a:xfrm>
-          <a:prstGeom prst="rect">
-            <a:avLst/>
-          </a:prstGeom>
-          <a:noFill/>
-        </p:spPr>
-        <p:txBody>
-          <a:bodyPr wrap="square" lIns="0" tIns="0" rIns="0" bIns="0">
-            <a:spAutoFit/>
-          </a:bodyPr>
-          <a:lstStyle/>
-          <a:p>
             <a:pPr algn="r"/>
             <a:r>
               <a:rPr sz="1000" b="0">
@@ -10766,7 +11107,7 @@
       </p:sp>
       <p:cxnSp>
         <p:nvCxnSpPr>
-          <p:cNvPr id="7" name="Connector 6"/>
+          <p:cNvPr id="10" name="Connector 9"/>
           <p:cNvCxnSpPr/>
           <p:nvPr/>
         </p:nvCxnSpPr>
@@ -10801,7 +11142,7 @@
       </p:cxnSp>
       <p:sp>
         <p:nvSpPr>
-          <p:cNvPr id="8" name="Rounded Rectangle 7"/>
+          <p:cNvPr id="11" name="Rounded Rectangle 10"/>
           <p:cNvSpPr/>
           <p:nvPr/>
         </p:nvSpPr>
@@ -10847,7 +11188,7 @@
       </p:sp>
       <p:sp>
         <p:nvSpPr>
-          <p:cNvPr id="9" name="Rounded Rectangle 8"/>
+          <p:cNvPr id="12" name="Rounded Rectangle 11"/>
           <p:cNvSpPr/>
           <p:nvPr/>
         </p:nvSpPr>
@@ -10893,7 +11234,7 @@
       </p:sp>
       <p:sp>
         <p:nvSpPr>
-          <p:cNvPr id="10" name="Rounded Rectangle 9"/>
+          <p:cNvPr id="13" name="Rounded Rectangle 12"/>
           <p:cNvSpPr/>
           <p:nvPr/>
         </p:nvSpPr>
@@ -10939,7 +11280,7 @@
       </p:sp>
       <p:sp>
         <p:nvSpPr>
-          <p:cNvPr id="11" name="Rounded Rectangle 10"/>
+          <p:cNvPr id="14" name="Rounded Rectangle 13"/>
           <p:cNvSpPr/>
           <p:nvPr/>
         </p:nvSpPr>
@@ -10985,7 +11326,7 @@
       </p:sp>
       <p:sp>
         <p:nvSpPr>
-          <p:cNvPr id="12" name="Rounded Rectangle 11"/>
+          <p:cNvPr id="15" name="Rounded Rectangle 14"/>
           <p:cNvSpPr/>
           <p:nvPr/>
         </p:nvSpPr>
@@ -11031,7 +11372,7 @@
       </p:sp>
       <p:sp>
         <p:nvSpPr>
-          <p:cNvPr id="13" name="Rounded Rectangle 12"/>
+          <p:cNvPr id="16" name="Rounded Rectangle 15"/>
           <p:cNvSpPr/>
           <p:nvPr/>
         </p:nvSpPr>
@@ -11077,7 +11418,7 @@
       </p:sp>
       <p:sp>
         <p:nvSpPr>
-          <p:cNvPr id="14" name="Rounded Rectangle 13"/>
+          <p:cNvPr id="17" name="Rounded Rectangle 16"/>
           <p:cNvSpPr/>
           <p:nvPr/>
         </p:nvSpPr>
@@ -11123,7 +11464,7 @@
       </p:sp>
       <p:sp>
         <p:nvSpPr>
-          <p:cNvPr id="15" name="TextBox 14"/>
+          <p:cNvPr id="18" name="TextBox 17"/>
           <p:cNvSpPr txBox="1"/>
           <p:nvPr/>
         </p:nvSpPr>
@@ -11156,170 +11497,16 @@
           </a:p>
         </p:txBody>
       </p:sp>
-      <p:sp>
-        <p:nvSpPr>
-          <p:cNvPr id="16" name="Rounded Rectangle 10"/>
-          <p:cNvSpPr/>
-          <p:nvPr/>
-        </p:nvSpPr>
-        <p:spPr>
-          <a:xfrm>
-            <a:off x="731520" y="4572000"/>
-            <a:ext cx="10424160" cy="1234440"/>
-          </a:xfrm>
-          <a:prstGeom prst="roundRect">
-            <a:avLst>
-              <a:gd name="adj" fmla="val 8000"/>
-            </a:avLst>
-          </a:prstGeom>
-          <a:solidFill>
-            <a:srgbClr val="F0EFEC"/>
-          </a:solidFill>
-          <a:ln>
-            <a:noFill/>
-          </a:ln>
-          <a:effectLst/>
-        </p:spPr>
-        <p:style>
-          <a:lnRef idx="1">
-            <a:schemeClr val="accent1"/>
-          </a:lnRef>
-          <a:fillRef idx="3">
-            <a:schemeClr val="accent1"/>
-          </a:fillRef>
-          <a:effectRef idx="2">
-            <a:schemeClr val="accent1"/>
-          </a:effectRef>
-          <a:fontRef idx="minor">
-            <a:schemeClr val="lt1"/>
-          </a:fontRef>
-        </p:style>
-        <p:txBody>
-          <a:bodyPr wrap="square" lIns="228600" tIns="109728" rIns="228600" bIns="109728" rtlCol="0" anchor="ctr"/>
-          <a:lstStyle/>
-          <a:p>
-            <a:pPr algn="l"/>
-            <a:r>
-              <a:rPr sz="1500" b="1">
-                <a:solidFill>
-                  <a:srgbClr val="0B0B0B"/>
-                </a:solidFill>
-                <a:latin typeface="Segoe UI"/>
-              </a:rPr>
-              <a:t>It's a tool, not a replacement: </a:t>
-            </a:r>
-            <a:r>
-              <a:rPr sz="1500" b="0">
-                <a:solidFill>
-                  <a:srgbClr val="52514E"/>
-                </a:solidFill>
-                <a:latin typeface="Segoe UI"/>
-              </a:rPr>
-              <a:t>it sharpens the work and buys back your time — the insight, and the credit, stay with the researcher. </a:t>
-            </a:r>
-            <a:r>
-              <a:rPr sz="1500" b="1">
-                <a:solidFill>
-                  <a:srgbClr val="0B0B0B"/>
-                </a:solidFill>
-                <a:latin typeface="Segoe UI"/>
-              </a:rPr>
-              <a:t>Stay critical: </a:t>
-            </a:r>
-            <a:r>
-              <a:rPr sz="1500" b="0">
-                <a:solidFill>
-                  <a:srgbClr val="52514E"/>
-                </a:solidFill>
-                <a:latin typeface="Segoe UI"/>
-              </a:rPr>
-              <a:t>when in doubt, ask it to explain itself and back its claims with sources.</a:t>
-            </a:r>
-          </a:p>
-        </p:txBody>
-      </p:sp>
-      <p:sp>
-        <p:nvSpPr>
-          <p:cNvPr id="17" name="TextBox 16"/>
-          <p:cNvSpPr txBox="1"/>
-          <p:nvPr/>
-        </p:nvSpPr>
-        <p:spPr>
-          <a:xfrm>
-            <a:off x="749808" y="5987741"/>
-            <a:ext cx="10424160" cy="292608"/>
-          </a:xfrm>
-          <a:prstGeom prst="rect">
-            <a:avLst/>
-          </a:prstGeom>
-          <a:noFill/>
-        </p:spPr>
-        <p:txBody>
-          <a:bodyPr wrap="square" lIns="0" tIns="0" rIns="0" bIns="0">
-            <a:spAutoFit/>
-          </a:bodyPr>
-          <a:lstStyle/>
-          <a:p>
-            <a:r>
-              <a:rPr sz="1200" b="1" dirty="0">
-                <a:solidFill>
-                  <a:srgbClr val="0B0B0B"/>
-                </a:solidFill>
-                <a:latin typeface="Segoe UI"/>
-              </a:rPr>
-              <a:t>Handling sensitive proposal data? </a:t>
-            </a:r>
-            <a:r>
-              <a:rPr sz="1200" b="0" dirty="0">
-                <a:solidFill>
-                  <a:srgbClr val="52514E"/>
-                </a:solidFill>
-                <a:latin typeface="Segoe UI"/>
-              </a:rPr>
-              <a:t>Check </a:t>
-            </a:r>
-            <a:r>
-              <a:rPr sz="1200" b="0" u="sng" dirty="0" err="1">
-                <a:solidFill>
-                  <a:srgbClr val="2A78D6"/>
-                </a:solidFill>
-                <a:latin typeface="Segoe UI"/>
-                <a:hlinkClick r:id="rId3"/>
-              </a:rPr>
-              <a:t>UHasselt's</a:t>
-            </a:r>
-            <a:r>
-              <a:rPr sz="1200" b="0" u="sng" dirty="0">
-                <a:solidFill>
-                  <a:srgbClr val="2A78D6"/>
-                </a:solidFill>
-                <a:latin typeface="Segoe UI"/>
-                <a:hlinkClick r:id="rId3"/>
-              </a:rPr>
-              <a:t> AI-tools guidance</a:t>
-            </a:r>
-            <a:r>
-              <a:rPr sz="1200" b="0" dirty="0">
-                <a:solidFill>
-                  <a:srgbClr val="52514E"/>
-                </a:solidFill>
-                <a:latin typeface="Segoe UI"/>
-              </a:rPr>
-              <a:t> before you paste anything into a tool.</a:t>
-            </a:r>
-          </a:p>
-        </p:txBody>
-      </p:sp>
       <p:pic>
         <p:nvPicPr>
-          <p:cNvPr id="19" name="Picture 18" descr="cris_title_shape59.png"/>
+          <p:cNvPr id="20" name="Picture 19" descr="cris_title_shape59.png"/>
           <p:cNvPicPr>
             <a:picLocks noChangeAspect="1"/>
           </p:cNvPicPr>
           <p:nvPr/>
         </p:nvPicPr>
         <p:blipFill>
-          <a:blip r:embed="rId4"/>
+          <a:blip r:embed="rId3"/>
           <a:stretch>
             <a:fillRect/>
           </a:stretch>
@@ -11343,6 +11530,893 @@
 </file>
 
 <file path=ppt/slides/slide17.xml><?xml version="1.0" encoding="utf-8"?>
+<p:sld xmlns:a="http://schemas.openxmlformats.org/drawingml/2006/main" xmlns:r="http://schemas.openxmlformats.org/officeDocument/2006/relationships" xmlns:p="http://schemas.openxmlformats.org/presentationml/2006/main">
+  <p:cSld>
+    <p:spTree>
+      <p:nvGrpSpPr>
+        <p:cNvPr id="1" name=""/>
+        <p:cNvGrpSpPr/>
+        <p:nvPr/>
+      </p:nvGrpSpPr>
+      <p:grpSpPr>
+        <a:xfrm>
+          <a:off x="0" y="0"/>
+          <a:ext cx="0" cy="0"/>
+          <a:chOff x="0" y="0"/>
+          <a:chExt cx="0" cy="0"/>
+        </a:xfrm>
+      </p:grpSpPr>
+      <p:pic>
+        <p:nvPicPr>
+          <p:cNvPr id="18" name="Picture 17" descr="border_clean.png"/>
+          <p:cNvPicPr>
+            <a:picLocks noChangeAspect="1"/>
+          </p:cNvPicPr>
+          <p:nvPr/>
+        </p:nvPicPr>
+        <p:blipFill>
+          <a:blip r:embed="rId2"/>
+          <a:stretch>
+            <a:fillRect/>
+          </a:stretch>
+        </p:blipFill>
+        <p:spPr>
+          <a:xfrm>
+            <a:off x="169333" y="76200"/>
+            <a:ext cx="11826400" cy="6687200"/>
+          </a:xfrm>
+          <a:prstGeom prst="rect">
+            <a:avLst/>
+          </a:prstGeom>
+        </p:spPr>
+      </p:pic>
+      <p:sp>
+        <p:nvSpPr>
+          <p:cNvPr id="2" name="TextBox 1"/>
+          <p:cNvSpPr txBox="1"/>
+          <p:nvPr/>
+        </p:nvSpPr>
+        <p:spPr>
+          <a:xfrm>
+            <a:off x="640080" y="256032"/>
+            <a:ext cx="9601200" cy="320040"/>
+          </a:xfrm>
+          <a:prstGeom prst="rect">
+            <a:avLst/>
+          </a:prstGeom>
+          <a:noFill/>
+        </p:spPr>
+        <p:txBody>
+          <a:bodyPr wrap="square" lIns="0" tIns="0" rIns="0" bIns="0">
+            <a:spAutoFit/>
+          </a:bodyPr>
+          <a:lstStyle/>
+          <a:p>
+            <a:r>
+              <a:rPr sz="1300" b="1">
+                <a:solidFill>
+                  <a:srgbClr val="2A78D6"/>
+                </a:solidFill>
+                <a:latin typeface="Segoe UI Semibold"/>
+              </a:rPr>
+              <a:t>WRAPPING UP</a:t>
+            </a:r>
+          </a:p>
+        </p:txBody>
+      </p:sp>
+      <p:sp>
+        <p:nvSpPr>
+          <p:cNvPr id="3" name="TextBox 2"/>
+          <p:cNvSpPr txBox="1"/>
+          <p:nvPr/>
+        </p:nvSpPr>
+        <p:spPr>
+          <a:xfrm>
+            <a:off x="640080" y="502920"/>
+            <a:ext cx="10881360" cy="822960"/>
+          </a:xfrm>
+          <a:prstGeom prst="rect">
+            <a:avLst/>
+          </a:prstGeom>
+          <a:noFill/>
+        </p:spPr>
+        <p:txBody>
+          <a:bodyPr wrap="square" lIns="0" tIns="0" rIns="0" bIns="0">
+            <a:spAutoFit/>
+          </a:bodyPr>
+          <a:lstStyle/>
+          <a:p>
+            <a:r>
+              <a:rPr sz="3000" b="1">
+                <a:solidFill>
+                  <a:srgbClr val="0B0B0B"/>
+                </a:solidFill>
+                <a:latin typeface="Segoe UI Semibold"/>
+              </a:rPr>
+              <a:t>Takeaways</a:t>
+            </a:r>
+          </a:p>
+        </p:txBody>
+      </p:sp>
+      <p:sp>
+        <p:nvSpPr>
+          <p:cNvPr id="4" name="TextBox 3"/>
+          <p:cNvSpPr txBox="1"/>
+          <p:nvPr/>
+        </p:nvSpPr>
+        <p:spPr>
+          <a:xfrm>
+            <a:off x="731520" y="1700000"/>
+            <a:ext cx="10424160" cy="3300000"/>
+          </a:xfrm>
+          <a:prstGeom prst="rect">
+            <a:avLst/>
+          </a:prstGeom>
+          <a:noFill/>
+        </p:spPr>
+        <p:txBody>
+          <a:bodyPr wrap="square" lIns="0" tIns="0" rIns="0" bIns="0">
+            <a:spAutoFit/>
+          </a:bodyPr>
+          <a:lstStyle/>
+          <a:p>
+            <a:pPr marL="320040" indent="-320040">
+              <a:spcAft>
+                <a:spcPts val="1400"/>
+              </a:spcAft>
+              <a:buFont typeface="Arial"/>
+              <a:buChar char="—  "/>
+            </a:pPr>
+            <a:r>
+              <a:rPr sz="1600" b="1" dirty="0">
+                <a:solidFill>
+                  <a:srgbClr val="0B0B0B"/>
+                </a:solidFill>
+                <a:latin typeface="Segoe UI"/>
+              </a:rPr>
+              <a:t>Every level narrows the same gap: </a:t>
+            </a:r>
+            <a:r>
+              <a:rPr sz="1600" b="0" dirty="0">
+                <a:solidFill>
+                  <a:srgbClr val="52514E"/>
+                </a:solidFill>
+                <a:latin typeface="Segoe UI"/>
+              </a:rPr>
+              <a:t>average to excellent — sometimes with context, sometimes with a skill, a second model, or a loop.</a:t>
+            </a:r>
+          </a:p>
+          <a:p>
+            <a:pPr marL="320040" indent="-320040">
+              <a:spcAft>
+                <a:spcPts val="1400"/>
+              </a:spcAft>
+              <a:buFont typeface="Arial"/>
+              <a:buChar char="—  "/>
+            </a:pPr>
+            <a:r>
+              <a:rPr sz="1600" b="1" dirty="0">
+                <a:solidFill>
+                  <a:srgbClr val="0B0B0B"/>
+                </a:solidFill>
+                <a:latin typeface="Segoe UI"/>
+              </a:rPr>
+              <a:t>Most people quit at Level 1's disappointing first impression — </a:t>
+            </a:r>
+            <a:r>
+              <a:rPr sz="1600" b="0" dirty="0">
+                <a:solidFill>
+                  <a:srgbClr val="52514E"/>
+                </a:solidFill>
+                <a:latin typeface="Segoe UI"/>
+              </a:rPr>
+              <a:t>Levels 2 and 3 alone already change the experience.</a:t>
+            </a:r>
+          </a:p>
+          <a:p>
+            <a:pPr marL="320040" indent="-320040">
+              <a:spcAft>
+                <a:spcPts val="1400"/>
+              </a:spcAft>
+              <a:buFont typeface="Arial"/>
+              <a:buChar char="—  "/>
+            </a:pPr>
+            <a:r>
+              <a:rPr sz="1600" b="1" dirty="0">
+                <a:solidFill>
+                  <a:srgbClr val="0B0B0B"/>
+                </a:solidFill>
+                <a:latin typeface="Segoe UI"/>
+              </a:rPr>
+              <a:t>Levels 4 to 6 are where research teams start actually delegating: </a:t>
+            </a:r>
+            <a:r>
+              <a:rPr sz="1600" b="0" dirty="0">
+                <a:solidFill>
+                  <a:srgbClr val="52514E"/>
+                </a:solidFill>
+                <a:latin typeface="Segoe UI"/>
+              </a:rPr>
+              <a:t>skills, second opinions, review loops.</a:t>
+            </a:r>
+          </a:p>
+          <a:p>
+            <a:pPr marL="320040" indent="-320040">
+              <a:spcAft>
+                <a:spcPts val="1400"/>
+              </a:spcAft>
+              <a:buFont typeface="Arial"/>
+              <a:buChar char="—  "/>
+            </a:pPr>
+            <a:r>
+              <a:rPr sz="1600" b="1" dirty="0">
+                <a:solidFill>
+                  <a:srgbClr val="0B0B0B"/>
+                </a:solidFill>
+                <a:latin typeface="Segoe UI"/>
+              </a:rPr>
+              <a:t>Level 7 is optional — </a:t>
+            </a:r>
+            <a:r>
+              <a:rPr sz="1600" b="0" dirty="0">
+                <a:solidFill>
+                  <a:srgbClr val="52514E"/>
+                </a:solidFill>
+                <a:latin typeface="Segoe UI"/>
+              </a:rPr>
+              <a:t>interesting, but not where most of the value is today.</a:t>
+            </a:r>
+          </a:p>
+        </p:txBody>
+      </p:sp>
+      <p:sp>
+        <p:nvSpPr>
+          <p:cNvPr id="5" name="TextBox 4"/>
+          <p:cNvSpPr txBox="1"/>
+          <p:nvPr/>
+        </p:nvSpPr>
+        <p:spPr>
+          <a:xfrm>
+            <a:off x="457200" y="6473952"/>
+            <a:ext cx="8229600" cy="320040"/>
+          </a:xfrm>
+          <a:prstGeom prst="rect">
+            <a:avLst/>
+          </a:prstGeom>
+          <a:noFill/>
+        </p:spPr>
+        <p:txBody>
+          <a:bodyPr wrap="square" lIns="0" tIns="0" rIns="0" bIns="0">
+            <a:spAutoFit/>
+          </a:bodyPr>
+          <a:lstStyle/>
+          <a:p>
+            <a:r>
+              <a:rPr sz="1000" b="0">
+                <a:solidFill>
+                  <a:srgbClr val="898781"/>
+                </a:solidFill>
+                <a:latin typeface="Segoe UI"/>
+              </a:rPr>
+              <a:t>Levels of Using AI in Research</a:t>
+            </a:r>
+          </a:p>
+        </p:txBody>
+      </p:sp>
+      <p:sp>
+        <p:nvSpPr>
+          <p:cNvPr id="6" name="TextBox 5"/>
+          <p:cNvSpPr txBox="1"/>
+          <p:nvPr/>
+        </p:nvSpPr>
+        <p:spPr>
+          <a:xfrm>
+            <a:off x="11430000" y="6473952"/>
+            <a:ext cx="457200" cy="320040"/>
+          </a:xfrm>
+          <a:prstGeom prst="rect">
+            <a:avLst/>
+          </a:prstGeom>
+          <a:noFill/>
+        </p:spPr>
+        <p:txBody>
+          <a:bodyPr wrap="square" lIns="0" tIns="0" rIns="0" bIns="0">
+            <a:spAutoFit/>
+          </a:bodyPr>
+          <a:lstStyle/>
+          <a:p>
+            <a:pPr algn="r"/>
+            <a:r>
+              <a:rPr sz="1000" b="0">
+                <a:solidFill>
+                  <a:srgbClr val="898781"/>
+                </a:solidFill>
+                <a:latin typeface="Segoe UI"/>
+              </a:rPr>
+              <a:t>17</a:t>
+            </a:r>
+          </a:p>
+        </p:txBody>
+      </p:sp>
+      <p:cxnSp>
+        <p:nvCxnSpPr>
+          <p:cNvPr id="7" name="Connector 6"/>
+          <p:cNvCxnSpPr/>
+          <p:nvPr/>
+        </p:nvCxnSpPr>
+        <p:spPr>
+          <a:xfrm>
+            <a:off x="457200" y="6419088"/>
+            <a:ext cx="11274552" cy="0"/>
+          </a:xfrm>
+          <a:prstGeom prst="line">
+            <a:avLst/>
+          </a:prstGeom>
+          <a:ln w="9525">
+            <a:solidFill>
+              <a:srgbClr val="E1E0D9"/>
+            </a:solidFill>
+          </a:ln>
+        </p:spPr>
+        <p:style>
+          <a:lnRef idx="2">
+            <a:schemeClr val="accent1"/>
+          </a:lnRef>
+          <a:fillRef idx="0">
+            <a:schemeClr val="accent1"/>
+          </a:fillRef>
+          <a:effectRef idx="1">
+            <a:schemeClr val="accent1"/>
+          </a:effectRef>
+          <a:fontRef idx="minor">
+            <a:schemeClr val="tx1"/>
+          </a:fontRef>
+        </p:style>
+      </p:cxnSp>
+      <p:sp>
+        <p:nvSpPr>
+          <p:cNvPr id="8" name="Rounded Rectangle 7"/>
+          <p:cNvSpPr/>
+          <p:nvPr/>
+        </p:nvSpPr>
+        <p:spPr>
+          <a:xfrm>
+            <a:off x="9838944" y="6583680"/>
+            <a:ext cx="201168" cy="91440"/>
+          </a:xfrm>
+          <a:prstGeom prst="roundRect">
+            <a:avLst>
+              <a:gd name="adj" fmla="val 50000"/>
+            </a:avLst>
+          </a:prstGeom>
+          <a:solidFill>
+            <a:srgbClr val="2A78D6"/>
+          </a:solidFill>
+          <a:ln>
+            <a:noFill/>
+          </a:ln>
+        </p:spPr>
+        <p:style>
+          <a:lnRef idx="1">
+            <a:schemeClr val="accent1"/>
+          </a:lnRef>
+          <a:fillRef idx="3">
+            <a:schemeClr val="accent1"/>
+          </a:fillRef>
+          <a:effectRef idx="2">
+            <a:schemeClr val="accent1"/>
+          </a:effectRef>
+          <a:fontRef idx="minor">
+            <a:schemeClr val="lt1"/>
+          </a:fontRef>
+        </p:style>
+        <p:txBody>
+          <a:bodyPr rtlCol="0" anchor="ctr"/>
+          <a:lstStyle/>
+          <a:p>
+            <a:pPr algn="ctr"/>
+            <a:endParaRPr/>
+          </a:p>
+        </p:txBody>
+      </p:sp>
+      <p:sp>
+        <p:nvSpPr>
+          <p:cNvPr id="9" name="Rounded Rectangle 8"/>
+          <p:cNvSpPr/>
+          <p:nvPr/>
+        </p:nvSpPr>
+        <p:spPr>
+          <a:xfrm>
+            <a:off x="10085832" y="6583680"/>
+            <a:ext cx="201168" cy="91440"/>
+          </a:xfrm>
+          <a:prstGeom prst="roundRect">
+            <a:avLst>
+              <a:gd name="adj" fmla="val 50000"/>
+            </a:avLst>
+          </a:prstGeom>
+          <a:solidFill>
+            <a:srgbClr val="2A78D6"/>
+          </a:solidFill>
+          <a:ln>
+            <a:noFill/>
+          </a:ln>
+        </p:spPr>
+        <p:style>
+          <a:lnRef idx="1">
+            <a:schemeClr val="accent1"/>
+          </a:lnRef>
+          <a:fillRef idx="3">
+            <a:schemeClr val="accent1"/>
+          </a:fillRef>
+          <a:effectRef idx="2">
+            <a:schemeClr val="accent1"/>
+          </a:effectRef>
+          <a:fontRef idx="minor">
+            <a:schemeClr val="lt1"/>
+          </a:fontRef>
+        </p:style>
+        <p:txBody>
+          <a:bodyPr rtlCol="0" anchor="ctr"/>
+          <a:lstStyle/>
+          <a:p>
+            <a:pPr algn="ctr"/>
+            <a:endParaRPr/>
+          </a:p>
+        </p:txBody>
+      </p:sp>
+      <p:sp>
+        <p:nvSpPr>
+          <p:cNvPr id="10" name="Rounded Rectangle 9"/>
+          <p:cNvSpPr/>
+          <p:nvPr/>
+        </p:nvSpPr>
+        <p:spPr>
+          <a:xfrm>
+            <a:off x="10332720" y="6583680"/>
+            <a:ext cx="201168" cy="91440"/>
+          </a:xfrm>
+          <a:prstGeom prst="roundRect">
+            <a:avLst>
+              <a:gd name="adj" fmla="val 50000"/>
+            </a:avLst>
+          </a:prstGeom>
+          <a:solidFill>
+            <a:srgbClr val="2A78D6"/>
+          </a:solidFill>
+          <a:ln>
+            <a:noFill/>
+          </a:ln>
+        </p:spPr>
+        <p:style>
+          <a:lnRef idx="1">
+            <a:schemeClr val="accent1"/>
+          </a:lnRef>
+          <a:fillRef idx="3">
+            <a:schemeClr val="accent1"/>
+          </a:fillRef>
+          <a:effectRef idx="2">
+            <a:schemeClr val="accent1"/>
+          </a:effectRef>
+          <a:fontRef idx="minor">
+            <a:schemeClr val="lt1"/>
+          </a:fontRef>
+        </p:style>
+        <p:txBody>
+          <a:bodyPr rtlCol="0" anchor="ctr"/>
+          <a:lstStyle/>
+          <a:p>
+            <a:pPr algn="ctr"/>
+            <a:endParaRPr/>
+          </a:p>
+        </p:txBody>
+      </p:sp>
+      <p:sp>
+        <p:nvSpPr>
+          <p:cNvPr id="11" name="Rounded Rectangle 10"/>
+          <p:cNvSpPr/>
+          <p:nvPr/>
+        </p:nvSpPr>
+        <p:spPr>
+          <a:xfrm>
+            <a:off x="10579608" y="6583680"/>
+            <a:ext cx="201168" cy="91440"/>
+          </a:xfrm>
+          <a:prstGeom prst="roundRect">
+            <a:avLst>
+              <a:gd name="adj" fmla="val 50000"/>
+            </a:avLst>
+          </a:prstGeom>
+          <a:solidFill>
+            <a:srgbClr val="2A78D6"/>
+          </a:solidFill>
+          <a:ln>
+            <a:noFill/>
+          </a:ln>
+        </p:spPr>
+        <p:style>
+          <a:lnRef idx="1">
+            <a:schemeClr val="accent1"/>
+          </a:lnRef>
+          <a:fillRef idx="3">
+            <a:schemeClr val="accent1"/>
+          </a:fillRef>
+          <a:effectRef idx="2">
+            <a:schemeClr val="accent1"/>
+          </a:effectRef>
+          <a:fontRef idx="minor">
+            <a:schemeClr val="lt1"/>
+          </a:fontRef>
+        </p:style>
+        <p:txBody>
+          <a:bodyPr rtlCol="0" anchor="ctr"/>
+          <a:lstStyle/>
+          <a:p>
+            <a:pPr algn="ctr"/>
+            <a:endParaRPr/>
+          </a:p>
+        </p:txBody>
+      </p:sp>
+      <p:sp>
+        <p:nvSpPr>
+          <p:cNvPr id="12" name="Rounded Rectangle 11"/>
+          <p:cNvSpPr/>
+          <p:nvPr/>
+        </p:nvSpPr>
+        <p:spPr>
+          <a:xfrm>
+            <a:off x="10826496" y="6583680"/>
+            <a:ext cx="201168" cy="91440"/>
+          </a:xfrm>
+          <a:prstGeom prst="roundRect">
+            <a:avLst>
+              <a:gd name="adj" fmla="val 50000"/>
+            </a:avLst>
+          </a:prstGeom>
+          <a:solidFill>
+            <a:srgbClr val="2A78D6"/>
+          </a:solidFill>
+          <a:ln>
+            <a:noFill/>
+          </a:ln>
+        </p:spPr>
+        <p:style>
+          <a:lnRef idx="1">
+            <a:schemeClr val="accent1"/>
+          </a:lnRef>
+          <a:fillRef idx="3">
+            <a:schemeClr val="accent1"/>
+          </a:fillRef>
+          <a:effectRef idx="2">
+            <a:schemeClr val="accent1"/>
+          </a:effectRef>
+          <a:fontRef idx="minor">
+            <a:schemeClr val="lt1"/>
+          </a:fontRef>
+        </p:style>
+        <p:txBody>
+          <a:bodyPr rtlCol="0" anchor="ctr"/>
+          <a:lstStyle/>
+          <a:p>
+            <a:pPr algn="ctr"/>
+            <a:endParaRPr/>
+          </a:p>
+        </p:txBody>
+      </p:sp>
+      <p:sp>
+        <p:nvSpPr>
+          <p:cNvPr id="13" name="Rounded Rectangle 12"/>
+          <p:cNvSpPr/>
+          <p:nvPr/>
+        </p:nvSpPr>
+        <p:spPr>
+          <a:xfrm>
+            <a:off x="11073384" y="6583680"/>
+            <a:ext cx="201168" cy="91440"/>
+          </a:xfrm>
+          <a:prstGeom prst="roundRect">
+            <a:avLst>
+              <a:gd name="adj" fmla="val 50000"/>
+            </a:avLst>
+          </a:prstGeom>
+          <a:solidFill>
+            <a:srgbClr val="2A78D6"/>
+          </a:solidFill>
+          <a:ln>
+            <a:noFill/>
+          </a:ln>
+        </p:spPr>
+        <p:style>
+          <a:lnRef idx="1">
+            <a:schemeClr val="accent1"/>
+          </a:lnRef>
+          <a:fillRef idx="3">
+            <a:schemeClr val="accent1"/>
+          </a:fillRef>
+          <a:effectRef idx="2">
+            <a:schemeClr val="accent1"/>
+          </a:effectRef>
+          <a:fontRef idx="minor">
+            <a:schemeClr val="lt1"/>
+          </a:fontRef>
+        </p:style>
+        <p:txBody>
+          <a:bodyPr rtlCol="0" anchor="ctr"/>
+          <a:lstStyle/>
+          <a:p>
+            <a:pPr algn="ctr"/>
+            <a:endParaRPr/>
+          </a:p>
+        </p:txBody>
+      </p:sp>
+      <p:sp>
+        <p:nvSpPr>
+          <p:cNvPr id="14" name="Rounded Rectangle 13"/>
+          <p:cNvSpPr/>
+          <p:nvPr/>
+        </p:nvSpPr>
+        <p:spPr>
+          <a:xfrm>
+            <a:off x="11320272" y="6583680"/>
+            <a:ext cx="201168" cy="91440"/>
+          </a:xfrm>
+          <a:prstGeom prst="roundRect">
+            <a:avLst>
+              <a:gd name="adj" fmla="val 50000"/>
+            </a:avLst>
+          </a:prstGeom>
+          <a:solidFill>
+            <a:srgbClr val="2A78D6"/>
+          </a:solidFill>
+          <a:ln>
+            <a:noFill/>
+          </a:ln>
+        </p:spPr>
+        <p:style>
+          <a:lnRef idx="1">
+            <a:schemeClr val="accent1"/>
+          </a:lnRef>
+          <a:fillRef idx="3">
+            <a:schemeClr val="accent1"/>
+          </a:fillRef>
+          <a:effectRef idx="2">
+            <a:schemeClr val="accent1"/>
+          </a:effectRef>
+          <a:fontRef idx="minor">
+            <a:schemeClr val="lt1"/>
+          </a:fontRef>
+        </p:style>
+        <p:txBody>
+          <a:bodyPr rtlCol="0" anchor="ctr"/>
+          <a:lstStyle/>
+          <a:p>
+            <a:pPr algn="ctr"/>
+            <a:endParaRPr/>
+          </a:p>
+        </p:txBody>
+      </p:sp>
+      <p:sp>
+        <p:nvSpPr>
+          <p:cNvPr id="15" name="TextBox 14"/>
+          <p:cNvSpPr txBox="1"/>
+          <p:nvPr/>
+        </p:nvSpPr>
+        <p:spPr>
+          <a:xfrm>
+            <a:off x="8375904" y="6473952"/>
+            <a:ext cx="1371600" cy="274320"/>
+          </a:xfrm>
+          <a:prstGeom prst="rect">
+            <a:avLst/>
+          </a:prstGeom>
+          <a:noFill/>
+        </p:spPr>
+        <p:txBody>
+          <a:bodyPr wrap="square" lIns="0" tIns="0" rIns="0" bIns="0">
+            <a:spAutoFit/>
+          </a:bodyPr>
+          <a:lstStyle/>
+          <a:p>
+            <a:pPr algn="r"/>
+            <a:r>
+              <a:rPr sz="800" b="1">
+                <a:solidFill>
+                  <a:srgbClr val="898781"/>
+                </a:solidFill>
+                <a:latin typeface="Segoe UI"/>
+              </a:rPr>
+              <a:t>LEVEL 7 / 7</a:t>
+            </a:r>
+          </a:p>
+        </p:txBody>
+      </p:sp>
+      <p:sp>
+        <p:nvSpPr>
+          <p:cNvPr id="16" name="Rounded Rectangle 10"/>
+          <p:cNvSpPr/>
+          <p:nvPr/>
+        </p:nvSpPr>
+        <p:spPr>
+          <a:xfrm>
+            <a:off x="731520" y="4572000"/>
+            <a:ext cx="10424160" cy="1234440"/>
+          </a:xfrm>
+          <a:prstGeom prst="roundRect">
+            <a:avLst>
+              <a:gd name="adj" fmla="val 8000"/>
+            </a:avLst>
+          </a:prstGeom>
+          <a:solidFill>
+            <a:srgbClr val="F0EFEC"/>
+          </a:solidFill>
+          <a:ln>
+            <a:noFill/>
+          </a:ln>
+          <a:effectLst/>
+        </p:spPr>
+        <p:style>
+          <a:lnRef idx="1">
+            <a:schemeClr val="accent1"/>
+          </a:lnRef>
+          <a:fillRef idx="3">
+            <a:schemeClr val="accent1"/>
+          </a:fillRef>
+          <a:effectRef idx="2">
+            <a:schemeClr val="accent1"/>
+          </a:effectRef>
+          <a:fontRef idx="minor">
+            <a:schemeClr val="lt1"/>
+          </a:fontRef>
+        </p:style>
+        <p:txBody>
+          <a:bodyPr wrap="square" lIns="228600" tIns="109728" rIns="228600" bIns="109728" rtlCol="0" anchor="ctr"/>
+          <a:lstStyle/>
+          <a:p>
+            <a:pPr algn="l"/>
+            <a:r>
+              <a:rPr sz="1500" b="1">
+                <a:solidFill>
+                  <a:srgbClr val="0B0B0B"/>
+                </a:solidFill>
+                <a:latin typeface="Segoe UI"/>
+              </a:rPr>
+              <a:t>It's a tool, not a replacement: </a:t>
+            </a:r>
+            <a:r>
+              <a:rPr sz="1500" b="0">
+                <a:solidFill>
+                  <a:srgbClr val="52514E"/>
+                </a:solidFill>
+                <a:latin typeface="Segoe UI"/>
+              </a:rPr>
+              <a:t>it sharpens the work and buys back your time — the insight, and the credit, stay with the researcher. </a:t>
+            </a:r>
+            <a:r>
+              <a:rPr sz="1500" b="1">
+                <a:solidFill>
+                  <a:srgbClr val="0B0B0B"/>
+                </a:solidFill>
+                <a:latin typeface="Segoe UI"/>
+              </a:rPr>
+              <a:t>Stay critical: </a:t>
+            </a:r>
+            <a:r>
+              <a:rPr sz="1500" b="0">
+                <a:solidFill>
+                  <a:srgbClr val="52514E"/>
+                </a:solidFill>
+                <a:latin typeface="Segoe UI"/>
+              </a:rPr>
+              <a:t>when in doubt, ask it to explain itself and back its claims with sources.</a:t>
+            </a:r>
+          </a:p>
+        </p:txBody>
+      </p:sp>
+      <p:sp>
+        <p:nvSpPr>
+          <p:cNvPr id="17" name="TextBox 16"/>
+          <p:cNvSpPr txBox="1"/>
+          <p:nvPr/>
+        </p:nvSpPr>
+        <p:spPr>
+          <a:xfrm>
+            <a:off x="749808" y="5987741"/>
+            <a:ext cx="10424160" cy="292608"/>
+          </a:xfrm>
+          <a:prstGeom prst="rect">
+            <a:avLst/>
+          </a:prstGeom>
+          <a:noFill/>
+        </p:spPr>
+        <p:txBody>
+          <a:bodyPr wrap="square" lIns="0" tIns="0" rIns="0" bIns="0">
+            <a:spAutoFit/>
+          </a:bodyPr>
+          <a:lstStyle/>
+          <a:p>
+            <a:r>
+              <a:rPr sz="1200" b="1" dirty="0">
+                <a:solidFill>
+                  <a:srgbClr val="0B0B0B"/>
+                </a:solidFill>
+                <a:latin typeface="Segoe UI"/>
+              </a:rPr>
+              <a:t>Handling sensitive proposal data? </a:t>
+            </a:r>
+            <a:r>
+              <a:rPr sz="1200" b="0" dirty="0">
+                <a:solidFill>
+                  <a:srgbClr val="52514E"/>
+                </a:solidFill>
+                <a:latin typeface="Segoe UI"/>
+              </a:rPr>
+              <a:t>Check </a:t>
+            </a:r>
+            <a:r>
+              <a:rPr sz="1200" b="0" u="sng" dirty="0" err="1">
+                <a:solidFill>
+                  <a:srgbClr val="2A78D6"/>
+                </a:solidFill>
+                <a:latin typeface="Segoe UI"/>
+                <a:hlinkClick r:id="rId3"/>
+              </a:rPr>
+              <a:t>UHasselt's</a:t>
+            </a:r>
+            <a:r>
+              <a:rPr sz="1200" b="0" u="sng" dirty="0">
+                <a:solidFill>
+                  <a:srgbClr val="2A78D6"/>
+                </a:solidFill>
+                <a:latin typeface="Segoe UI"/>
+                <a:hlinkClick r:id="rId3"/>
+              </a:rPr>
+              <a:t> AI-tools guidance</a:t>
+            </a:r>
+            <a:r>
+              <a:rPr sz="1200" b="0" dirty="0">
+                <a:solidFill>
+                  <a:srgbClr val="52514E"/>
+                </a:solidFill>
+                <a:latin typeface="Segoe UI"/>
+              </a:rPr>
+              <a:t> before you paste anything into a tool.</a:t>
+            </a:r>
+          </a:p>
+        </p:txBody>
+      </p:sp>
+      <p:pic>
+        <p:nvPicPr>
+          <p:cNvPr id="19" name="Picture 18" descr="cris_title_shape59.png"/>
+          <p:cNvPicPr>
+            <a:picLocks noChangeAspect="1"/>
+          </p:cNvPicPr>
+          <p:nvPr/>
+        </p:nvPicPr>
+        <p:blipFill>
+          <a:blip r:embed="rId4"/>
+          <a:stretch>
+            <a:fillRect/>
+          </a:stretch>
+        </p:blipFill>
+        <p:spPr>
+          <a:xfrm>
+            <a:off x="5074920" y="6519672"/>
+            <a:ext cx="771579" cy="182880"/>
+          </a:xfrm>
+          <a:prstGeom prst="rect">
+            <a:avLst/>
+          </a:prstGeom>
+        </p:spPr>
+      </p:pic>
+    </p:spTree>
+  </p:cSld>
+  <p:clrMapOvr>
+    <a:masterClrMapping/>
+  </p:clrMapOvr>
+</p:sld>
+</file>
+
+<file path=ppt/slides/slide18.xml><?xml version="1.0" encoding="utf-8"?>
 <p:sld xmlns:a="http://schemas.openxmlformats.org/drawingml/2006/main" xmlns:r="http://schemas.openxmlformats.org/officeDocument/2006/relationships" xmlns:p="http://schemas.openxmlformats.org/presentationml/2006/main" show="0">
   <p:cSld>
     <p:spTree>
@@ -11725,7 +12799,7 @@
                 </a:solidFill>
                 <a:latin typeface="Segoe UI"/>
               </a:rPr>
-              <a:t>17</a:t>
+              <a:t>18</a:t>
             </a:r>
           </a:p>
         </p:txBody>

</xml_diff>

<commit_message>
Rework slide 12 into an FWO knowledge-base-to-skill schematic
Slide 12 now shows the pipeline behind the two FWO skills (raw sources
-> llm-wiki extraction -> packaged skill -> pressure-tested proposal),
tying Levels 2-4 together on one real funder. The "more prompts worth
testing" cards that used to live here move to slide 13's Extra section,
replacing the old FWO extra entries.
</commit_message>
<xml_diff>
--- a/Levels of Using AI in Research.pptx
+++ b/Levels of Using AI in Research.pptx
@@ -3923,7 +3923,7 @@
         <p:spPr>
           <a:xfrm>
             <a:off x="10304592" y="6308467"/>
-            <a:ext cx="1554018" cy="307777"/>
+            <a:ext cx="1554018" cy="338554"/>
           </a:xfrm>
           <a:prstGeom prst="rect">
             <a:avLst/>
@@ -3938,7 +3938,7 @@
           <a:p>
             <a:pPr algn="ctr"/>
             <a:r>
-              <a:rPr sz="700" dirty="0">
+              <a:rPr sz="800" dirty="0">
                 <a:solidFill>
                   <a:srgbClr val="595959"/>
                 </a:solidFill>
@@ -3983,23 +3983,7 @@
                   <a:schemeClr val="accent1"/>
                 </a:solidFill>
               </a:rPr>
-              <a:t>Want </a:t>
-            </a:r>
-            <a:r>
-              <a:rPr lang="nl-BE" sz="1400" dirty="0" err="1">
-                <a:solidFill>
-                  <a:schemeClr val="accent1"/>
-                </a:solidFill>
-              </a:rPr>
-              <a:t>to</a:t>
-            </a:r>
-            <a:r>
-              <a:rPr lang="nl-BE" sz="1400" dirty="0">
-                <a:solidFill>
-                  <a:schemeClr val="accent1"/>
-                </a:solidFill>
-              </a:rPr>
-              <a:t> follow </a:t>
+              <a:t>Follow </a:t>
             </a:r>
             <a:r>
               <a:rPr lang="nl-BE" sz="1400" dirty="0" err="1">
@@ -4112,7 +4096,7 @@
         <p:spPr>
           <a:xfrm>
             <a:off x="640080" y="502920"/>
-            <a:ext cx="10881360" cy="822960"/>
+            <a:ext cx="10881360" cy="461665"/>
           </a:xfrm>
           <a:prstGeom prst="rect">
             <a:avLst/>
@@ -4126,14 +4110,65 @@
           <a:lstStyle/>
           <a:p>
             <a:r>
-              <a:rPr sz="3000" b="1">
+              <a:rPr sz="3000" b="1" dirty="0">
                 <a:solidFill>
                   <a:srgbClr val="0B0B0B"/>
                 </a:solidFill>
                 <a:latin typeface="Segoe UI Semibold"/>
               </a:rPr>
-              <a:t>“Grill me” on your proposal</a:t>
-            </a:r>
+              <a:t>Grill</a:t>
+            </a:r>
+            <a:r>
+              <a:rPr lang="nl-BE" sz="3000" b="1" dirty="0">
+                <a:solidFill>
+                  <a:srgbClr val="0B0B0B"/>
+                </a:solidFill>
+                <a:latin typeface="Segoe UI Semibold"/>
+              </a:rPr>
+              <a:t>-</a:t>
+            </a:r>
+            <a:r>
+              <a:rPr sz="3000" b="1" dirty="0">
+                <a:solidFill>
+                  <a:srgbClr val="0B0B0B"/>
+                </a:solidFill>
+                <a:latin typeface="Segoe UI Semibold"/>
+              </a:rPr>
+              <a:t>me</a:t>
+            </a:r>
+            <a:r>
+              <a:rPr lang="nl-BE" sz="3000" b="1" dirty="0">
+                <a:solidFill>
+                  <a:srgbClr val="0B0B0B"/>
+                </a:solidFill>
+                <a:latin typeface="Segoe UI Semibold"/>
+              </a:rPr>
+              <a:t>-</a:t>
+            </a:r>
+            <a:r>
+              <a:rPr lang="nl-BE" sz="3000" b="1" dirty="0" err="1">
+                <a:solidFill>
+                  <a:srgbClr val="0B0B0B"/>
+                </a:solidFill>
+                <a:latin typeface="Segoe UI Semibold"/>
+              </a:rPr>
+              <a:t>for</a:t>
+            </a:r>
+            <a:r>
+              <a:rPr lang="nl-BE" sz="3000" b="1" dirty="0">
+                <a:solidFill>
+                  <a:srgbClr val="0B0B0B"/>
+                </a:solidFill>
+                <a:latin typeface="Segoe UI Semibold"/>
+              </a:rPr>
+              <a:t>-research</a:t>
+            </a:r>
+            <a:endParaRPr sz="3000" b="1" dirty="0">
+              <a:solidFill>
+                <a:srgbClr val="0B0B0B"/>
+              </a:solidFill>
+              <a:latin typeface="Segoe UI Semibold"/>
+            </a:endParaRPr>
           </a:p>
         </p:txBody>
       </p:sp>
@@ -4929,30 +4964,6 @@
           <a:xfrm>
             <a:off x="5074920" y="6519672"/>
             <a:ext cx="771579" cy="182880"/>
-          </a:xfrm>
-          <a:prstGeom prst="rect">
-            <a:avLst/>
-          </a:prstGeom>
-        </p:spPr>
-      </p:pic>
-      <p:pic>
-        <p:nvPicPr>
-          <p:cNvPr id="24" name="Picture 23" descr="image.png"/>
-          <p:cNvPicPr>
-            <a:picLocks noChangeAspect="1"/>
-          </p:cNvPicPr>
-          <p:nvPr/>
-        </p:nvPicPr>
-        <p:blipFill>
-          <a:blip r:embed="rId5"/>
-          <a:stretch>
-            <a:fillRect/>
-          </a:stretch>
-        </p:blipFill>
-        <p:spPr>
-          <a:xfrm>
-            <a:off x="10807293" y="201168"/>
-            <a:ext cx="1051560" cy="1051560"/>
           </a:xfrm>
           <a:prstGeom prst="rect">
             <a:avLst/>
@@ -6244,30 +6255,6 @@
           </a:prstGeom>
         </p:spPr>
       </p:pic>
-      <p:pic>
-        <p:nvPicPr>
-          <p:cNvPr id="29" name="Picture 28" descr="image.png"/>
-          <p:cNvPicPr>
-            <a:picLocks noChangeAspect="1"/>
-          </p:cNvPicPr>
-          <p:nvPr/>
-        </p:nvPicPr>
-        <p:blipFill>
-          <a:blip r:embed="rId4"/>
-          <a:stretch>
-            <a:fillRect/>
-          </a:stretch>
-        </p:blipFill>
-        <p:spPr>
-          <a:xfrm>
-            <a:off x="11183112" y="4320540"/>
-            <a:ext cx="640080" cy="640080"/>
-          </a:xfrm>
-          <a:prstGeom prst="rect">
-            <a:avLst/>
-          </a:prstGeom>
-        </p:spPr>
-      </p:pic>
     </p:spTree>
   </p:cSld>
   <p:clrMapOvr>
@@ -6346,7 +6333,7 @@
                 </a:solidFill>
                 <a:latin typeface="Segoe UI Semibold"/>
               </a:rPr>
-              <a:t>LEVEL 4 · MORE FROM THE FIELD</a:t>
+              <a:t>LEVEL 4 · SKILL #4</a:t>
             </a:r>
           </a:p>
         </p:txBody>
@@ -6380,21 +6367,506 @@
                 </a:solidFill>
                 <a:latin typeface="Segoe UI Semibold"/>
               </a:rPr>
-              <a:t>More prompts worth testing</a:t>
-            </a:r>
-          </a:p>
-        </p:txBody>
-      </p:sp>
-      <p:sp>
-        <p:nvSpPr>
-          <p:cNvPr id="4" name="Rounded Rectangle 3"/>
+              <a:t>From FWO's rulebook to a pressure-tested proposal</a:t>
+            </a:r>
+          </a:p>
+        </p:txBody>
+      </p:sp>
+      <p:sp>
+        <p:nvSpPr>
+          <p:cNvPr id="8" name="TextBox 7"/>
+          <p:cNvSpPr txBox="1"/>
+          <p:nvPr/>
+        </p:nvSpPr>
+        <p:spPr>
+          <a:xfrm>
+            <a:off x="457200" y="6473952"/>
+            <a:ext cx="8229600" cy="320040"/>
+          </a:xfrm>
+          <a:prstGeom prst="rect">
+            <a:avLst/>
+          </a:prstGeom>
+          <a:noFill/>
+        </p:spPr>
+        <p:txBody>
+          <a:bodyPr wrap="square" lIns="0" tIns="0" rIns="0" bIns="0">
+            <a:spAutoFit/>
+          </a:bodyPr>
+          <a:lstStyle/>
+          <a:p>
+            <a:r>
+              <a:rPr sz="1000" b="0">
+                <a:solidFill>
+                  <a:srgbClr val="898781"/>
+                </a:solidFill>
+                <a:latin typeface="Segoe UI"/>
+              </a:rPr>
+              <a:t>Levels of Using AI in Research</a:t>
+            </a:r>
+          </a:p>
+        </p:txBody>
+      </p:sp>
+      <p:sp>
+        <p:nvSpPr>
+          <p:cNvPr id="9" name="TextBox 8"/>
+          <p:cNvSpPr txBox="1"/>
+          <p:nvPr/>
+        </p:nvSpPr>
+        <p:spPr>
+          <a:xfrm>
+            <a:off x="11430000" y="6473952"/>
+            <a:ext cx="457200" cy="320040"/>
+          </a:xfrm>
+          <a:prstGeom prst="rect">
+            <a:avLst/>
+          </a:prstGeom>
+          <a:noFill/>
+        </p:spPr>
+        <p:txBody>
+          <a:bodyPr wrap="square" lIns="0" tIns="0" rIns="0" bIns="0">
+            <a:spAutoFit/>
+          </a:bodyPr>
+          <a:lstStyle/>
+          <a:p>
+            <a:pPr algn="r"/>
+            <a:r>
+              <a:rPr sz="1000" b="0">
+                <a:solidFill>
+                  <a:srgbClr val="898781"/>
+                </a:solidFill>
+                <a:latin typeface="Segoe UI"/>
+              </a:rPr>
+              <a:t>12</a:t>
+            </a:r>
+          </a:p>
+        </p:txBody>
+      </p:sp>
+      <p:cxnSp>
+        <p:nvCxnSpPr>
+          <p:cNvPr id="10" name="Connector 9"/>
+          <p:cNvCxnSpPr/>
+          <p:nvPr/>
+        </p:nvCxnSpPr>
+        <p:spPr>
+          <a:xfrm>
+            <a:off x="457200" y="6419088"/>
+            <a:ext cx="11274552" cy="0"/>
+          </a:xfrm>
+          <a:prstGeom prst="line">
+            <a:avLst/>
+          </a:prstGeom>
+          <a:ln w="9525">
+            <a:solidFill>
+              <a:srgbClr val="E1E0D9"/>
+            </a:solidFill>
+          </a:ln>
+        </p:spPr>
+        <p:style>
+          <a:lnRef idx="2">
+            <a:schemeClr val="accent1"/>
+          </a:lnRef>
+          <a:fillRef idx="0">
+            <a:schemeClr val="accent1"/>
+          </a:fillRef>
+          <a:effectRef idx="1">
+            <a:schemeClr val="accent1"/>
+          </a:effectRef>
+          <a:fontRef idx="minor">
+            <a:schemeClr val="tx1"/>
+          </a:fontRef>
+        </p:style>
+      </p:cxnSp>
+      <p:sp>
+        <p:nvSpPr>
+          <p:cNvPr id="11" name="Rounded Rectangle 10"/>
           <p:cNvSpPr/>
           <p:nvPr/>
         </p:nvSpPr>
         <p:spPr>
           <a:xfrm>
-            <a:off x="731520" y="2369872"/>
-            <a:ext cx="2440000" cy="2842216"/>
+            <a:off x="9838944" y="6583680"/>
+            <a:ext cx="201168" cy="91440"/>
+          </a:xfrm>
+          <a:prstGeom prst="roundRect">
+            <a:avLst>
+              <a:gd name="adj" fmla="val 50000"/>
+            </a:avLst>
+          </a:prstGeom>
+          <a:solidFill>
+            <a:srgbClr val="2A78D6"/>
+          </a:solidFill>
+          <a:ln>
+            <a:noFill/>
+          </a:ln>
+        </p:spPr>
+        <p:style>
+          <a:lnRef idx="1">
+            <a:schemeClr val="accent1"/>
+          </a:lnRef>
+          <a:fillRef idx="3">
+            <a:schemeClr val="accent1"/>
+          </a:fillRef>
+          <a:effectRef idx="2">
+            <a:schemeClr val="accent1"/>
+          </a:effectRef>
+          <a:fontRef idx="minor">
+            <a:schemeClr val="lt1"/>
+          </a:fontRef>
+        </p:style>
+        <p:txBody>
+          <a:bodyPr rtlCol="0" anchor="ctr"/>
+          <a:lstStyle/>
+          <a:p>
+            <a:pPr algn="ctr"/>
+            <a:endParaRPr/>
+          </a:p>
+        </p:txBody>
+      </p:sp>
+      <p:sp>
+        <p:nvSpPr>
+          <p:cNvPr id="12" name="Rounded Rectangle 11"/>
+          <p:cNvSpPr/>
+          <p:nvPr/>
+        </p:nvSpPr>
+        <p:spPr>
+          <a:xfrm>
+            <a:off x="10085832" y="6583680"/>
+            <a:ext cx="201168" cy="91440"/>
+          </a:xfrm>
+          <a:prstGeom prst="roundRect">
+            <a:avLst>
+              <a:gd name="adj" fmla="val 50000"/>
+            </a:avLst>
+          </a:prstGeom>
+          <a:solidFill>
+            <a:srgbClr val="2A78D6"/>
+          </a:solidFill>
+          <a:ln>
+            <a:noFill/>
+          </a:ln>
+        </p:spPr>
+        <p:style>
+          <a:lnRef idx="1">
+            <a:schemeClr val="accent1"/>
+          </a:lnRef>
+          <a:fillRef idx="3">
+            <a:schemeClr val="accent1"/>
+          </a:fillRef>
+          <a:effectRef idx="2">
+            <a:schemeClr val="accent1"/>
+          </a:effectRef>
+          <a:fontRef idx="minor">
+            <a:schemeClr val="lt1"/>
+          </a:fontRef>
+        </p:style>
+        <p:txBody>
+          <a:bodyPr rtlCol="0" anchor="ctr"/>
+          <a:lstStyle/>
+          <a:p>
+            <a:pPr algn="ctr"/>
+            <a:endParaRPr/>
+          </a:p>
+        </p:txBody>
+      </p:sp>
+      <p:sp>
+        <p:nvSpPr>
+          <p:cNvPr id="13" name="Rounded Rectangle 12"/>
+          <p:cNvSpPr/>
+          <p:nvPr/>
+        </p:nvSpPr>
+        <p:spPr>
+          <a:xfrm>
+            <a:off x="10332720" y="6583680"/>
+            <a:ext cx="201168" cy="91440"/>
+          </a:xfrm>
+          <a:prstGeom prst="roundRect">
+            <a:avLst>
+              <a:gd name="adj" fmla="val 50000"/>
+            </a:avLst>
+          </a:prstGeom>
+          <a:solidFill>
+            <a:srgbClr val="2A78D6"/>
+          </a:solidFill>
+          <a:ln>
+            <a:noFill/>
+          </a:ln>
+        </p:spPr>
+        <p:style>
+          <a:lnRef idx="1">
+            <a:schemeClr val="accent1"/>
+          </a:lnRef>
+          <a:fillRef idx="3">
+            <a:schemeClr val="accent1"/>
+          </a:fillRef>
+          <a:effectRef idx="2">
+            <a:schemeClr val="accent1"/>
+          </a:effectRef>
+          <a:fontRef idx="minor">
+            <a:schemeClr val="lt1"/>
+          </a:fontRef>
+        </p:style>
+        <p:txBody>
+          <a:bodyPr rtlCol="0" anchor="ctr"/>
+          <a:lstStyle/>
+          <a:p>
+            <a:pPr algn="ctr"/>
+            <a:endParaRPr/>
+          </a:p>
+        </p:txBody>
+      </p:sp>
+      <p:sp>
+        <p:nvSpPr>
+          <p:cNvPr id="14" name="Rounded Rectangle 13"/>
+          <p:cNvSpPr/>
+          <p:nvPr/>
+        </p:nvSpPr>
+        <p:spPr>
+          <a:xfrm>
+            <a:off x="10579608" y="6583680"/>
+            <a:ext cx="201168" cy="91440"/>
+          </a:xfrm>
+          <a:prstGeom prst="roundRect">
+            <a:avLst>
+              <a:gd name="adj" fmla="val 50000"/>
+            </a:avLst>
+          </a:prstGeom>
+          <a:solidFill>
+            <a:srgbClr val="2A78D6"/>
+          </a:solidFill>
+          <a:ln>
+            <a:noFill/>
+          </a:ln>
+        </p:spPr>
+        <p:style>
+          <a:lnRef idx="1">
+            <a:schemeClr val="accent1"/>
+          </a:lnRef>
+          <a:fillRef idx="3">
+            <a:schemeClr val="accent1"/>
+          </a:fillRef>
+          <a:effectRef idx="2">
+            <a:schemeClr val="accent1"/>
+          </a:effectRef>
+          <a:fontRef idx="minor">
+            <a:schemeClr val="lt1"/>
+          </a:fontRef>
+        </p:style>
+        <p:txBody>
+          <a:bodyPr rtlCol="0" anchor="ctr"/>
+          <a:lstStyle/>
+          <a:p>
+            <a:pPr algn="ctr"/>
+            <a:endParaRPr/>
+          </a:p>
+        </p:txBody>
+      </p:sp>
+      <p:sp>
+        <p:nvSpPr>
+          <p:cNvPr id="15" name="Rounded Rectangle 14"/>
+          <p:cNvSpPr/>
+          <p:nvPr/>
+        </p:nvSpPr>
+        <p:spPr>
+          <a:xfrm>
+            <a:off x="10826496" y="6583680"/>
+            <a:ext cx="201168" cy="91440"/>
+          </a:xfrm>
+          <a:prstGeom prst="roundRect">
+            <a:avLst>
+              <a:gd name="adj" fmla="val 50000"/>
+            </a:avLst>
+          </a:prstGeom>
+          <a:solidFill>
+            <a:srgbClr val="E1E0D9"/>
+          </a:solidFill>
+          <a:ln>
+            <a:noFill/>
+          </a:ln>
+        </p:spPr>
+        <p:style>
+          <a:lnRef idx="1">
+            <a:schemeClr val="accent1"/>
+          </a:lnRef>
+          <a:fillRef idx="3">
+            <a:schemeClr val="accent1"/>
+          </a:fillRef>
+          <a:effectRef idx="2">
+            <a:schemeClr val="accent1"/>
+          </a:effectRef>
+          <a:fontRef idx="minor">
+            <a:schemeClr val="lt1"/>
+          </a:fontRef>
+        </p:style>
+        <p:txBody>
+          <a:bodyPr rtlCol="0" anchor="ctr"/>
+          <a:lstStyle/>
+          <a:p>
+            <a:pPr algn="ctr"/>
+            <a:endParaRPr/>
+          </a:p>
+        </p:txBody>
+      </p:sp>
+      <p:sp>
+        <p:nvSpPr>
+          <p:cNvPr id="16" name="Rounded Rectangle 15"/>
+          <p:cNvSpPr/>
+          <p:nvPr/>
+        </p:nvSpPr>
+        <p:spPr>
+          <a:xfrm>
+            <a:off x="11073384" y="6583680"/>
+            <a:ext cx="201168" cy="91440"/>
+          </a:xfrm>
+          <a:prstGeom prst="roundRect">
+            <a:avLst>
+              <a:gd name="adj" fmla="val 50000"/>
+            </a:avLst>
+          </a:prstGeom>
+          <a:solidFill>
+            <a:srgbClr val="E1E0D9"/>
+          </a:solidFill>
+          <a:ln>
+            <a:noFill/>
+          </a:ln>
+        </p:spPr>
+        <p:style>
+          <a:lnRef idx="1">
+            <a:schemeClr val="accent1"/>
+          </a:lnRef>
+          <a:fillRef idx="3">
+            <a:schemeClr val="accent1"/>
+          </a:fillRef>
+          <a:effectRef idx="2">
+            <a:schemeClr val="accent1"/>
+          </a:effectRef>
+          <a:fontRef idx="minor">
+            <a:schemeClr val="lt1"/>
+          </a:fontRef>
+        </p:style>
+        <p:txBody>
+          <a:bodyPr rtlCol="0" anchor="ctr"/>
+          <a:lstStyle/>
+          <a:p>
+            <a:pPr algn="ctr"/>
+            <a:endParaRPr/>
+          </a:p>
+        </p:txBody>
+      </p:sp>
+      <p:sp>
+        <p:nvSpPr>
+          <p:cNvPr id="17" name="Rounded Rectangle 16"/>
+          <p:cNvSpPr/>
+          <p:nvPr/>
+        </p:nvSpPr>
+        <p:spPr>
+          <a:xfrm>
+            <a:off x="11320272" y="6583680"/>
+            <a:ext cx="201168" cy="91440"/>
+          </a:xfrm>
+          <a:prstGeom prst="roundRect">
+            <a:avLst>
+              <a:gd name="adj" fmla="val 50000"/>
+            </a:avLst>
+          </a:prstGeom>
+          <a:solidFill>
+            <a:srgbClr val="E1E0D9"/>
+          </a:solidFill>
+          <a:ln>
+            <a:noFill/>
+          </a:ln>
+        </p:spPr>
+        <p:style>
+          <a:lnRef idx="1">
+            <a:schemeClr val="accent1"/>
+          </a:lnRef>
+          <a:fillRef idx="3">
+            <a:schemeClr val="accent1"/>
+          </a:fillRef>
+          <a:effectRef idx="2">
+            <a:schemeClr val="accent1"/>
+          </a:effectRef>
+          <a:fontRef idx="minor">
+            <a:schemeClr val="lt1"/>
+          </a:fontRef>
+        </p:style>
+        <p:txBody>
+          <a:bodyPr rtlCol="0" anchor="ctr"/>
+          <a:lstStyle/>
+          <a:p>
+            <a:pPr algn="ctr"/>
+            <a:endParaRPr/>
+          </a:p>
+        </p:txBody>
+      </p:sp>
+      <p:sp>
+        <p:nvSpPr>
+          <p:cNvPr id="18" name="TextBox 17"/>
+          <p:cNvSpPr txBox="1"/>
+          <p:nvPr/>
+        </p:nvSpPr>
+        <p:spPr>
+          <a:xfrm>
+            <a:off x="8375904" y="6473952"/>
+            <a:ext cx="1371600" cy="274320"/>
+          </a:xfrm>
+          <a:prstGeom prst="rect">
+            <a:avLst/>
+          </a:prstGeom>
+          <a:noFill/>
+        </p:spPr>
+        <p:txBody>
+          <a:bodyPr wrap="square" lIns="0" tIns="0" rIns="0" bIns="0">
+            <a:spAutoFit/>
+          </a:bodyPr>
+          <a:lstStyle/>
+          <a:p>
+            <a:pPr algn="r"/>
+            <a:r>
+              <a:rPr sz="800" b="1">
+                <a:solidFill>
+                  <a:srgbClr val="898781"/>
+                </a:solidFill>
+                <a:latin typeface="Segoe UI"/>
+              </a:rPr>
+              <a:t>LEVEL 4 / 7</a:t>
+            </a:r>
+          </a:p>
+        </p:txBody>
+      </p:sp>
+      <p:pic>
+        <p:nvPicPr>
+          <p:cNvPr id="29" name="Picture 28" descr="cris_title_shape59.png"/>
+          <p:cNvPicPr>
+            <a:picLocks noChangeAspect="1"/>
+          </p:cNvPicPr>
+          <p:nvPr/>
+        </p:nvPicPr>
+        <p:blipFill>
+          <a:blip r:embed="rId3"/>
+          <a:stretch>
+            <a:fillRect/>
+          </a:stretch>
+        </p:blipFill>
+        <p:spPr>
+          <a:xfrm>
+            <a:off x="5074920" y="6519672"/>
+            <a:ext cx="771579" cy="182880"/>
+          </a:xfrm>
+          <a:prstGeom prst="rect">
+            <a:avLst/>
+          </a:prstGeom>
+        </p:spPr>
+      </p:pic>
+      <p:sp>
+        <p:nvSpPr>
+          <p:cNvPr id="30" name="Pipeline Box 1"/>
+          <p:cNvSpPr/>
+          <p:nvPr/>
+        </p:nvSpPr>
+        <p:spPr>
+          <a:xfrm>
+            <a:off x="731520" y="1900000"/>
+            <a:ext cx="2320000" cy="1417320"/>
           </a:xfrm>
           <a:prstGeom prst="roundRect">
             <a:avLst>
@@ -6427,29 +6899,76 @@
           <a:bodyPr wrap="square" tIns="54864" bIns="54864" rtlCol="0" anchor="ctr"/>
           <a:lstStyle/>
           <a:p>
-            <a:pPr algn="just"/>
-            <a:r>
-              <a:rPr sz="1200" b="0" dirty="0">
+            <a:pPr algn="ctr"/>
+            <a:r>
+              <a:rPr sz="1250" b="1" i="0">
                 <a:solidFill>
                   <a:srgbClr val="0B0B0B"/>
                 </a:solidFill>
-                <a:latin typeface="Consolas"/>
-              </a:rPr>
-              <a:t>Act as a collaborative team of EU funding advisors. Deconstruct this call text for [Insert Topic] and list the mandatory compliance hurdles, core Key Performance Indicators (KPIs), and strategic alignment requirements we must address in the work package.</a:t>
-            </a:r>
-          </a:p>
-        </p:txBody>
-      </p:sp>
-      <p:sp>
-        <p:nvSpPr>
-          <p:cNvPr id="5" name="Rounded Rectangle 4"/>
+                <a:latin typeface="Segoe UI Semibold"/>
+              </a:rPr>
+              <a:t>Knowledge base</a:t>
+            </a:r>
+          </a:p>
+          <a:p>
+            <a:pPr algn="ctr"/>
+            <a:r>
+              <a:rPr sz="950" b="0" i="0">
+                <a:solidFill>
+                  <a:srgbClr val="52514E"/>
+                </a:solidFill>
+                <a:latin typeface="Segoe UI"/>
+              </a:rPr>
+              <a:t>raw FWO sources: regulations, scoring grid, panels, templates</a:t>
+            </a:r>
+          </a:p>
+        </p:txBody>
+      </p:sp>
+      <p:sp>
+        <p:nvSpPr>
+          <p:cNvPr id="31" name="Pipeline Arrow 1"/>
+          <p:cNvSpPr txBox="1"/>
+          <p:nvPr/>
+        </p:nvSpPr>
+        <p:spPr>
+          <a:xfrm>
+            <a:off x="3051520" y="2425780"/>
+            <a:ext cx="350000" cy="365760"/>
+          </a:xfrm>
+          <a:prstGeom prst="rect">
+            <a:avLst/>
+          </a:prstGeom>
+          <a:noFill/>
+        </p:spPr>
+        <p:txBody>
+          <a:bodyPr wrap="square" lIns="0" tIns="0" rIns="0" bIns="0" anchor="ctr">
+            <a:spAutoFit/>
+          </a:bodyPr>
+          <a:lstStyle/>
+          <a:p>
+            <a:pPr algn="ctr"/>
+            <a:r>
+              <a:rPr sz="1800" b="0">
+                <a:solidFill>
+                  <a:srgbClr val="898781"/>
+                </a:solidFill>
+                <a:latin typeface="Segoe UI"/>
+              </a:rPr>
+              <a:t>→</a:t>
+            </a:r>
+          </a:p>
+        </p:txBody>
+      </p:sp>
+      <p:sp>
+        <p:nvSpPr>
+          <p:cNvPr id="32" name="Pipeline Box 2"/>
           <p:cNvSpPr/>
           <p:nvPr/>
         </p:nvSpPr>
         <p:spPr>
           <a:xfrm>
-            <a:off x="3392907" y="2369872"/>
-            <a:ext cx="2440000" cy="2842216"/>
+            <a:off x="3401520" y="1900000"/>
+            <a:ext cx="2320000" cy="1417320"/>
           </a:xfrm>
           <a:prstGeom prst="roundRect">
             <a:avLst>
@@ -6457,7 +6976,7 @@
             </a:avLst>
           </a:prstGeom>
           <a:solidFill>
-            <a:srgbClr val="F0EFEC"/>
+            <a:srgbClr val="CDE2FB"/>
           </a:solidFill>
           <a:ln>
             <a:noFill/>
@@ -6482,29 +7001,76 @@
           <a:bodyPr wrap="square" tIns="54864" bIns="54864" rtlCol="0" anchor="ctr"/>
           <a:lstStyle/>
           <a:p>
-            <a:pPr algn="just"/>
-            <a:r>
-              <a:rPr sz="1200" b="0" dirty="0">
+            <a:pPr algn="ctr"/>
+            <a:r>
+              <a:rPr sz="1250" b="1" i="0">
                 <a:solidFill>
                   <a:srgbClr val="0B0B0B"/>
                 </a:solidFill>
-                <a:latin typeface="Consolas"/>
-              </a:rPr>
-              <a:t>Take this heavily jargon-filled project summary and rewrite it to retain technical accuracy while improving readability and engagement for a diverse evaluation board.</a:t>
-            </a:r>
-          </a:p>
-        </p:txBody>
-      </p:sp>
-      <p:sp>
-        <p:nvSpPr>
-          <p:cNvPr id="6" name="Rounded Rectangle 5"/>
+                <a:latin typeface="Segoe UI Semibold"/>
+              </a:rPr>
+              <a:t>Extract</a:t>
+            </a:r>
+          </a:p>
+          <a:p>
+            <a:pPr algn="ctr"/>
+            <a:r>
+              <a:rPr sz="950" b="0" i="0">
+                <a:solidFill>
+                  <a:srgbClr val="52514E"/>
+                </a:solidFill>
+                <a:latin typeface="Segoe UI"/>
+              </a:rPr>
+              <a:t>llm-wiki compiles it into wiki/ pages: criteria, process, guides</a:t>
+            </a:r>
+          </a:p>
+        </p:txBody>
+      </p:sp>
+      <p:sp>
+        <p:nvSpPr>
+          <p:cNvPr id="33" name="Pipeline Arrow 2"/>
+          <p:cNvSpPr txBox="1"/>
+          <p:nvPr/>
+        </p:nvSpPr>
+        <p:spPr>
+          <a:xfrm>
+            <a:off x="5721520" y="2425780"/>
+            <a:ext cx="350000" cy="365760"/>
+          </a:xfrm>
+          <a:prstGeom prst="rect">
+            <a:avLst/>
+          </a:prstGeom>
+          <a:noFill/>
+        </p:spPr>
+        <p:txBody>
+          <a:bodyPr wrap="square" lIns="0" tIns="0" rIns="0" bIns="0" anchor="ctr">
+            <a:spAutoFit/>
+          </a:bodyPr>
+          <a:lstStyle/>
+          <a:p>
+            <a:pPr algn="ctr"/>
+            <a:r>
+              <a:rPr sz="1800" b="0">
+                <a:solidFill>
+                  <a:srgbClr val="898781"/>
+                </a:solidFill>
+                <a:latin typeface="Segoe UI"/>
+              </a:rPr>
+              <a:t>→</a:t>
+            </a:r>
+          </a:p>
+        </p:txBody>
+      </p:sp>
+      <p:sp>
+        <p:nvSpPr>
+          <p:cNvPr id="34" name="Pipeline Box 3"/>
           <p:cNvSpPr/>
           <p:nvPr/>
         </p:nvSpPr>
         <p:spPr>
           <a:xfrm>
-            <a:off x="6054294" y="2369872"/>
-            <a:ext cx="2440000" cy="2842216"/>
+            <a:off x="6071520" y="1900000"/>
+            <a:ext cx="2320000" cy="1417320"/>
           </a:xfrm>
           <a:prstGeom prst="roundRect">
             <a:avLst>
@@ -6512,7 +7078,7 @@
             </a:avLst>
           </a:prstGeom>
           <a:solidFill>
-            <a:srgbClr val="F0EFEC"/>
+            <a:srgbClr val="CDE2FB"/>
           </a:solidFill>
           <a:ln>
             <a:noFill/>
@@ -6537,29 +7103,41 @@
           <a:bodyPr wrap="square" tIns="54864" bIns="54864" rtlCol="0" anchor="ctr"/>
           <a:lstStyle/>
           <a:p>
-            <a:pPr algn="just"/>
-            <a:r>
-              <a:rPr sz="1200" b="0" dirty="0">
+            <a:pPr algn="ctr"/>
+            <a:r>
+              <a:rPr sz="1250" b="1" i="0">
                 <a:solidFill>
                   <a:srgbClr val="0B0B0B"/>
                 </a:solidFill>
-                <a:latin typeface="Consolas"/>
-              </a:rPr>
-              <a:t>Act as a research administration expert. Based on a process where pre-award grant writing is heavily automated, help me outline a strategic roadmap for our institutional support team to shift focus toward high-value human tasks like consortium building and impact strategy.</a:t>
-            </a:r>
-          </a:p>
-        </p:txBody>
-      </p:sp>
-      <p:sp>
-        <p:nvSpPr>
-          <p:cNvPr id="7" name="TextBox 6"/>
+                <a:latin typeface="Segoe UI Semibold"/>
+              </a:rPr>
+              <a:t>Skill</a:t>
+            </a:r>
+          </a:p>
+          <a:p>
+            <a:pPr algn="ctr"/>
+            <a:r>
+              <a:rPr sz="950" b="0" i="0">
+                <a:solidFill>
+                  <a:srgbClr val="52514E"/>
+                </a:solidFill>
+                <a:latin typeface="Segoe UI"/>
+              </a:rPr>
+              <a:t>packaged as SKILL.md, runs on demand</a:t>
+            </a:r>
+          </a:p>
+        </p:txBody>
+      </p:sp>
+      <p:sp>
+        <p:nvSpPr>
+          <p:cNvPr id="35" name="Pipeline Arrow 3"/>
           <p:cNvSpPr txBox="1"/>
           <p:nvPr/>
         </p:nvSpPr>
         <p:spPr>
           <a:xfrm>
-            <a:off x="731520" y="5303520"/>
-            <a:ext cx="10424160" cy="365760"/>
+            <a:off x="8391520" y="2425780"/>
+            <a:ext cx="350000" cy="365760"/>
           </a:xfrm>
           <a:prstGeom prst="rect">
             <a:avLst/>
@@ -6567,149 +7145,47 @@
           <a:noFill/>
         </p:spPr>
         <p:txBody>
-          <a:bodyPr wrap="square" lIns="0" tIns="0" rIns="0" bIns="0">
+          <a:bodyPr wrap="square" lIns="0" tIns="0" rIns="0" bIns="0" anchor="ctr">
             <a:spAutoFit/>
           </a:bodyPr>
           <a:lstStyle/>
           <a:p>
-            <a:r>
-              <a:rPr sz="1200" b="0">
+            <a:pPr algn="ctr"/>
+            <a:r>
+              <a:rPr sz="1800" b="0">
                 <a:solidFill>
                   <a:srgbClr val="898781"/>
                 </a:solidFill>
                 <a:latin typeface="Segoe UI"/>
               </a:rPr>
-              <a:t>First three: Mads Lykke Berggreen, EARMA AI community.</a:t>
-            </a:r>
-          </a:p>
-        </p:txBody>
-      </p:sp>
-      <p:sp>
-        <p:nvSpPr>
-          <p:cNvPr id="8" name="TextBox 7"/>
-          <p:cNvSpPr txBox="1"/>
-          <p:nvPr/>
-        </p:nvSpPr>
-        <p:spPr>
-          <a:xfrm>
-            <a:off x="457200" y="6473952"/>
-            <a:ext cx="8229600" cy="320040"/>
-          </a:xfrm>
-          <a:prstGeom prst="rect">
-            <a:avLst/>
-          </a:prstGeom>
-          <a:noFill/>
-        </p:spPr>
-        <p:txBody>
-          <a:bodyPr wrap="square" lIns="0" tIns="0" rIns="0" bIns="0">
-            <a:spAutoFit/>
-          </a:bodyPr>
-          <a:lstStyle/>
-          <a:p>
-            <a:r>
-              <a:rPr sz="1000" b="0">
-                <a:solidFill>
-                  <a:srgbClr val="898781"/>
-                </a:solidFill>
-                <a:latin typeface="Segoe UI"/>
-              </a:rPr>
-              <a:t>Levels of Using AI in Research</a:t>
-            </a:r>
-          </a:p>
-        </p:txBody>
-      </p:sp>
-      <p:sp>
-        <p:nvSpPr>
-          <p:cNvPr id="9" name="TextBox 8"/>
-          <p:cNvSpPr txBox="1"/>
-          <p:nvPr/>
-        </p:nvSpPr>
-        <p:spPr>
-          <a:xfrm>
-            <a:off x="11430000" y="6473952"/>
-            <a:ext cx="457200" cy="320040"/>
-          </a:xfrm>
-          <a:prstGeom prst="rect">
-            <a:avLst/>
-          </a:prstGeom>
-          <a:noFill/>
-        </p:spPr>
-        <p:txBody>
-          <a:bodyPr wrap="square" lIns="0" tIns="0" rIns="0" bIns="0">
-            <a:spAutoFit/>
-          </a:bodyPr>
-          <a:lstStyle/>
-          <a:p>
-            <a:pPr algn="r"/>
-            <a:r>
-              <a:rPr sz="1000" b="0">
-                <a:solidFill>
-                  <a:srgbClr val="898781"/>
-                </a:solidFill>
-                <a:latin typeface="Segoe UI"/>
-              </a:rPr>
-              <a:t>12</a:t>
-            </a:r>
-          </a:p>
-        </p:txBody>
-      </p:sp>
-      <p:cxnSp>
-        <p:nvCxnSpPr>
-          <p:cNvPr id="10" name="Connector 9"/>
-          <p:cNvCxnSpPr/>
-          <p:nvPr/>
-        </p:nvCxnSpPr>
-        <p:spPr>
-          <a:xfrm>
-            <a:off x="457200" y="6419088"/>
-            <a:ext cx="11274552" cy="0"/>
-          </a:xfrm>
-          <a:prstGeom prst="line">
-            <a:avLst/>
-          </a:prstGeom>
-          <a:ln w="9525">
-            <a:solidFill>
-              <a:srgbClr val="E1E0D9"/>
-            </a:solidFill>
-          </a:ln>
-        </p:spPr>
-        <p:style>
-          <a:lnRef idx="2">
-            <a:schemeClr val="accent1"/>
-          </a:lnRef>
-          <a:fillRef idx="0">
-            <a:schemeClr val="accent1"/>
-          </a:fillRef>
-          <a:effectRef idx="1">
-            <a:schemeClr val="accent1"/>
-          </a:effectRef>
-          <a:fontRef idx="minor">
-            <a:schemeClr val="tx1"/>
-          </a:fontRef>
-        </p:style>
-      </p:cxnSp>
-      <p:sp>
-        <p:nvSpPr>
-          <p:cNvPr id="11" name="Rounded Rectangle 10"/>
+              <a:t>→</a:t>
+            </a:r>
+          </a:p>
+        </p:txBody>
+      </p:sp>
+      <p:sp>
+        <p:nvSpPr>
+          <p:cNvPr id="36" name="Pipeline Box 4"/>
           <p:cNvSpPr/>
           <p:nvPr/>
         </p:nvSpPr>
         <p:spPr>
           <a:xfrm>
-            <a:off x="9838944" y="6583680"/>
-            <a:ext cx="201168" cy="91440"/>
+            <a:off x="8741520" y="1900000"/>
+            <a:ext cx="2320000" cy="1417320"/>
           </a:xfrm>
           <a:prstGeom prst="roundRect">
             <a:avLst>
-              <a:gd name="adj" fmla="val 50000"/>
+              <a:gd name="adj" fmla="val 10000"/>
             </a:avLst>
           </a:prstGeom>
           <a:solidFill>
-            <a:srgbClr val="2A78D6"/>
+            <a:srgbClr val="F9DACC"/>
           </a:solidFill>
           <a:ln>
             <a:noFill/>
           </a:ln>
+          <a:effectLst/>
         </p:spPr>
         <p:style>
           <a:lnRef idx="1">
@@ -6726,300 +7202,44 @@
           </a:fontRef>
         </p:style>
         <p:txBody>
-          <a:bodyPr rtlCol="0" anchor="ctr"/>
+          <a:bodyPr wrap="square" tIns="54864" bIns="54864" rtlCol="0" anchor="ctr"/>
           <a:lstStyle/>
           <a:p>
             <a:pPr algn="ctr"/>
-            <a:endParaRPr/>
-          </a:p>
-        </p:txBody>
-      </p:sp>
-      <p:sp>
-        <p:nvSpPr>
-          <p:cNvPr id="12" name="Rounded Rectangle 11"/>
-          <p:cNvSpPr/>
-          <p:nvPr/>
-        </p:nvSpPr>
-        <p:spPr>
-          <a:xfrm>
-            <a:off x="10085832" y="6583680"/>
-            <a:ext cx="201168" cy="91440"/>
-          </a:xfrm>
-          <a:prstGeom prst="roundRect">
-            <a:avLst>
-              <a:gd name="adj" fmla="val 50000"/>
-            </a:avLst>
-          </a:prstGeom>
-          <a:solidFill>
-            <a:srgbClr val="2A78D6"/>
-          </a:solidFill>
-          <a:ln>
-            <a:noFill/>
-          </a:ln>
-        </p:spPr>
-        <p:style>
-          <a:lnRef idx="1">
-            <a:schemeClr val="accent1"/>
-          </a:lnRef>
-          <a:fillRef idx="3">
-            <a:schemeClr val="accent1"/>
-          </a:fillRef>
-          <a:effectRef idx="2">
-            <a:schemeClr val="accent1"/>
-          </a:effectRef>
-          <a:fontRef idx="minor">
-            <a:schemeClr val="lt1"/>
-          </a:fontRef>
-        </p:style>
-        <p:txBody>
-          <a:bodyPr rtlCol="0" anchor="ctr"/>
-          <a:lstStyle/>
+            <a:r>
+              <a:rPr sz="1250" b="1" i="0">
+                <a:solidFill>
+                  <a:srgbClr val="0B0B0B"/>
+                </a:solidFill>
+                <a:latin typeface="Segoe UI Semibold"/>
+              </a:rPr>
+              <a:t>Better proposal</a:t>
+            </a:r>
+          </a:p>
           <a:p>
             <a:pPr algn="ctr"/>
-            <a:endParaRPr/>
-          </a:p>
-        </p:txBody>
-      </p:sp>
-      <p:sp>
-        <p:nvSpPr>
-          <p:cNvPr id="13" name="Rounded Rectangle 12"/>
-          <p:cNvSpPr/>
-          <p:nvPr/>
-        </p:nvSpPr>
-        <p:spPr>
-          <a:xfrm>
-            <a:off x="10332720" y="6583680"/>
-            <a:ext cx="201168" cy="91440"/>
-          </a:xfrm>
-          <a:prstGeom prst="roundRect">
-            <a:avLst>
-              <a:gd name="adj" fmla="val 50000"/>
-            </a:avLst>
-          </a:prstGeom>
-          <a:solidFill>
-            <a:srgbClr val="2A78D6"/>
-          </a:solidFill>
-          <a:ln>
-            <a:noFill/>
-          </a:ln>
-        </p:spPr>
-        <p:style>
-          <a:lnRef idx="1">
-            <a:schemeClr val="accent1"/>
-          </a:lnRef>
-          <a:fillRef idx="3">
-            <a:schemeClr val="accent1"/>
-          </a:fillRef>
-          <a:effectRef idx="2">
-            <a:schemeClr val="accent1"/>
-          </a:effectRef>
-          <a:fontRef idx="minor">
-            <a:schemeClr val="lt1"/>
-          </a:fontRef>
-        </p:style>
-        <p:txBody>
-          <a:bodyPr rtlCol="0" anchor="ctr"/>
-          <a:lstStyle/>
-          <a:p>
-            <a:pPr algn="ctr"/>
-            <a:endParaRPr/>
-          </a:p>
-        </p:txBody>
-      </p:sp>
-      <p:sp>
-        <p:nvSpPr>
-          <p:cNvPr id="14" name="Rounded Rectangle 13"/>
-          <p:cNvSpPr/>
-          <p:nvPr/>
-        </p:nvSpPr>
-        <p:spPr>
-          <a:xfrm>
-            <a:off x="10579608" y="6583680"/>
-            <a:ext cx="201168" cy="91440"/>
-          </a:xfrm>
-          <a:prstGeom prst="roundRect">
-            <a:avLst>
-              <a:gd name="adj" fmla="val 50000"/>
-            </a:avLst>
-          </a:prstGeom>
-          <a:solidFill>
-            <a:srgbClr val="2A78D6"/>
-          </a:solidFill>
-          <a:ln>
-            <a:noFill/>
-          </a:ln>
-        </p:spPr>
-        <p:style>
-          <a:lnRef idx="1">
-            <a:schemeClr val="accent1"/>
-          </a:lnRef>
-          <a:fillRef idx="3">
-            <a:schemeClr val="accent1"/>
-          </a:fillRef>
-          <a:effectRef idx="2">
-            <a:schemeClr val="accent1"/>
-          </a:effectRef>
-          <a:fontRef idx="minor">
-            <a:schemeClr val="lt1"/>
-          </a:fontRef>
-        </p:style>
-        <p:txBody>
-          <a:bodyPr rtlCol="0" anchor="ctr"/>
-          <a:lstStyle/>
-          <a:p>
-            <a:pPr algn="ctr"/>
-            <a:endParaRPr/>
-          </a:p>
-        </p:txBody>
-      </p:sp>
-      <p:sp>
-        <p:nvSpPr>
-          <p:cNvPr id="15" name="Rounded Rectangle 14"/>
-          <p:cNvSpPr/>
-          <p:nvPr/>
-        </p:nvSpPr>
-        <p:spPr>
-          <a:xfrm>
-            <a:off x="10826496" y="6583680"/>
-            <a:ext cx="201168" cy="91440"/>
-          </a:xfrm>
-          <a:prstGeom prst="roundRect">
-            <a:avLst>
-              <a:gd name="adj" fmla="val 50000"/>
-            </a:avLst>
-          </a:prstGeom>
-          <a:solidFill>
-            <a:srgbClr val="E1E0D9"/>
-          </a:solidFill>
-          <a:ln>
-            <a:noFill/>
-          </a:ln>
-        </p:spPr>
-        <p:style>
-          <a:lnRef idx="1">
-            <a:schemeClr val="accent1"/>
-          </a:lnRef>
-          <a:fillRef idx="3">
-            <a:schemeClr val="accent1"/>
-          </a:fillRef>
-          <a:effectRef idx="2">
-            <a:schemeClr val="accent1"/>
-          </a:effectRef>
-          <a:fontRef idx="minor">
-            <a:schemeClr val="lt1"/>
-          </a:fontRef>
-        </p:style>
-        <p:txBody>
-          <a:bodyPr rtlCol="0" anchor="ctr"/>
-          <a:lstStyle/>
-          <a:p>
-            <a:pPr algn="ctr"/>
-            <a:endParaRPr/>
-          </a:p>
-        </p:txBody>
-      </p:sp>
-      <p:sp>
-        <p:nvSpPr>
-          <p:cNvPr id="16" name="Rounded Rectangle 15"/>
-          <p:cNvSpPr/>
-          <p:nvPr/>
-        </p:nvSpPr>
-        <p:spPr>
-          <a:xfrm>
-            <a:off x="11073384" y="6583680"/>
-            <a:ext cx="201168" cy="91440"/>
-          </a:xfrm>
-          <a:prstGeom prst="roundRect">
-            <a:avLst>
-              <a:gd name="adj" fmla="val 50000"/>
-            </a:avLst>
-          </a:prstGeom>
-          <a:solidFill>
-            <a:srgbClr val="E1E0D9"/>
-          </a:solidFill>
-          <a:ln>
-            <a:noFill/>
-          </a:ln>
-        </p:spPr>
-        <p:style>
-          <a:lnRef idx="1">
-            <a:schemeClr val="accent1"/>
-          </a:lnRef>
-          <a:fillRef idx="3">
-            <a:schemeClr val="accent1"/>
-          </a:fillRef>
-          <a:effectRef idx="2">
-            <a:schemeClr val="accent1"/>
-          </a:effectRef>
-          <a:fontRef idx="minor">
-            <a:schemeClr val="lt1"/>
-          </a:fontRef>
-        </p:style>
-        <p:txBody>
-          <a:bodyPr rtlCol="0" anchor="ctr"/>
-          <a:lstStyle/>
-          <a:p>
-            <a:pPr algn="ctr"/>
-            <a:endParaRPr/>
-          </a:p>
-        </p:txBody>
-      </p:sp>
-      <p:sp>
-        <p:nvSpPr>
-          <p:cNvPr id="17" name="Rounded Rectangle 16"/>
-          <p:cNvSpPr/>
-          <p:nvPr/>
-        </p:nvSpPr>
-        <p:spPr>
-          <a:xfrm>
-            <a:off x="11320272" y="6583680"/>
-            <a:ext cx="201168" cy="91440"/>
-          </a:xfrm>
-          <a:prstGeom prst="roundRect">
-            <a:avLst>
-              <a:gd name="adj" fmla="val 50000"/>
-            </a:avLst>
-          </a:prstGeom>
-          <a:solidFill>
-            <a:srgbClr val="E1E0D9"/>
-          </a:solidFill>
-          <a:ln>
-            <a:noFill/>
-          </a:ln>
-        </p:spPr>
-        <p:style>
-          <a:lnRef idx="1">
-            <a:schemeClr val="accent1"/>
-          </a:lnRef>
-          <a:fillRef idx="3">
-            <a:schemeClr val="accent1"/>
-          </a:fillRef>
-          <a:effectRef idx="2">
-            <a:schemeClr val="accent1"/>
-          </a:effectRef>
-          <a:fontRef idx="minor">
-            <a:schemeClr val="lt1"/>
-          </a:fontRef>
-        </p:style>
-        <p:txBody>
-          <a:bodyPr rtlCol="0" anchor="ctr"/>
-          <a:lstStyle/>
-          <a:p>
-            <a:pPr algn="ctr"/>
-            <a:endParaRPr/>
-          </a:p>
-        </p:txBody>
-      </p:sp>
-      <p:sp>
-        <p:nvSpPr>
-          <p:cNvPr id="18" name="TextBox 17"/>
+            <a:r>
+              <a:rPr sz="950" b="0" i="0">
+                <a:solidFill>
+                  <a:srgbClr val="52514E"/>
+                </a:solidFill>
+                <a:latin typeface="Segoe UI"/>
+              </a:rPr>
+              <a:t>checked and scored before it reaches a panel</a:t>
+            </a:r>
+          </a:p>
+        </p:txBody>
+      </p:sp>
+      <p:sp>
+        <p:nvSpPr>
+          <p:cNvPr id="37" name="TextBox 36"/>
           <p:cNvSpPr txBox="1"/>
           <p:nvPr/>
         </p:nvSpPr>
         <p:spPr>
           <a:xfrm>
-            <a:off x="8375904" y="6473952"/>
-            <a:ext cx="1371600" cy="274320"/>
+            <a:off x="731520" y="1350000"/>
+            <a:ext cx="10424160" cy="292388"/>
           </a:xfrm>
           <a:prstGeom prst="rect">
             <a:avLst/>
@@ -7027,34 +7247,66 @@
           <a:noFill/>
         </p:spPr>
         <p:txBody>
-          <a:bodyPr wrap="square" lIns="0" tIns="0" rIns="0" bIns="0">
+          <a:bodyPr wrap="square">
             <a:spAutoFit/>
           </a:bodyPr>
           <a:lstStyle/>
           <a:p>
-            <a:pPr algn="r"/>
-            <a:r>
-              <a:rPr sz="800" b="1">
+            <a:r>
+              <a:rPr sz="1300" b="0" dirty="0">
                 <a:solidFill>
                   <a:srgbClr val="898781"/>
                 </a:solidFill>
                 <a:latin typeface="Segoe UI"/>
               </a:rPr>
-              <a:t>LEVEL 4 / 7</a:t>
-            </a:r>
-          </a:p>
-        </p:txBody>
-      </p:sp>
-      <p:sp>
-        <p:nvSpPr>
-          <p:cNvPr id="19" name="TextBox 18"/>
+              <a:t>Every level from this talk, chained on one funder: raw files become a searchable knowledge base, </a:t>
+            </a:r>
+            <a:r>
+              <a:rPr lang="nl-BE" sz="1300" b="0" dirty="0" err="1">
+                <a:solidFill>
+                  <a:srgbClr val="898781"/>
+                </a:solidFill>
+                <a:latin typeface="Segoe UI"/>
+              </a:rPr>
+              <a:t>then</a:t>
+            </a:r>
+            <a:r>
+              <a:rPr lang="nl-BE" sz="1300" b="0" dirty="0">
+                <a:solidFill>
+                  <a:srgbClr val="898781"/>
+                </a:solidFill>
+                <a:latin typeface="Segoe UI"/>
+              </a:rPr>
+              <a:t> a</a:t>
+            </a:r>
+            <a:r>
+              <a:rPr lang="en-US" sz="1300" b="0" dirty="0">
+                <a:solidFill>
+                  <a:srgbClr val="898781"/>
+                </a:solidFill>
+                <a:latin typeface="Segoe UI"/>
+              </a:rPr>
+              <a:t> skill</a:t>
+            </a:r>
+            <a:endParaRPr sz="1300" b="0" dirty="0">
+              <a:solidFill>
+                <a:srgbClr val="898781"/>
+              </a:solidFill>
+              <a:latin typeface="Segoe UI"/>
+            </a:endParaRPr>
+          </a:p>
+        </p:txBody>
+      </p:sp>
+      <p:sp>
+        <p:nvSpPr>
+          <p:cNvPr id="38" name="TextBox 37"/>
           <p:cNvSpPr txBox="1"/>
           <p:nvPr/>
         </p:nvSpPr>
         <p:spPr>
           <a:xfrm>
-            <a:off x="731520" y="1519480"/>
-            <a:ext cx="2440000" cy="274320"/>
+            <a:off x="731520" y="3540000"/>
+            <a:ext cx="10424160" cy="274320"/>
           </a:xfrm>
           <a:prstGeom prst="rect">
             <a:avLst/>
@@ -7068,27 +7320,131 @@
           <a:lstStyle/>
           <a:p>
             <a:r>
-              <a:rPr sz="1100" b="1">
+              <a:rPr sz="1200" b="1">
                 <a:solidFill>
                   <a:srgbClr val="2A78D6"/>
                 </a:solidFill>
                 <a:latin typeface="Segoe UI Semibold"/>
               </a:rPr>
-              <a:t>DECONSTRUCT THE CALL</a:t>
-            </a:r>
-          </a:p>
-        </p:txBody>
-      </p:sp>
-      <p:sp>
-        <p:nvSpPr>
-          <p:cNvPr id="20" name="TextBox 19"/>
+              <a:t>THE TWO SKILLS</a:t>
+            </a:r>
+          </a:p>
+        </p:txBody>
+      </p:sp>
+      <p:sp>
+        <p:nvSpPr>
+          <p:cNvPr id="39" name="TextBox 38"/>
           <p:cNvSpPr txBox="1"/>
           <p:nvPr/>
         </p:nvSpPr>
         <p:spPr>
           <a:xfrm>
-            <a:off x="3392907" y="1519480"/>
-            <a:ext cx="2440000" cy="274320"/>
+            <a:off x="731520" y="3880000"/>
+            <a:ext cx="10424160" cy="500000"/>
+          </a:xfrm>
+          <a:prstGeom prst="rect">
+            <a:avLst/>
+          </a:prstGeom>
+          <a:noFill/>
+        </p:spPr>
+        <p:txBody>
+          <a:bodyPr wrap="square">
+            <a:spAutoFit/>
+          </a:bodyPr>
+          <a:lstStyle/>
+          <a:p>
+            <a:r>
+              <a:rPr sz="1300" b="1" dirty="0">
+                <a:solidFill>
+                  <a:srgbClr val="0B0B0B"/>
+                </a:solidFill>
+                <a:latin typeface="Consolas"/>
+              </a:rPr>
+              <a:t>/</a:t>
+            </a:r>
+            <a:r>
+              <a:rPr sz="1300" b="1" dirty="0" err="1">
+                <a:solidFill>
+                  <a:srgbClr val="0B0B0B"/>
+                </a:solidFill>
+                <a:latin typeface="Consolas"/>
+              </a:rPr>
+              <a:t>fwo</a:t>
+            </a:r>
+            <a:r>
+              <a:rPr sz="1300" b="1" dirty="0">
+                <a:solidFill>
+                  <a:srgbClr val="0B0B0B"/>
+                </a:solidFill>
+                <a:latin typeface="Consolas"/>
+              </a:rPr>
+              <a:t>-admissibility-check</a:t>
+            </a:r>
+            <a:r>
+              <a:rPr sz="1300" b="0" dirty="0">
+                <a:solidFill>
+                  <a:srgbClr val="52514E"/>
+                </a:solidFill>
+                <a:latin typeface="Segoe UI"/>
+              </a:rPr>
+              <a:t>  the eligibility gate — supervisor role, Junior/Senior, submission limits, budget caps, form completeness — pass/fail before it ever reaches a panel.</a:t>
+            </a:r>
+          </a:p>
+        </p:txBody>
+      </p:sp>
+      <p:sp>
+        <p:nvSpPr>
+          <p:cNvPr id="40" name="TextBox 39"/>
+          <p:cNvSpPr txBox="1"/>
+          <p:nvPr/>
+        </p:nvSpPr>
+        <p:spPr>
+          <a:xfrm>
+            <a:off x="731520" y="4550000"/>
+            <a:ext cx="10424160" cy="550000"/>
+          </a:xfrm>
+          <a:prstGeom prst="rect">
+            <a:avLst/>
+          </a:prstGeom>
+          <a:noFill/>
+        </p:spPr>
+        <p:txBody>
+          <a:bodyPr wrap="square">
+            <a:spAutoFit/>
+          </a:bodyPr>
+          <a:lstStyle/>
+          <a:p>
+            <a:r>
+              <a:rPr sz="1300" b="1">
+                <a:solidFill>
+                  <a:srgbClr val="0B0B0B"/>
+                </a:solidFill>
+                <a:latin typeface="Consolas"/>
+              </a:rPr>
+              <a:t>/fwo-reviewer [INTDIS]</a:t>
+            </a:r>
+            <a:r>
+              <a:rPr sz="1300" b="0">
+                <a:solidFill>
+                  <a:srgbClr val="52514E"/>
+                </a:solidFill>
+                <a:latin typeface="Segoe UI"/>
+              </a:rPr>
+              <a:t>  simulates the panel — scores Team, Originality, Feasibility (and Interdisciplinarity) against FWO's real scoring grid, then lists concrete fixes.</a:t>
+            </a:r>
+          </a:p>
+        </p:txBody>
+      </p:sp>
+      <p:sp>
+        <p:nvSpPr>
+          <p:cNvPr id="41" name="TextBox 40"/>
+          <p:cNvSpPr txBox="1"/>
+          <p:nvPr/>
+        </p:nvSpPr>
+        <p:spPr>
+          <a:xfrm>
+            <a:off x="731520" y="5739208"/>
+            <a:ext cx="10424160" cy="365760"/>
           </a:xfrm>
           <a:prstGeom prst="rect">
             <a:avLst/>
@@ -7102,364 +7458,17 @@
           <a:lstStyle/>
           <a:p>
             <a:r>
-              <a:rPr sz="1100" b="1">
-                <a:solidFill>
-                  <a:srgbClr val="2A78D6"/>
-                </a:solidFill>
-                <a:latin typeface="Segoe UI Semibold"/>
-              </a:rPr>
-              <a:t>PLAIN-LANGUAGE POLISH</a:t>
-            </a:r>
-          </a:p>
-        </p:txBody>
-      </p:sp>
-      <p:sp>
-        <p:nvSpPr>
-          <p:cNvPr id="21" name="TextBox 20"/>
-          <p:cNvSpPr txBox="1"/>
-          <p:nvPr/>
-        </p:nvSpPr>
-        <p:spPr>
-          <a:xfrm>
-            <a:off x="6054294" y="1519480"/>
-            <a:ext cx="2440000" cy="274320"/>
-          </a:xfrm>
-          <a:prstGeom prst="rect">
-            <a:avLst/>
-          </a:prstGeom>
-          <a:noFill/>
-        </p:spPr>
-        <p:txBody>
-          <a:bodyPr wrap="none">
-            <a:spAutoFit/>
-          </a:bodyPr>
-          <a:lstStyle/>
-          <a:p>
-            <a:r>
-              <a:rPr sz="1100" b="1">
-                <a:solidFill>
-                  <a:srgbClr val="2A78D6"/>
-                </a:solidFill>
-                <a:latin typeface="Segoe UI Semibold"/>
-              </a:rPr>
-              <a:t>WORKFLOW AUDIT</a:t>
-            </a:r>
-          </a:p>
-        </p:txBody>
-      </p:sp>
-      <p:sp>
-        <p:nvSpPr>
-          <p:cNvPr id="22" name="TextBox 20"/>
-          <p:cNvSpPr txBox="1"/>
-          <p:nvPr/>
-        </p:nvSpPr>
-        <p:spPr>
-          <a:xfrm>
-            <a:off x="8715681" y="1519480"/>
-            <a:ext cx="2440000" cy="274320"/>
-          </a:xfrm>
-          <a:prstGeom prst="rect">
-            <a:avLst/>
-          </a:prstGeom>
-          <a:noFill/>
-        </p:spPr>
-        <p:txBody>
-          <a:bodyPr wrap="none">
-            <a:spAutoFit/>
-          </a:bodyPr>
-          <a:lstStyle/>
-          <a:p>
-            <a:r>
-              <a:rPr sz="1100" b="1" dirty="0">
-                <a:solidFill>
-                  <a:srgbClr val="2A78D6"/>
-                </a:solidFill>
-                <a:latin typeface="Segoe UI Semibold"/>
-              </a:rPr>
-              <a:t>CONSISTENCY CHECK</a:t>
-            </a:r>
-          </a:p>
-        </p:txBody>
-      </p:sp>
-      <p:sp>
-        <p:nvSpPr>
-          <p:cNvPr id="23" name="Rounded Rectangle 5"/>
-          <p:cNvSpPr/>
-          <p:nvPr/>
-        </p:nvSpPr>
-        <p:spPr>
-          <a:xfrm>
-            <a:off x="8715681" y="2369872"/>
-            <a:ext cx="2440000" cy="2842216"/>
-          </a:xfrm>
-          <a:prstGeom prst="roundRect">
-            <a:avLst>
-              <a:gd name="adj" fmla="val 10000"/>
-            </a:avLst>
-          </a:prstGeom>
-          <a:solidFill>
-            <a:srgbClr val="F0EFEC"/>
-          </a:solidFill>
-          <a:ln>
-            <a:noFill/>
-          </a:ln>
-          <a:effectLst/>
-        </p:spPr>
-        <p:style>
-          <a:lnRef idx="1">
-            <a:schemeClr val="accent1"/>
-          </a:lnRef>
-          <a:fillRef idx="3">
-            <a:schemeClr val="accent1"/>
-          </a:fillRef>
-          <a:effectRef idx="2">
-            <a:schemeClr val="accent1"/>
-          </a:effectRef>
-          <a:fontRef idx="minor">
-            <a:schemeClr val="lt1"/>
-          </a:fontRef>
-        </p:style>
-        <p:txBody>
-          <a:bodyPr wrap="square" tIns="54864" bIns="54864" rtlCol="0" anchor="ctr"/>
-          <a:lstStyle/>
-          <a:p>
-            <a:pPr algn="just"/>
-            <a:r>
-              <a:rPr sz="1200" b="0">
-                <a:solidFill>
-                  <a:srgbClr val="0B0B0B"/>
-                </a:solidFill>
-                <a:latin typeface="Consolas"/>
-              </a:rPr>
-              <a:t>Check this proposal for consistency: fonts and heading styles, table and figure numbering and captions, and section numbering. Then check every reference against [insert citation style, e.g. APA / Vancouver / IEEE] and flag any that don't match — offer to convert the whole list to [insert target style] if I ask.</a:t>
-            </a:r>
-          </a:p>
-        </p:txBody>
-      </p:sp>
-      <p:sp>
-        <p:nvSpPr>
-          <p:cNvPr id="24" name="TextBox 23"/>
-          <p:cNvSpPr txBox="1"/>
-          <p:nvPr/>
-        </p:nvSpPr>
-        <p:spPr>
-          <a:xfrm>
-            <a:off x="731520" y="1839520"/>
-            <a:ext cx="2079230" cy="338554"/>
-          </a:xfrm>
-          <a:prstGeom prst="rect">
-            <a:avLst/>
-          </a:prstGeom>
-          <a:noFill/>
-        </p:spPr>
-        <p:txBody>
-          <a:bodyPr wrap="square" lIns="0" tIns="0" rIns="0" bIns="0">
-            <a:spAutoFit/>
-          </a:bodyPr>
-          <a:lstStyle/>
-          <a:p>
-            <a:pPr algn="just"/>
-            <a:r>
-              <a:rPr sz="1100" b="1" dirty="0">
-                <a:solidFill>
-                  <a:srgbClr val="0B0B0B"/>
+              <a:rPr sz="1250" b="0" dirty="0">
+                <a:solidFill>
+                  <a:srgbClr val="898781"/>
                 </a:solidFill>
                 <a:latin typeface="Segoe UI"/>
               </a:rPr>
-              <a:t>Goal: </a:t>
-            </a:r>
-            <a:r>
-              <a:rPr sz="1100" b="0" dirty="0">
-                <a:solidFill>
-                  <a:srgbClr val="52514E"/>
-                </a:solidFill>
-                <a:latin typeface="Segoe UI"/>
-              </a:rPr>
-              <a:t>Turns a call text into a compliance &amp; KPI checklist.</a:t>
-            </a:r>
-          </a:p>
-        </p:txBody>
-      </p:sp>
-      <p:sp>
-        <p:nvSpPr>
-          <p:cNvPr id="25" name="TextBox 24"/>
-          <p:cNvSpPr txBox="1"/>
-          <p:nvPr/>
-        </p:nvSpPr>
-        <p:spPr>
-          <a:xfrm>
-            <a:off x="3392907" y="1848663"/>
-            <a:ext cx="2250511" cy="338554"/>
-          </a:xfrm>
-          <a:prstGeom prst="rect">
-            <a:avLst/>
-          </a:prstGeom>
-          <a:noFill/>
-        </p:spPr>
-        <p:txBody>
-          <a:bodyPr wrap="square" lIns="0" tIns="0" rIns="0" bIns="0">
-            <a:spAutoFit/>
-          </a:bodyPr>
-          <a:lstStyle/>
-          <a:p>
-            <a:pPr algn="l"/>
-            <a:r>
-              <a:rPr sz="1100" b="1" dirty="0">
-                <a:solidFill>
-                  <a:srgbClr val="0B0B0B"/>
-                </a:solidFill>
-                <a:latin typeface="Segoe UI"/>
-              </a:rPr>
-              <a:t>Goal: </a:t>
-            </a:r>
-            <a:r>
-              <a:rPr sz="1100" b="0" dirty="0">
-                <a:solidFill>
-                  <a:srgbClr val="52514E"/>
-                </a:solidFill>
-                <a:latin typeface="Segoe UI"/>
-              </a:rPr>
-              <a:t>Rewrites jargon so any evaluator can follow it.</a:t>
-            </a:r>
-          </a:p>
-        </p:txBody>
-      </p:sp>
-      <p:sp>
-        <p:nvSpPr>
-          <p:cNvPr id="26" name="TextBox 25"/>
-          <p:cNvSpPr txBox="1"/>
-          <p:nvPr/>
-        </p:nvSpPr>
-        <p:spPr>
-          <a:xfrm>
-            <a:off x="6080760" y="1839520"/>
-            <a:ext cx="2295144" cy="338554"/>
-          </a:xfrm>
-          <a:prstGeom prst="rect">
-            <a:avLst/>
-          </a:prstGeom>
-          <a:noFill/>
-        </p:spPr>
-        <p:txBody>
-          <a:bodyPr wrap="square" lIns="0" tIns="0" rIns="0" bIns="0">
-            <a:spAutoFit/>
-          </a:bodyPr>
-          <a:lstStyle/>
-          <a:p>
-            <a:pPr algn="just"/>
-            <a:r>
-              <a:rPr sz="1100" b="1" dirty="0">
-                <a:solidFill>
-                  <a:srgbClr val="0B0B0B"/>
-                </a:solidFill>
-                <a:latin typeface="Segoe UI"/>
-              </a:rPr>
-              <a:t>Goal: </a:t>
-            </a:r>
-            <a:r>
-              <a:rPr sz="1100" b="0" dirty="0">
-                <a:solidFill>
-                  <a:srgbClr val="52514E"/>
-                </a:solidFill>
-                <a:latin typeface="Segoe UI"/>
-              </a:rPr>
-              <a:t>Shows where automation frees up staff time.</a:t>
-            </a:r>
-          </a:p>
-        </p:txBody>
-      </p:sp>
-      <p:sp>
-        <p:nvSpPr>
-          <p:cNvPr id="27" name="TextBox 26"/>
-          <p:cNvSpPr txBox="1"/>
-          <p:nvPr/>
-        </p:nvSpPr>
-        <p:spPr>
-          <a:xfrm>
-            <a:off x="8715681" y="1839520"/>
-            <a:ext cx="2357703" cy="338554"/>
-          </a:xfrm>
-          <a:prstGeom prst="rect">
-            <a:avLst/>
-          </a:prstGeom>
-          <a:noFill/>
-        </p:spPr>
-        <p:txBody>
-          <a:bodyPr wrap="square" lIns="0" tIns="0" rIns="0" bIns="0">
-            <a:spAutoFit/>
-          </a:bodyPr>
-          <a:lstStyle/>
-          <a:p>
-            <a:pPr algn="just"/>
-            <a:r>
-              <a:rPr sz="1100" b="1" dirty="0">
-                <a:solidFill>
-                  <a:srgbClr val="0B0B0B"/>
-                </a:solidFill>
-                <a:latin typeface="Segoe UI"/>
-              </a:rPr>
-              <a:t>Goal: </a:t>
-            </a:r>
-            <a:r>
-              <a:rPr sz="1100" b="0" dirty="0">
-                <a:solidFill>
-                  <a:srgbClr val="52514E"/>
-                </a:solidFill>
-                <a:latin typeface="Segoe UI"/>
-              </a:rPr>
-              <a:t>Catches formatting and citation-style mismatches.</a:t>
-            </a:r>
-          </a:p>
-        </p:txBody>
-      </p:sp>
-      <p:pic>
-        <p:nvPicPr>
-          <p:cNvPr id="29" name="Picture 28" descr="cris_title_shape59.png"/>
-          <p:cNvPicPr>
-            <a:picLocks noChangeAspect="1"/>
-          </p:cNvPicPr>
-          <p:nvPr/>
-        </p:nvPicPr>
-        <p:blipFill>
-          <a:blip r:embed="rId3"/>
-          <a:stretch>
-            <a:fillRect/>
-          </a:stretch>
-        </p:blipFill>
-        <p:spPr>
-          <a:xfrm>
-            <a:off x="5074920" y="6519672"/>
-            <a:ext cx="771579" cy="182880"/>
-          </a:xfrm>
-          <a:prstGeom prst="rect">
-            <a:avLst/>
-          </a:prstGeom>
-        </p:spPr>
-      </p:pic>
-      <p:pic>
-        <p:nvPicPr>
-          <p:cNvPr id="30" name="Picture 29" descr="image.png"/>
-          <p:cNvPicPr>
-            <a:picLocks noChangeAspect="1"/>
-          </p:cNvPicPr>
-          <p:nvPr/>
-        </p:nvPicPr>
-        <p:blipFill>
-          <a:blip r:embed="rId4"/>
-          <a:stretch>
-            <a:fillRect/>
-          </a:stretch>
-        </p:blipFill>
-        <p:spPr>
-          <a:xfrm>
-            <a:off x="10807293" y="201168"/>
-            <a:ext cx="1051560" cy="1051560"/>
-          </a:xfrm>
-          <a:prstGeom prst="rect">
-            <a:avLst/>
-          </a:prstGeom>
-        </p:spPr>
-      </p:pic>
+              <a:t>Same recipe for any funder — swap the raw sources, and the skill rebuilds itself.</a:t>
+            </a:r>
+          </a:p>
+        </p:txBody>
+      </p:sp>
     </p:spTree>
   </p:cSld>
   <p:clrMapOvr>
@@ -7501,7 +7510,7 @@
         </p:blipFill>
         <p:spPr>
           <a:xfrm>
-            <a:off x="169333" y="76200"/>
+            <a:off x="169333" y="85400"/>
             <a:ext cx="11826400" cy="6687200"/>
           </a:xfrm>
           <a:prstGeom prst="rect">
@@ -7552,7 +7561,7 @@
         <p:spPr>
           <a:xfrm>
             <a:off x="640080" y="502920"/>
-            <a:ext cx="10881360" cy="822960"/>
+            <a:ext cx="10881360" cy="461665"/>
           </a:xfrm>
           <a:prstGeom prst="rect">
             <a:avLst/>
@@ -7566,82 +7575,56 @@
           <a:lstStyle/>
           <a:p>
             <a:r>
-              <a:rPr sz="3000" b="1">
+              <a:rPr lang="nl-BE" sz="3000" b="1" dirty="0" err="1">
                 <a:solidFill>
                   <a:srgbClr val="0B0B0B"/>
                 </a:solidFill>
                 <a:latin typeface="Segoe UI Semibold"/>
               </a:rPr>
-              <a:t>All 9 skills, in one place</a:t>
-            </a:r>
-          </a:p>
-        </p:txBody>
-      </p:sp>
-      <p:sp>
-        <p:nvSpPr>
-          <p:cNvPr id="4" name="TextBox 3"/>
-          <p:cNvSpPr txBox="1"/>
-          <p:nvPr/>
-        </p:nvSpPr>
-        <p:spPr>
-          <a:xfrm>
-            <a:off x="731520" y="1325880"/>
-            <a:ext cx="10424160" cy="400110"/>
-          </a:xfrm>
-          <a:prstGeom prst="rect">
-            <a:avLst/>
-          </a:prstGeom>
-          <a:noFill/>
-        </p:spPr>
-        <p:txBody>
-          <a:bodyPr wrap="square" lIns="0" tIns="0" rIns="0" bIns="0">
-            <a:spAutoFit/>
-          </a:bodyPr>
-          <a:lstStyle/>
-          <a:p>
-            <a:r>
-              <a:rPr sz="1300" b="0" dirty="0">
-                <a:solidFill>
-                  <a:srgbClr val="898781"/>
-                </a:solidFill>
-                <a:latin typeface="Segoe UI"/>
-              </a:rPr>
-              <a:t>Everything from Level 4, listed with what each one does — install any of them, or copy the prompt straight from the repo.</a:t>
-            </a:r>
-          </a:p>
-        </p:txBody>
-      </p:sp>
-      <p:sp>
-        <p:nvSpPr>
-          <p:cNvPr id="5" name="TextBox 4"/>
-          <p:cNvSpPr txBox="1"/>
-          <p:nvPr/>
-        </p:nvSpPr>
-        <p:spPr>
-          <a:xfrm>
-            <a:off x="731520" y="1965960"/>
-            <a:ext cx="5029200" cy="184666"/>
-          </a:xfrm>
-          <a:prstGeom prst="rect">
-            <a:avLst/>
-          </a:prstGeom>
-          <a:noFill/>
-        </p:spPr>
-        <p:txBody>
-          <a:bodyPr wrap="square" lIns="0" tIns="0" rIns="0" bIns="0">
-            <a:spAutoFit/>
-          </a:bodyPr>
-          <a:lstStyle/>
-          <a:p>
-            <a:r>
-              <a:rPr sz="1200" b="1" dirty="0">
-                <a:solidFill>
-                  <a:srgbClr val="2A78D6"/>
+              <a:t>All</a:t>
+            </a:r>
+            <a:r>
+              <a:rPr lang="nl-BE" sz="3000" b="1" dirty="0">
+                <a:solidFill>
+                  <a:srgbClr val="0B0B0B"/>
                 </a:solidFill>
                 <a:latin typeface="Segoe UI Semibold"/>
               </a:rPr>
-              <a:t>SKILLS 1–5</a:t>
-            </a:r>
+              <a:t> research skills in </a:t>
+            </a:r>
+            <a:r>
+              <a:rPr lang="nl-BE" sz="3000" b="1" dirty="0" err="1">
+                <a:solidFill>
+                  <a:srgbClr val="0B0B0B"/>
+                </a:solidFill>
+                <a:latin typeface="Segoe UI Semibold"/>
+              </a:rPr>
+              <a:t>the</a:t>
+            </a:r>
+            <a:r>
+              <a:rPr lang="nl-BE" sz="3000" b="1" dirty="0">
+                <a:solidFill>
+                  <a:srgbClr val="0B0B0B"/>
+                </a:solidFill>
+                <a:latin typeface="Segoe UI Semibold"/>
+              </a:rPr>
+              <a:t> </a:t>
+            </a:r>
+            <a:r>
+              <a:rPr lang="nl-BE" sz="3000" b="1" dirty="0" err="1">
+                <a:solidFill>
+                  <a:srgbClr val="0B0B0B"/>
+                </a:solidFill>
+                <a:latin typeface="Segoe UI Semibold"/>
+              </a:rPr>
+              <a:t>repo</a:t>
+            </a:r>
+            <a:endParaRPr sz="3000" b="1" dirty="0">
+              <a:solidFill>
+                <a:srgbClr val="0B0B0B"/>
+              </a:solidFill>
+              <a:latin typeface="Segoe UI Semibold"/>
+            </a:endParaRPr>
           </a:p>
         </p:txBody>
       </p:sp>
@@ -7653,8 +7636,8 @@
         </p:nvSpPr>
         <p:spPr>
           <a:xfrm>
-            <a:off x="731520" y="2331720"/>
-            <a:ext cx="5029200" cy="3657600"/>
+            <a:off x="640080" y="1507492"/>
+            <a:ext cx="7854604" cy="4281126"/>
           </a:xfrm>
           <a:prstGeom prst="roundRect">
             <a:avLst>
@@ -7698,7 +7681,7 @@
               </a:spcAft>
             </a:pPr>
             <a:r>
-              <a:rPr sz="1100" b="1">
+              <a:rPr sz="1100" b="1" dirty="0">
                 <a:solidFill>
                   <a:srgbClr val="0B0B0B"/>
                 </a:solidFill>
@@ -7707,7 +7690,7 @@
               <a:t>/grant-evaluator [funder]</a:t>
             </a:r>
             <a:r>
-              <a:rPr sz="1100" b="0">
+              <a:rPr sz="1100" b="0" dirty="0">
                 <a:solidFill>
                   <a:srgbClr val="0B0B0B"/>
                 </a:solidFill>
@@ -7726,7 +7709,7 @@
               </a:spcAft>
             </a:pPr>
             <a:r>
-              <a:rPr sz="1100" b="1">
+              <a:rPr sz="1100" b="1" dirty="0">
                 <a:solidFill>
                   <a:srgbClr val="0B0B0B"/>
                 </a:solidFill>
@@ -7735,7 +7718,7 @@
               <a:t>/bias-omission-check</a:t>
             </a:r>
             <a:r>
-              <a:rPr sz="1100" b="0">
+              <a:rPr sz="1100" b="0" dirty="0">
                 <a:solidFill>
                   <a:srgbClr val="0B0B0B"/>
                 </a:solidFill>
@@ -7754,7 +7737,7 @@
               </a:spcAft>
             </a:pPr>
             <a:r>
-              <a:rPr sz="1100" b="1">
+              <a:rPr sz="1100" b="1" dirty="0">
                 <a:solidFill>
                   <a:srgbClr val="0B0B0B"/>
                 </a:solidFill>
@@ -7763,7 +7746,7 @@
               <a:t>/grill-me-for-research [n]</a:t>
             </a:r>
             <a:r>
-              <a:rPr sz="1100" b="0">
+              <a:rPr sz="1100" b="0" dirty="0">
                 <a:solidFill>
                   <a:srgbClr val="0B0B0B"/>
                 </a:solidFill>
@@ -7782,7 +7765,7 @@
               </a:spcAft>
             </a:pPr>
             <a:r>
-              <a:rPr sz="1100" b="1">
+              <a:rPr sz="1100" b="1" dirty="0">
                 <a:solidFill>
                   <a:srgbClr val="0B0B0B"/>
                 </a:solidFill>
@@ -7791,7 +7774,7 @@
               <a:t>/deconstruct-call [topic]</a:t>
             </a:r>
             <a:r>
-              <a:rPr sz="1100" b="0">
+              <a:rPr sz="1100" b="0" dirty="0">
                 <a:solidFill>
                   <a:srgbClr val="0B0B0B"/>
                 </a:solidFill>
@@ -7810,13 +7793,360 @@
               </a:spcAft>
             </a:pPr>
             <a:r>
+              <a:rPr sz="1100" b="1" dirty="0">
+                <a:solidFill>
+                  <a:srgbClr val="0B0B0B"/>
+                </a:solidFill>
+                <a:latin typeface="Consolas"/>
+              </a:rPr>
+              <a:t>/plain-language-polish</a:t>
+            </a:r>
+            <a:r>
+              <a:rPr sz="1100" b="0" dirty="0">
+                <a:solidFill>
+                  <a:srgbClr val="0B0B0B"/>
+                </a:solidFill>
+                <a:latin typeface="Consolas"/>
+              </a:rPr>
+              <a:t>  Rewrites jargon for a diverse evaluation board.</a:t>
+            </a:r>
+            <a:endParaRPr lang="nl-BE" sz="1100" b="0" dirty="0">
+              <a:solidFill>
+                <a:srgbClr val="0B0B0B"/>
+              </a:solidFill>
+              <a:latin typeface="Consolas"/>
+            </a:endParaRPr>
+          </a:p>
+          <a:p>
+            <a:pPr>
+              <a:lnSpc>
+                <a:spcPct val="110000"/>
+              </a:lnSpc>
+              <a:spcAft>
+                <a:spcPts val="700"/>
+              </a:spcAft>
+            </a:pPr>
+            <a:r>
+              <a:rPr lang="nl-BE" sz="1100" b="1" dirty="0">
+                <a:solidFill>
+                  <a:srgbClr val="0B0B0B"/>
+                </a:solidFill>
+                <a:latin typeface="Consolas"/>
+              </a:rPr>
+              <a:t>/</a:t>
+            </a:r>
+            <a:r>
+              <a:rPr lang="nl-BE" sz="1100" b="1" dirty="0" err="1">
+                <a:solidFill>
+                  <a:srgbClr val="0B0B0B"/>
+                </a:solidFill>
+                <a:latin typeface="Consolas"/>
+              </a:rPr>
+              <a:t>consistency</a:t>
+            </a:r>
+            <a:r>
+              <a:rPr lang="nl-BE" sz="1100" b="1" dirty="0">
+                <a:solidFill>
+                  <a:srgbClr val="0B0B0B"/>
+                </a:solidFill>
+                <a:latin typeface="Consolas"/>
+              </a:rPr>
+              <a:t>-check [style]</a:t>
+            </a:r>
+            <a:r>
+              <a:rPr lang="nl-BE" sz="1100" dirty="0">
+                <a:solidFill>
+                  <a:srgbClr val="0B0B0B"/>
+                </a:solidFill>
+                <a:latin typeface="Consolas"/>
+              </a:rPr>
+              <a:t>  Checks </a:t>
+            </a:r>
+            <a:r>
+              <a:rPr lang="nl-BE" sz="1100" dirty="0" err="1">
+                <a:solidFill>
+                  <a:srgbClr val="0B0B0B"/>
+                </a:solidFill>
+                <a:latin typeface="Consolas"/>
+              </a:rPr>
+              <a:t>formatting</a:t>
+            </a:r>
+            <a:r>
+              <a:rPr lang="nl-BE" sz="1100" dirty="0">
+                <a:solidFill>
+                  <a:srgbClr val="0B0B0B"/>
+                </a:solidFill>
+                <a:latin typeface="Consolas"/>
+              </a:rPr>
+              <a:t> </a:t>
+            </a:r>
+            <a:r>
+              <a:rPr lang="nl-BE" sz="1100" dirty="0" err="1">
+                <a:solidFill>
+                  <a:srgbClr val="0B0B0B"/>
+                </a:solidFill>
+                <a:latin typeface="Consolas"/>
+              </a:rPr>
+              <a:t>and</a:t>
+            </a:r>
+            <a:r>
+              <a:rPr lang="nl-BE" sz="1100" dirty="0">
+                <a:solidFill>
+                  <a:srgbClr val="0B0B0B"/>
+                </a:solidFill>
+                <a:latin typeface="Consolas"/>
+              </a:rPr>
+              <a:t> </a:t>
+            </a:r>
+            <a:r>
+              <a:rPr lang="nl-BE" sz="1100" dirty="0" err="1">
+                <a:solidFill>
+                  <a:srgbClr val="0B0B0B"/>
+                </a:solidFill>
+                <a:latin typeface="Consolas"/>
+              </a:rPr>
+              <a:t>citation</a:t>
+            </a:r>
+            <a:r>
+              <a:rPr lang="nl-BE" sz="1100" dirty="0">
+                <a:solidFill>
+                  <a:srgbClr val="0B0B0B"/>
+                </a:solidFill>
+                <a:latin typeface="Consolas"/>
+              </a:rPr>
+              <a:t>-style </a:t>
+            </a:r>
+            <a:r>
+              <a:rPr lang="nl-BE" sz="1100" dirty="0" err="1">
+                <a:solidFill>
+                  <a:srgbClr val="0B0B0B"/>
+                </a:solidFill>
+                <a:latin typeface="Consolas"/>
+              </a:rPr>
+              <a:t>consistency</a:t>
+            </a:r>
+            <a:r>
+              <a:rPr lang="nl-BE" sz="1100" dirty="0">
+                <a:solidFill>
+                  <a:srgbClr val="0B0B0B"/>
+                </a:solidFill>
+                <a:latin typeface="Consolas"/>
+              </a:rPr>
+              <a:t>.</a:t>
+            </a:r>
+          </a:p>
+          <a:p>
+            <a:pPr>
+              <a:lnSpc>
+                <a:spcPct val="110000"/>
+              </a:lnSpc>
+              <a:spcAft>
+                <a:spcPts val="700"/>
+              </a:spcAft>
+            </a:pPr>
+            <a:r>
+              <a:rPr lang="nl-BE" sz="1100" b="1" dirty="0">
+                <a:solidFill>
+                  <a:srgbClr val="0B0B0B"/>
+                </a:solidFill>
+                <a:latin typeface="Consolas"/>
+              </a:rPr>
+              <a:t>/</a:t>
+            </a:r>
+            <a:r>
+              <a:rPr lang="nl-BE" sz="1100" b="1" dirty="0" err="1">
+                <a:solidFill>
+                  <a:srgbClr val="0B0B0B"/>
+                </a:solidFill>
+                <a:latin typeface="Consolas"/>
+              </a:rPr>
+              <a:t>llm</a:t>
+            </a:r>
+            <a:r>
+              <a:rPr lang="nl-BE" sz="1100" b="1" dirty="0">
+                <a:solidFill>
+                  <a:srgbClr val="0B0B0B"/>
+                </a:solidFill>
+                <a:latin typeface="Consolas"/>
+              </a:rPr>
+              <a:t>-wiki [</a:t>
+            </a:r>
+            <a:r>
+              <a:rPr lang="nl-BE" sz="1100" b="1" dirty="0" err="1">
+                <a:solidFill>
+                  <a:srgbClr val="0B0B0B"/>
+                </a:solidFill>
+                <a:latin typeface="Consolas"/>
+              </a:rPr>
+              <a:t>ingest|query|lint</a:t>
+            </a:r>
+            <a:r>
+              <a:rPr lang="nl-BE" sz="1100" b="1" dirty="0">
+                <a:solidFill>
+                  <a:srgbClr val="0B0B0B"/>
+                </a:solidFill>
+                <a:latin typeface="Consolas"/>
+              </a:rPr>
+              <a:t>]</a:t>
+            </a:r>
+            <a:r>
+              <a:rPr lang="nl-BE" sz="1100" dirty="0">
+                <a:solidFill>
+                  <a:srgbClr val="0B0B0B"/>
+                </a:solidFill>
+                <a:latin typeface="Consolas"/>
+              </a:rPr>
+              <a:t>  Persistent </a:t>
+            </a:r>
+            <a:r>
+              <a:rPr lang="nl-BE" sz="1100" dirty="0" err="1">
+                <a:solidFill>
+                  <a:srgbClr val="0B0B0B"/>
+                </a:solidFill>
+                <a:latin typeface="Consolas"/>
+              </a:rPr>
+              <a:t>markdown</a:t>
+            </a:r>
+            <a:r>
+              <a:rPr lang="nl-BE" sz="1100" dirty="0">
+                <a:solidFill>
+                  <a:srgbClr val="0B0B0B"/>
+                </a:solidFill>
+                <a:latin typeface="Consolas"/>
+              </a:rPr>
+              <a:t> </a:t>
+            </a:r>
+            <a:r>
+              <a:rPr lang="nl-BE" sz="1100" dirty="0" err="1">
+                <a:solidFill>
+                  <a:srgbClr val="0B0B0B"/>
+                </a:solidFill>
+                <a:latin typeface="Consolas"/>
+              </a:rPr>
+              <a:t>knowledge</a:t>
+            </a:r>
+            <a:r>
+              <a:rPr lang="nl-BE" sz="1100" dirty="0">
+                <a:solidFill>
+                  <a:srgbClr val="0B0B0B"/>
+                </a:solidFill>
+                <a:latin typeface="Consolas"/>
+              </a:rPr>
+              <a:t> wiki </a:t>
+            </a:r>
+            <a:r>
+              <a:rPr lang="nl-BE" sz="1100" dirty="0" err="1">
+                <a:solidFill>
+                  <a:srgbClr val="0B0B0B"/>
+                </a:solidFill>
+                <a:latin typeface="Consolas"/>
+              </a:rPr>
+              <a:t>instead</a:t>
+            </a:r>
+            <a:r>
+              <a:rPr lang="nl-BE" sz="1100" dirty="0">
+                <a:solidFill>
+                  <a:srgbClr val="0B0B0B"/>
+                </a:solidFill>
+                <a:latin typeface="Consolas"/>
+              </a:rPr>
+              <a:t> of re-</a:t>
+            </a:r>
+            <a:r>
+              <a:rPr lang="nl-BE" sz="1100" dirty="0" err="1">
+                <a:solidFill>
+                  <a:srgbClr val="0B0B0B"/>
+                </a:solidFill>
+                <a:latin typeface="Consolas"/>
+              </a:rPr>
+              <a:t>searching</a:t>
+            </a:r>
+            <a:r>
+              <a:rPr lang="nl-BE" sz="1100" dirty="0">
+                <a:solidFill>
+                  <a:srgbClr val="0B0B0B"/>
+                </a:solidFill>
+                <a:latin typeface="Consolas"/>
+              </a:rPr>
+              <a:t> </a:t>
+            </a:r>
+            <a:r>
+              <a:rPr lang="nl-BE" sz="1100" dirty="0" err="1">
+                <a:solidFill>
+                  <a:srgbClr val="0B0B0B"/>
+                </a:solidFill>
+                <a:latin typeface="Consolas"/>
+              </a:rPr>
+              <a:t>raw</a:t>
+            </a:r>
+            <a:r>
+              <a:rPr lang="nl-BE" sz="1100" dirty="0">
+                <a:solidFill>
+                  <a:srgbClr val="0B0B0B"/>
+                </a:solidFill>
+                <a:latin typeface="Consolas"/>
+              </a:rPr>
+              <a:t> sources.</a:t>
+            </a:r>
+          </a:p>
+          <a:p>
+            <a:pPr>
+              <a:lnSpc>
+                <a:spcPct val="110000"/>
+              </a:lnSpc>
+              <a:spcAft>
+                <a:spcPts val="700"/>
+              </a:spcAft>
+            </a:pPr>
+            <a:endParaRPr lang="nl-BE" sz="1100" b="0" dirty="0">
+              <a:solidFill>
+                <a:srgbClr val="0B0B0B"/>
+              </a:solidFill>
+              <a:latin typeface="Consolas"/>
+            </a:endParaRPr>
+          </a:p>
+          <a:p>
+            <a:pPr>
+              <a:lnSpc>
+                <a:spcPct val="110000"/>
+              </a:lnSpc>
+              <a:spcAft>
+                <a:spcPts val="700"/>
+              </a:spcAft>
+            </a:pPr>
+            <a:r>
+              <a:rPr lang="nl-BE" sz="1100" dirty="0">
+                <a:solidFill>
+                  <a:srgbClr val="0B0B0B"/>
+                </a:solidFill>
+                <a:latin typeface="Consolas"/>
+              </a:rPr>
+              <a:t>Extra — more prompts worth testing:</a:t>
+            </a:r>
+            <a:endParaRPr lang="nl-BE" sz="1100" b="0" dirty="0">
+              <a:solidFill>
+                <a:srgbClr val="0B0B0B"/>
+              </a:solidFill>
+              <a:latin typeface="Consolas"/>
+            </a:endParaRPr>
+          </a:p>
+          <a:p>
+            <a:pPr>
+              <a:lnSpc>
+                <a:spcPct val="110000"/>
+              </a:lnSpc>
+              <a:spcAft>
+                <a:spcPts val="700"/>
+              </a:spcAft>
+            </a:pPr>
+            <a:r>
               <a:rPr sz="1100" b="1">
                 <a:solidFill>
                   <a:srgbClr val="0B0B0B"/>
                 </a:solidFill>
                 <a:latin typeface="Consolas"/>
               </a:rPr>
-              <a:t>/plain-language-polish</a:t>
+              <a:t>Deconstruct the call</a:t>
             </a:r>
             <a:r>
               <a:rPr sz="1100" b="0">
@@ -7825,42 +8155,104 @@
                 </a:solidFill>
                 <a:latin typeface="Consolas"/>
               </a:rPr>
+              <a:t>  Turns a funding call text into a compliance &amp; KPI checklist.</a:t>
+            </a:r>
+          </a:p>
+          <a:p>
+            <a:pPr>
+              <a:lnSpc>
+                <a:spcPct val="110000"/>
+              </a:lnSpc>
+              <a:spcAft>
+                <a:spcPts val="700"/>
+              </a:spcAft>
+            </a:pPr>
+            <a:r>
+              <a:rPr sz="1100" b="1">
+                <a:solidFill>
+                  <a:srgbClr val="0B0B0B"/>
+                </a:solidFill>
+                <a:latin typeface="Consolas"/>
+              </a:rPr>
+              <a:t>Plain-language polish</a:t>
+            </a:r>
+            <a:r>
+              <a:rPr sz="1100" b="0">
+                <a:solidFill>
+                  <a:srgbClr val="0B0B0B"/>
+                </a:solidFill>
+                <a:latin typeface="Consolas"/>
+              </a:rPr>
               <a:t>  Rewrites jargon for a diverse evaluation board.</a:t>
             </a:r>
           </a:p>
-        </p:txBody>
-      </p:sp>
-      <p:sp>
-        <p:nvSpPr>
-          <p:cNvPr id="7" name="TextBox 6"/>
-          <p:cNvSpPr txBox="1"/>
-          <p:nvPr/>
-        </p:nvSpPr>
-        <p:spPr>
-          <a:xfrm>
-            <a:off x="6126480" y="1965960"/>
-            <a:ext cx="5029199" cy="320040"/>
-          </a:xfrm>
-          <a:prstGeom prst="rect">
-            <a:avLst/>
-          </a:prstGeom>
-          <a:noFill/>
-        </p:spPr>
-        <p:txBody>
-          <a:bodyPr wrap="square" lIns="0" tIns="0" rIns="0" bIns="0">
-            <a:spAutoFit/>
-          </a:bodyPr>
-          <a:lstStyle/>
-          <a:p>
-            <a:r>
-              <a:rPr sz="1200" b="1">
-                <a:solidFill>
-                  <a:srgbClr val="2A78D6"/>
-                </a:solidFill>
-                <a:latin typeface="Segoe UI Semibold"/>
-              </a:rPr>
-              <a:t>SKILLS 6–9</a:t>
-            </a:r>
+          <a:p>
+            <a:pPr>
+              <a:lnSpc>
+                <a:spcPct val="110000"/>
+              </a:lnSpc>
+              <a:spcAft>
+                <a:spcPts val="700"/>
+              </a:spcAft>
+            </a:pPr>
+            <a:r>
+              <a:rPr sz="1100" b="1">
+                <a:solidFill>
+                  <a:srgbClr val="0B0B0B"/>
+                </a:solidFill>
+                <a:latin typeface="Consolas"/>
+              </a:rPr>
+              <a:t>Workflow audit</a:t>
+            </a:r>
+            <a:r>
+              <a:rPr sz="1100" b="0">
+                <a:solidFill>
+                  <a:srgbClr val="0B0B0B"/>
+                </a:solidFill>
+                <a:latin typeface="Consolas"/>
+              </a:rPr>
+              <a:t>  Shows where automation frees up staff time for higher-value work.</a:t>
+            </a:r>
+            <a:endParaRPr lang="nl-BE" sz="1100" dirty="0">
+              <a:solidFill>
+                <a:srgbClr val="0B0B0B"/>
+              </a:solidFill>
+              <a:latin typeface="Consolas"/>
+            </a:endParaRPr>
+          </a:p>
+          <a:p>
+            <a:pPr>
+              <a:lnSpc>
+                <a:spcPct val="110000"/>
+              </a:lnSpc>
+              <a:spcAft>
+                <a:spcPts val="700"/>
+              </a:spcAft>
+            </a:pPr>
+            <a:r>
+              <a:rPr sz="1100" b="1">
+                <a:solidFill>
+                  <a:srgbClr val="0B0B0B"/>
+                </a:solidFill>
+                <a:latin typeface="Consolas"/>
+              </a:rPr>
+              <a:t>Consistency check</a:t>
+            </a:r>
+            <a:r>
+              <a:rPr sz="1100" b="0">
+                <a:solidFill>
+                  <a:srgbClr val="0B0B0B"/>
+                </a:solidFill>
+                <a:latin typeface="Consolas"/>
+              </a:rPr>
+              <a:t>  Catches formatting and citation-style mismatches.</a:t>
+            </a:r>
+            <a:endParaRPr sz="1100" b="0" dirty="0">
+              <a:solidFill>
+                <a:srgbClr val="0B0B0B"/>
+              </a:solidFill>
+              <a:latin typeface="Consolas"/>
+            </a:endParaRPr>
           </a:p>
         </p:txBody>
       </p:sp>
@@ -8365,169 +8757,14 @@
         </p:blipFill>
         <p:spPr>
           <a:xfrm>
-            <a:off x="10807293" y="201168"/>
-            <a:ext cx="1051560" cy="1051560"/>
+            <a:off x="9154214" y="182880"/>
+            <a:ext cx="2622379" cy="2622379"/>
           </a:xfrm>
           <a:prstGeom prst="rect">
             <a:avLst/>
           </a:prstGeom>
         </p:spPr>
       </p:pic>
-      <p:sp>
-        <p:nvSpPr>
-          <p:cNvPr id="25" name="Rounded Rectangle 24"/>
-          <p:cNvSpPr/>
-          <p:nvPr/>
-        </p:nvSpPr>
-        <p:spPr>
-          <a:xfrm>
-            <a:off x="6126480" y="2331720"/>
-            <a:ext cx="5029200" cy="3657600"/>
-          </a:xfrm>
-          <a:prstGeom prst="roundRect">
-            <a:avLst/>
-          </a:prstGeom>
-          <a:solidFill>
-            <a:srgbClr val="F0EFEC"/>
-          </a:solidFill>
-          <a:ln w="9525">
-            <a:solidFill>
-              <a:srgbClr val="E1E0D9"/>
-            </a:solidFill>
-          </a:ln>
-          <a:effectLst/>
-        </p:spPr>
-        <p:style>
-          <a:lnRef idx="1">
-            <a:schemeClr val="accent1"/>
-          </a:lnRef>
-          <a:fillRef idx="3">
-            <a:schemeClr val="accent1"/>
-          </a:fillRef>
-          <a:effectRef idx="2">
-            <a:schemeClr val="accent1"/>
-          </a:effectRef>
-          <a:fontRef idx="minor">
-            <a:schemeClr val="lt1"/>
-          </a:fontRef>
-        </p:style>
-        <p:txBody>
-          <a:bodyPr wrap="square" lIns="182880" tIns="137160" rIns="182880" bIns="137160" rtlCol="0" anchor="t"/>
-          <a:lstStyle/>
-          <a:p>
-            <a:pPr algn="l">
-              <a:lnSpc>
-                <a:spcPct val="110000"/>
-              </a:lnSpc>
-              <a:spcAft>
-                <a:spcPts val="700"/>
-              </a:spcAft>
-            </a:pPr>
-            <a:r>
-              <a:rPr sz="1100" b="1">
-                <a:solidFill>
-                  <a:srgbClr val="0B0B0B"/>
-                </a:solidFill>
-                <a:latin typeface="Consolas"/>
-              </a:rPr>
-              <a:t>/consistency-check [style]</a:t>
-            </a:r>
-            <a:r>
-              <a:rPr sz="1100" b="0">
-                <a:solidFill>
-                  <a:srgbClr val="0B0B0B"/>
-                </a:solidFill>
-                <a:latin typeface="Consolas"/>
-              </a:rPr>
-              <a:t>  Checks formatting and citation-style consistency.</a:t>
-            </a:r>
-          </a:p>
-          <a:p>
-            <a:pPr algn="l">
-              <a:lnSpc>
-                <a:spcPct val="110000"/>
-              </a:lnSpc>
-              <a:spcAft>
-                <a:spcPts val="700"/>
-              </a:spcAft>
-            </a:pPr>
-            <a:r>
-              <a:rPr sz="1100" b="1">
-                <a:solidFill>
-                  <a:srgbClr val="0B0B0B"/>
-                </a:solidFill>
-                <a:latin typeface="Consolas"/>
-              </a:rPr>
-              <a:t>/fwo-admissibility-check</a:t>
-            </a:r>
-            <a:r>
-              <a:rPr sz="1100" b="0">
-                <a:solidFill>
-                  <a:srgbClr val="0B0B0B"/>
-                </a:solidFill>
-                <a:latin typeface="Consolas"/>
-              </a:rPr>
-              <a:t>  FWO's own official eligibility rules for Fundamental Research Projects.</a:t>
-            </a:r>
-          </a:p>
-          <a:p>
-            <a:pPr algn="l">
-              <a:lnSpc>
-                <a:spcPct val="110000"/>
-              </a:lnSpc>
-              <a:spcAft>
-                <a:spcPts val="700"/>
-              </a:spcAft>
-            </a:pPr>
-            <a:r>
-              <a:rPr sz="1100" b="1">
-                <a:solidFill>
-                  <a:srgbClr val="0B0B0B"/>
-                </a:solidFill>
-                <a:latin typeface="Consolas"/>
-              </a:rPr>
-              <a:t>/fwo-reviewer [INTDIS]</a:t>
-            </a:r>
-            <a:r>
-              <a:rPr sz="1100" b="0">
-                <a:solidFill>
-                  <a:srgbClr val="0B0B0B"/>
-                </a:solidFill>
-                <a:latin typeface="Consolas"/>
-              </a:rPr>
-              <a:t>  Simulates an FWO panel review scored against FWO's real scoring grid.</a:t>
-            </a:r>
-          </a:p>
-          <a:p>
-            <a:pPr algn="l">
-              <a:lnSpc>
-                <a:spcPct val="110000"/>
-              </a:lnSpc>
-              <a:spcAft>
-                <a:spcPts val="700"/>
-              </a:spcAft>
-            </a:pPr>
-            <a:r>
-              <a:rPr sz="1100" b="1">
-                <a:solidFill>
-                  <a:srgbClr val="0B0B0B"/>
-                </a:solidFill>
-                <a:latin typeface="Consolas"/>
-              </a:rPr>
-              <a:t>/llm-wiki [ingest|query|lint]</a:t>
-            </a:r>
-            <a:r>
-              <a:rPr sz="1100" b="0">
-                <a:solidFill>
-                  <a:srgbClr val="0B0B0B"/>
-                </a:solidFill>
-                <a:latin typeface="Consolas"/>
-              </a:rPr>
-              <a:t>  Persistent markdown knowledge wiki instead of re-searching raw sources.</a:t>
-            </a:r>
-          </a:p>
-        </p:txBody>
-      </p:sp>
     </p:spTree>
     <p:extLst>
       <p:ext uri="{BB962C8B-B14F-4D97-AF65-F5344CB8AC3E}">
@@ -21167,30 +21404,6 @@
           <a:xfrm>
             <a:off x="5074920" y="6519672"/>
             <a:ext cx="771579" cy="182880"/>
-          </a:xfrm>
-          <a:prstGeom prst="rect">
-            <a:avLst/>
-          </a:prstGeom>
-        </p:spPr>
-      </p:pic>
-      <p:pic>
-        <p:nvPicPr>
-          <p:cNvPr id="24" name="Picture 23" descr="image.png"/>
-          <p:cNvPicPr>
-            <a:picLocks noChangeAspect="1"/>
-          </p:cNvPicPr>
-          <p:nvPr/>
-        </p:nvPicPr>
-        <p:blipFill>
-          <a:blip r:embed="rId5"/>
-          <a:stretch>
-            <a:fillRect/>
-          </a:stretch>
-        </p:blipFill>
-        <p:spPr>
-          <a:xfrm>
-            <a:off x="10807293" y="201168"/>
-            <a:ext cx="1051560" cy="1051560"/>
           </a:xfrm>
           <a:prstGeom prst="rect">
             <a:avLst/>

</xml_diff>

<commit_message>
Add test/evaluate/adjust loop to the FWO skill schematic (slide 12)
The pipeline was missing the iteration step: running a skill once isn't
the point, rerunning it after each revision is. Added a loop badge
(reusing the Level 6 circular-arrow icon) under the Skill -> Better
proposal junction, explicitly tying it back to the loop pattern shown
later on slide 15.
</commit_message>
<xml_diff>
--- a/Levels of Using AI in Research.pptx
+++ b/Levels of Using AI in Research.pptx
@@ -7259,34 +7259,7 @@
                 </a:solidFill>
                 <a:latin typeface="Segoe UI"/>
               </a:rPr>
-              <a:t>Every level from this talk, chained on one funder: raw files become a searchable knowledge base, </a:t>
-            </a:r>
-            <a:r>
-              <a:rPr lang="nl-BE" sz="1300" b="0" dirty="0" err="1">
-                <a:solidFill>
-                  <a:srgbClr val="898781"/>
-                </a:solidFill>
-                <a:latin typeface="Segoe UI"/>
-              </a:rPr>
-              <a:t>then</a:t>
-            </a:r>
-            <a:r>
-              <a:rPr lang="nl-BE" sz="1300" b="0" dirty="0">
-                <a:solidFill>
-                  <a:srgbClr val="898781"/>
-                </a:solidFill>
-                <a:latin typeface="Segoe UI"/>
-              </a:rPr>
-              <a:t> a</a:t>
-            </a:r>
-            <a:r>
-              <a:rPr lang="en-US" sz="1300" b="0" dirty="0">
-                <a:solidFill>
-                  <a:srgbClr val="898781"/>
-                </a:solidFill>
-                <a:latin typeface="Segoe UI"/>
-              </a:rPr>
-              <a:t> skill</a:t>
+              <a:t>Every level from this talk, chained on one funder: raw files become a searchable knowledge base, then a skill.</a:t>
             </a:r>
             <a:endParaRPr sz="1300" b="0" dirty="0">
               <a:solidFill>
@@ -7305,7 +7278,7 @@
         </p:nvSpPr>
         <p:spPr>
           <a:xfrm>
-            <a:off x="731520" y="3540000"/>
+            <a:off x="731520" y="4230000"/>
             <a:ext cx="10424160" cy="274320"/>
           </a:xfrm>
           <a:prstGeom prst="rect">
@@ -7339,8 +7312,8 @@
         </p:nvSpPr>
         <p:spPr>
           <a:xfrm>
-            <a:off x="731520" y="3880000"/>
-            <a:ext cx="10424160" cy="500000"/>
+            <a:off x="731520" y="4650000"/>
+            <a:ext cx="10424160" cy="450000"/>
           </a:xfrm>
           <a:prstGeom prst="rect">
             <a:avLst/>
@@ -7400,8 +7373,8 @@
         </p:nvSpPr>
         <p:spPr>
           <a:xfrm>
-            <a:off x="731520" y="4550000"/>
-            <a:ext cx="10424160" cy="550000"/>
+            <a:off x="731520" y="5250000"/>
+            <a:ext cx="10424160" cy="500000"/>
           </a:xfrm>
           <a:prstGeom prst="rect">
             <a:avLst/>
@@ -7443,7 +7416,7 @@
         </p:nvSpPr>
         <p:spPr>
           <a:xfrm>
-            <a:off x="731520" y="5739208"/>
+            <a:off x="731520" y="5900000"/>
             <a:ext cx="10424160" cy="365760"/>
           </a:xfrm>
           <a:prstGeom prst="rect">
@@ -7465,6 +7438,147 @@
                 <a:latin typeface="Segoe UI"/>
               </a:rPr>
               <a:t>Same recipe for any funder — swap the raw sources, and the skill rebuilds itself.</a:t>
+            </a:r>
+          </a:p>
+        </p:txBody>
+      </p:sp>
+      <p:sp>
+        <p:nvSpPr>
+          <p:cNvPr id="42" name="Loop Icon"/>
+          <p:cNvSpPr/>
+          <p:nvPr/>
+        </p:nvSpPr>
+        <p:spPr>
+          <a:xfrm rot="5400000">
+            <a:off x="7026520" y="3360000"/>
+            <a:ext cx="380000" cy="380000"/>
+          </a:xfrm>
+          <a:prstGeom prst="circularArrow">
+            <a:avLst>
+              <a:gd name="adj1" fmla="val 12500"/>
+              <a:gd name="adj2" fmla="val 1142319"/>
+              <a:gd name="adj3" fmla="val 20457681"/>
+              <a:gd name="adj4" fmla="val 5151147"/>
+              <a:gd name="adj5" fmla="val 12500"/>
+            </a:avLst>
+          </a:prstGeom>
+          <a:solidFill>
+            <a:srgbClr val="898781"/>
+          </a:solidFill>
+          <a:ln>
+            <a:noFill/>
+          </a:ln>
+          <a:effectLst/>
+        </p:spPr>
+        <p:style>
+          <a:lnRef idx="1">
+            <a:schemeClr val="accent1"/>
+          </a:lnRef>
+          <a:fillRef idx="3">
+            <a:schemeClr val="accent1"/>
+          </a:fillRef>
+          <a:effectRef idx="2">
+            <a:schemeClr val="accent1"/>
+          </a:effectRef>
+          <a:fontRef idx="minor">
+            <a:schemeClr val="lt1"/>
+          </a:fontRef>
+        </p:style>
+        <p:txBody>
+          <a:bodyPr rtlCol="0" anchor="ctr"/>
+          <a:lstStyle/>
+          <a:p>
+            <a:pPr algn="ctr"/>
+            <a:endParaRPr/>
+          </a:p>
+        </p:txBody>
+      </p:sp>
+      <p:sp>
+        <p:nvSpPr>
+          <p:cNvPr id="43" name="Loop Pill"/>
+          <p:cNvSpPr/>
+          <p:nvPr/>
+        </p:nvSpPr>
+        <p:spPr>
+          <a:xfrm>
+            <a:off x="7506520" y="3320000"/>
+            <a:ext cx="2600000" cy="460000"/>
+          </a:xfrm>
+          <a:prstGeom prst="roundRect">
+            <a:avLst>
+              <a:gd name="adj" fmla="val 10000"/>
+            </a:avLst>
+          </a:prstGeom>
+          <a:solidFill>
+            <a:srgbClr val="CDE2FB"/>
+          </a:solidFill>
+          <a:ln>
+            <a:noFill/>
+          </a:ln>
+          <a:effectLst/>
+        </p:spPr>
+        <p:style>
+          <a:lnRef idx="1">
+            <a:schemeClr val="accent1"/>
+          </a:lnRef>
+          <a:fillRef idx="3">
+            <a:schemeClr val="accent1"/>
+          </a:fillRef>
+          <a:effectRef idx="2">
+            <a:schemeClr val="accent1"/>
+          </a:effectRef>
+          <a:fontRef idx="minor">
+            <a:schemeClr val="lt1"/>
+          </a:fontRef>
+        </p:style>
+        <p:txBody>
+          <a:bodyPr wrap="square" tIns="54864" bIns="54864" rtlCol="0" anchor="ctr"/>
+          <a:lstStyle/>
+          <a:p>
+            <a:pPr algn="ctr"/>
+            <a:r>
+              <a:rPr sz="1300" b="1" i="0">
+                <a:solidFill>
+                  <a:srgbClr val="0B0B0B"/>
+                </a:solidFill>
+                <a:latin typeface="Segoe UI Semibold"/>
+              </a:rPr>
+              <a:t>Test → Evaluate → Adjust</a:t>
+            </a:r>
+          </a:p>
+        </p:txBody>
+      </p:sp>
+      <p:sp>
+        <p:nvSpPr>
+          <p:cNvPr id="44" name="TextBox 43"/>
+          <p:cNvSpPr txBox="1"/>
+          <p:nvPr/>
+        </p:nvSpPr>
+        <p:spPr>
+          <a:xfrm>
+            <a:off x="6071520" y="3820000"/>
+            <a:ext cx="4990000" cy="280000"/>
+          </a:xfrm>
+          <a:prstGeom prst="rect">
+            <a:avLst/>
+          </a:prstGeom>
+          <a:noFill/>
+        </p:spPr>
+        <p:txBody>
+          <a:bodyPr wrap="square">
+            <a:spAutoFit/>
+          </a:bodyPr>
+          <a:lstStyle/>
+          <a:p>
+            <a:pPr algn="ctr"/>
+            <a:r>
+              <a:rPr sz="1150" b="0">
+                <a:solidFill>
+                  <a:srgbClr val="898781"/>
+                </a:solidFill>
+                <a:latin typeface="Segoe UI"/>
+              </a:rPr>
+              <a:t>The Level 6 loop, run early: rerun the skill after each revision, until the check passes and the score clears your target.</a:t>
             </a:r>
           </a:p>
         </p:txBody>

</xml_diff>

<commit_message>
Tighten skill-library formatting and simplify slide 12 loop callout
Switch command/description separators to a colon style, shorten the
Extra header back to "Extra:", and drop the loop caption text under
the Test -> Evaluate -> Adjust badge on slide 12.
</commit_message>
<xml_diff>
--- a/Levels of Using AI in Research.pptx
+++ b/Levels of Using AI in Research.pptx
@@ -608,6 +608,219 @@
         <p:spPr/>
       </p:sp>
     </p:spTree>
+  </p:cSld>
+  <p:clrMapOvr>
+    <a:masterClrMapping/>
+  </p:clrMapOvr>
+</p:notes>
+</file>
+
+<file path=ppt/notesSlides/notesSlide2.xml><?xml version="1.0" encoding="utf-8"?>
+<p:notes xmlns:a="http://schemas.openxmlformats.org/drawingml/2006/main" xmlns:r="http://schemas.openxmlformats.org/officeDocument/2006/relationships" xmlns:p="http://schemas.openxmlformats.org/presentationml/2006/main">
+  <p:cSld>
+    <p:spTree>
+      <p:nvGrpSpPr>
+        <p:cNvPr id="1" name=""/>
+        <p:cNvGrpSpPr/>
+        <p:nvPr/>
+      </p:nvGrpSpPr>
+      <p:grpSpPr>
+        <a:xfrm>
+          <a:off x="0" y="0"/>
+          <a:ext cx="0" cy="0"/>
+          <a:chOff x="0" y="0"/>
+          <a:chExt cx="0" cy="0"/>
+        </a:xfrm>
+      </p:grpSpPr>
+      <p:sp>
+        <p:nvSpPr>
+          <p:cNvPr id="2" name="Slide Image Placeholder 1"/>
+          <p:cNvSpPr>
+            <a:spLocks noGrp="1" noRot="1" noChangeAspect="1"/>
+          </p:cNvSpPr>
+          <p:nvPr>
+            <p:ph type="sldImg"/>
+          </p:nvPr>
+        </p:nvSpPr>
+        <p:spPr/>
+      </p:sp>
+      <p:sp>
+        <p:nvSpPr>
+          <p:cNvPr id="3" name="Notes Placeholder 2"/>
+          <p:cNvSpPr>
+            <a:spLocks noGrp="1"/>
+          </p:cNvSpPr>
+          <p:nvPr>
+            <p:ph type="body" idx="1"/>
+          </p:nvPr>
+        </p:nvSpPr>
+        <p:spPr/>
+        <p:txBody>
+          <a:bodyPr/>
+          <a:lstStyle/>
+          <a:p>
+            <a:r>
+              <a:rPr lang="nl-BE" dirty="0"/>
+              <a:t>Loops </a:t>
+            </a:r>
+            <a:r>
+              <a:rPr lang="nl-BE" dirty="0" err="1"/>
+              <a:t>work</a:t>
+            </a:r>
+            <a:r>
+              <a:rPr lang="nl-BE" dirty="0"/>
+              <a:t> even </a:t>
+            </a:r>
+            <a:r>
+              <a:rPr lang="nl-BE" dirty="0" err="1"/>
+              <a:t>better</a:t>
+            </a:r>
+            <a:r>
+              <a:rPr lang="nl-BE" dirty="0"/>
+              <a:t> </a:t>
+            </a:r>
+            <a:r>
+              <a:rPr lang="nl-BE" dirty="0" err="1"/>
+              <a:t>if</a:t>
+            </a:r>
+            <a:r>
+              <a:rPr lang="nl-BE" dirty="0"/>
+              <a:t> </a:t>
+            </a:r>
+            <a:r>
+              <a:rPr lang="nl-BE" dirty="0" err="1"/>
+              <a:t>you</a:t>
+            </a:r>
+            <a:r>
+              <a:rPr lang="nl-BE" dirty="0"/>
+              <a:t> set </a:t>
+            </a:r>
+            <a:r>
+              <a:rPr lang="nl-BE" dirty="0" err="1"/>
+              <a:t>optimize</a:t>
+            </a:r>
+            <a:r>
+              <a:rPr lang="nl-BE" dirty="0"/>
+              <a:t> </a:t>
+            </a:r>
+            <a:r>
+              <a:rPr lang="nl-BE" dirty="0" err="1"/>
+              <a:t>for</a:t>
+            </a:r>
+            <a:r>
+              <a:rPr lang="nl-BE" dirty="0"/>
+              <a:t> x </a:t>
+            </a:r>
+            <a:r>
+              <a:rPr lang="nl-BE" dirty="0" err="1"/>
+              <a:t>and</a:t>
+            </a:r>
+            <a:r>
+              <a:rPr lang="nl-BE" dirty="0"/>
+              <a:t> y</a:t>
+            </a:r>
+          </a:p>
+          <a:p>
+            <a:r>
+              <a:rPr lang="nl-BE" dirty="0"/>
+              <a:t>Or </a:t>
+            </a:r>
+            <a:r>
+              <a:rPr lang="nl-BE" dirty="0" err="1"/>
+              <a:t>if</a:t>
+            </a:r>
+            <a:r>
+              <a:rPr lang="nl-BE" dirty="0"/>
+              <a:t> </a:t>
+            </a:r>
+            <a:r>
+              <a:rPr lang="nl-BE" dirty="0" err="1"/>
+              <a:t>you</a:t>
+            </a:r>
+            <a:r>
+              <a:rPr lang="nl-BE" dirty="0"/>
+              <a:t> have a list of </a:t>
+            </a:r>
+            <a:r>
+              <a:rPr lang="nl-BE" dirty="0" err="1"/>
+              <a:t>tasks</a:t>
+            </a:r>
+            <a:r>
+              <a:rPr lang="nl-BE" dirty="0"/>
+              <a:t> </a:t>
+            </a:r>
+            <a:r>
+              <a:rPr lang="nl-BE" dirty="0" err="1"/>
+              <a:t>and</a:t>
+            </a:r>
+            <a:r>
+              <a:rPr lang="nl-BE" dirty="0"/>
+              <a:t> </a:t>
+            </a:r>
+            <a:r>
+              <a:rPr lang="nl-BE" dirty="0" err="1"/>
+              <a:t>you</a:t>
+            </a:r>
+            <a:r>
+              <a:rPr lang="nl-BE" dirty="0"/>
+              <a:t> want </a:t>
+            </a:r>
+            <a:r>
+              <a:rPr lang="nl-BE" dirty="0" err="1"/>
+              <a:t>to</a:t>
+            </a:r>
+            <a:r>
+              <a:rPr lang="nl-BE" dirty="0"/>
+              <a:t> keep </a:t>
+            </a:r>
+            <a:r>
+              <a:rPr lang="nl-BE" dirty="0" err="1"/>
+              <a:t>the</a:t>
+            </a:r>
+            <a:r>
+              <a:rPr lang="nl-BE" dirty="0"/>
+              <a:t> context </a:t>
+            </a:r>
+            <a:r>
+              <a:rPr lang="nl-BE" dirty="0" err="1"/>
+              <a:t>window</a:t>
+            </a:r>
+            <a:r>
+              <a:rPr lang="nl-BE"/>
+              <a:t> clean</a:t>
+            </a:r>
+          </a:p>
+        </p:txBody>
+      </p:sp>
+      <p:sp>
+        <p:nvSpPr>
+          <p:cNvPr id="4" name="Slide Number Placeholder 3"/>
+          <p:cNvSpPr>
+            <a:spLocks noGrp="1"/>
+          </p:cNvSpPr>
+          <p:nvPr>
+            <p:ph type="sldNum" sz="quarter" idx="5"/>
+          </p:nvPr>
+        </p:nvSpPr>
+        <p:spPr/>
+        <p:txBody>
+          <a:bodyPr/>
+          <a:lstStyle/>
+          <a:p>
+            <a:fld id="{402002DD-0275-41CE-87EE-6CCAFDA78121}" type="slidenum">
+              <a:rPr lang="nl-BE" smtClean="0"/>
+              <a:t>15</a:t>
+            </a:fld>
+            <a:endParaRPr lang="nl-BE"/>
+          </a:p>
+        </p:txBody>
+      </p:sp>
+    </p:spTree>
+    <p:extLst>
+      <p:ext uri="{BB962C8B-B14F-4D97-AF65-F5344CB8AC3E}">
+        <p14:creationId xmlns:p14="http://schemas.microsoft.com/office/powerpoint/2010/main" val="60901462"/>
+      </p:ext>
+    </p:extLst>
   </p:cSld>
   <p:clrMapOvr>
     <a:masterClrMapping/>
@@ -7261,12 +7474,6 @@
               </a:rPr>
               <a:t>Every level from this talk, chained on one funder: raw files become a searchable knowledge base, then a skill.</a:t>
             </a:r>
-            <a:endParaRPr sz="1300" b="0" dirty="0">
-              <a:solidFill>
-                <a:srgbClr val="898781"/>
-              </a:solidFill>
-              <a:latin typeface="Segoe UI"/>
-            </a:endParaRPr>
           </a:p>
         </p:txBody>
       </p:sp>
@@ -7293,7 +7500,7 @@
           <a:lstStyle/>
           <a:p>
             <a:r>
-              <a:rPr sz="1200" b="1">
+              <a:rPr sz="1200" b="1" dirty="0">
                 <a:solidFill>
                   <a:srgbClr val="2A78D6"/>
                 </a:solidFill>
@@ -7449,8 +7656,8 @@
           <p:nvPr/>
         </p:nvSpPr>
         <p:spPr>
-          <a:xfrm rot="5400000">
-            <a:off x="7026520" y="3360000"/>
+          <a:xfrm rot="10800000">
+            <a:off x="9955198" y="3854822"/>
             <a:ext cx="380000" cy="380000"/>
           </a:xfrm>
           <a:prstGeom prst="circularArrow">
@@ -7501,7 +7708,7 @@
         </p:nvSpPr>
         <p:spPr>
           <a:xfrm>
-            <a:off x="7506520" y="3320000"/>
+            <a:off x="7506520" y="3540681"/>
             <a:ext cx="2600000" cy="460000"/>
           </a:xfrm>
           <a:prstGeom prst="roundRect">
@@ -7544,41 +7751,6 @@
                 <a:latin typeface="Segoe UI Semibold"/>
               </a:rPr>
               <a:t>Test → Evaluate → Adjust</a:t>
-            </a:r>
-          </a:p>
-        </p:txBody>
-      </p:sp>
-      <p:sp>
-        <p:nvSpPr>
-          <p:cNvPr id="44" name="TextBox 43"/>
-          <p:cNvSpPr txBox="1"/>
-          <p:nvPr/>
-        </p:nvSpPr>
-        <p:spPr>
-          <a:xfrm>
-            <a:off x="6071520" y="3820000"/>
-            <a:ext cx="4990000" cy="280000"/>
-          </a:xfrm>
-          <a:prstGeom prst="rect">
-            <a:avLst/>
-          </a:prstGeom>
-          <a:noFill/>
-        </p:spPr>
-        <p:txBody>
-          <a:bodyPr wrap="square">
-            <a:spAutoFit/>
-          </a:bodyPr>
-          <a:lstStyle/>
-          <a:p>
-            <a:pPr algn="ctr"/>
-            <a:r>
-              <a:rPr sz="1150" b="0">
-                <a:solidFill>
-                  <a:srgbClr val="898781"/>
-                </a:solidFill>
-                <a:latin typeface="Segoe UI"/>
-              </a:rPr>
-              <a:t>The Level 6 loop, run early: rerun the skill after each revision, until the check passes and the score clears your target.</a:t>
             </a:r>
           </a:p>
         </p:txBody>
@@ -7804,13 +7976,22 @@
               <a:t>/grant-evaluator [funder]</a:t>
             </a:r>
             <a:r>
+              <a:rPr lang="nl-BE" sz="1100" b="1" dirty="0">
+                <a:solidFill>
+                  <a:srgbClr val="0B0B0B"/>
+                </a:solidFill>
+                <a:latin typeface="Consolas"/>
+              </a:rPr>
+              <a:t>: </a:t>
+            </a:r>
+            <a:r>
               <a:rPr sz="1100" b="0" dirty="0">
                 <a:solidFill>
                   <a:srgbClr val="0B0B0B"/>
                 </a:solidFill>
                 <a:latin typeface="Consolas"/>
               </a:rPr>
-              <a:t>  Strict funder-style critique of a proposal section (default Horizon Europe).</a:t>
+              <a:t>Strict funder-style critique of a proposal section (default Horizon Europe).</a:t>
             </a:r>
           </a:p>
           <a:p>
@@ -7832,13 +8013,22 @@
               <a:t>/bias-omission-check</a:t>
             </a:r>
             <a:r>
+              <a:rPr lang="nl-BE" sz="1100" b="1" dirty="0">
+                <a:solidFill>
+                  <a:srgbClr val="0B0B0B"/>
+                </a:solidFill>
+                <a:latin typeface="Consolas"/>
+              </a:rPr>
+              <a:t>: </a:t>
+            </a:r>
+            <a:r>
               <a:rPr sz="1100" b="0" dirty="0">
                 <a:solidFill>
                   <a:srgbClr val="0B0B0B"/>
                 </a:solidFill>
                 <a:latin typeface="Consolas"/>
               </a:rPr>
-              <a:t>  Flags blind spots, inclusivity gaps, underrepresented stakeholders.</a:t>
+              <a:t>Flags blind spots, inclusivity gaps, underrepresented stakeholders.</a:t>
             </a:r>
           </a:p>
           <a:p>
@@ -7860,13 +8050,22 @@
               <a:t>/grill-me-for-research [n]</a:t>
             </a:r>
             <a:r>
+              <a:rPr lang="nl-BE" sz="1100" b="1" dirty="0">
+                <a:solidFill>
+                  <a:srgbClr val="0B0B0B"/>
+                </a:solidFill>
+                <a:latin typeface="Consolas"/>
+              </a:rPr>
+              <a:t>:</a:t>
+            </a:r>
+            <a:r>
               <a:rPr sz="1100" b="0" dirty="0">
                 <a:solidFill>
                   <a:srgbClr val="0B0B0B"/>
                 </a:solidFill>
                 <a:latin typeface="Consolas"/>
               </a:rPr>
-              <a:t>  Skeptical senior PI interrogates the proposal one question at a time.</a:t>
+              <a:t> Skeptical senior PI interrogates the proposal one question at a time.</a:t>
             </a:r>
           </a:p>
           <a:p>
@@ -7888,13 +8087,22 @@
               <a:t>/deconstruct-call [topic]</a:t>
             </a:r>
             <a:r>
+              <a:rPr lang="nl-BE" sz="1100" b="1" dirty="0">
+                <a:solidFill>
+                  <a:srgbClr val="0B0B0B"/>
+                </a:solidFill>
+                <a:latin typeface="Consolas"/>
+              </a:rPr>
+              <a:t>:</a:t>
+            </a:r>
+            <a:r>
               <a:rPr sz="1100" b="0" dirty="0">
                 <a:solidFill>
                   <a:srgbClr val="0B0B0B"/>
                 </a:solidFill>
                 <a:latin typeface="Consolas"/>
               </a:rPr>
-              <a:t>  Turns a funding call text into a compliance &amp; KPI checklist.</a:t>
+              <a:t> Turns a funding call text into a compliance &amp; KPI checklist.</a:t>
             </a:r>
           </a:p>
           <a:p>
@@ -7916,13 +8124,22 @@
               <a:t>/plain-language-polish</a:t>
             </a:r>
             <a:r>
+              <a:rPr lang="nl-BE" sz="1100" b="1" dirty="0">
+                <a:solidFill>
+                  <a:srgbClr val="0B0B0B"/>
+                </a:solidFill>
+                <a:latin typeface="Consolas"/>
+              </a:rPr>
+              <a:t>: </a:t>
+            </a:r>
+            <a:r>
               <a:rPr sz="1100" b="0" dirty="0">
                 <a:solidFill>
                   <a:srgbClr val="0B0B0B"/>
                 </a:solidFill>
                 <a:latin typeface="Consolas"/>
               </a:rPr>
-              <a:t>  Rewrites jargon for a diverse evaluation board.</a:t>
+              <a:t>Rewrites jargon for a diverse evaluation board.</a:t>
             </a:r>
             <a:endParaRPr lang="nl-BE" sz="1100" b="0" dirty="0">
               <a:solidFill>
@@ -7965,7 +8182,7 @@
                 </a:solidFill>
                 <a:latin typeface="Consolas"/>
               </a:rPr>
-              <a:t>-check [style]</a:t>
+              <a:t>-check [style]:</a:t>
             </a:r>
             <a:r>
               <a:rPr lang="nl-BE" sz="1100" dirty="0">
@@ -7974,7 +8191,7 @@
                 </a:solidFill>
                 <a:latin typeface="Consolas"/>
               </a:rPr>
-              <a:t>  Checks </a:t>
+              <a:t> Checks </a:t>
             </a:r>
             <a:r>
               <a:rPr lang="nl-BE" sz="1100" dirty="0" err="1">
@@ -8101,7 +8318,7 @@
                 </a:solidFill>
                 <a:latin typeface="Consolas"/>
               </a:rPr>
-              <a:t>]</a:t>
+              <a:t>]:</a:t>
             </a:r>
             <a:r>
               <a:rPr lang="nl-BE" sz="1100" dirty="0">
@@ -8110,7 +8327,7 @@
                 </a:solidFill>
                 <a:latin typeface="Consolas"/>
               </a:rPr>
-              <a:t>  Persistent </a:t>
+              <a:t> Persistent </a:t>
             </a:r>
             <a:r>
               <a:rPr lang="nl-BE" sz="1100" dirty="0" err="1">
@@ -8235,7 +8452,7 @@
                 </a:solidFill>
                 <a:latin typeface="Consolas"/>
               </a:rPr>
-              <a:t>Extra — more prompts worth testing:</a:t>
+              <a:t>Extra:</a:t>
             </a:r>
             <a:endParaRPr lang="nl-BE" sz="1100" b="0" dirty="0">
               <a:solidFill>
@@ -8254,7 +8471,7 @@
               </a:spcAft>
             </a:pPr>
             <a:r>
-              <a:rPr sz="1100" b="1">
+              <a:rPr sz="1100" b="1" dirty="0">
                 <a:solidFill>
                   <a:srgbClr val="0B0B0B"/>
                 </a:solidFill>
@@ -8263,13 +8480,22 @@
               <a:t>Deconstruct the call</a:t>
             </a:r>
             <a:r>
-              <a:rPr sz="1100" b="0">
+              <a:rPr lang="nl-BE" sz="1100" b="1" dirty="0">
                 <a:solidFill>
                   <a:srgbClr val="0B0B0B"/>
                 </a:solidFill>
                 <a:latin typeface="Consolas"/>
               </a:rPr>
-              <a:t>  Turns a funding call text into a compliance &amp; KPI checklist.</a:t>
+              <a:t>:</a:t>
+            </a:r>
+            <a:r>
+              <a:rPr sz="1100" b="0" dirty="0">
+                <a:solidFill>
+                  <a:srgbClr val="0B0B0B"/>
+                </a:solidFill>
+                <a:latin typeface="Consolas"/>
+              </a:rPr>
+              <a:t> Turns a funding call text into a compliance &amp; KPI checklist.</a:t>
             </a:r>
           </a:p>
           <a:p>
@@ -8282,7 +8508,7 @@
               </a:spcAft>
             </a:pPr>
             <a:r>
-              <a:rPr sz="1100" b="1">
+              <a:rPr sz="1100" b="1" dirty="0">
                 <a:solidFill>
                   <a:srgbClr val="0B0B0B"/>
                 </a:solidFill>
@@ -8291,13 +8517,22 @@
               <a:t>Plain-language polish</a:t>
             </a:r>
             <a:r>
-              <a:rPr sz="1100" b="0">
+              <a:rPr lang="nl-BE" sz="1100" b="1" dirty="0">
                 <a:solidFill>
                   <a:srgbClr val="0B0B0B"/>
                 </a:solidFill>
                 <a:latin typeface="Consolas"/>
               </a:rPr>
-              <a:t>  Rewrites jargon for a diverse evaluation board.</a:t>
+              <a:t>:</a:t>
+            </a:r>
+            <a:r>
+              <a:rPr sz="1100" b="0" dirty="0">
+                <a:solidFill>
+                  <a:srgbClr val="0B0B0B"/>
+                </a:solidFill>
+                <a:latin typeface="Consolas"/>
+              </a:rPr>
+              <a:t> Rewrites jargon for a diverse evaluation board.</a:t>
             </a:r>
           </a:p>
           <a:p>
@@ -8310,7 +8545,7 @@
               </a:spcAft>
             </a:pPr>
             <a:r>
-              <a:rPr sz="1100" b="1">
+              <a:rPr sz="1100" b="1" dirty="0">
                 <a:solidFill>
                   <a:srgbClr val="0B0B0B"/>
                 </a:solidFill>
@@ -8319,13 +8554,22 @@
               <a:t>Workflow audit</a:t>
             </a:r>
             <a:r>
-              <a:rPr sz="1100" b="0">
+              <a:rPr lang="nl-BE" sz="1100" b="1" dirty="0">
                 <a:solidFill>
                   <a:srgbClr val="0B0B0B"/>
                 </a:solidFill>
                 <a:latin typeface="Consolas"/>
               </a:rPr>
-              <a:t>  Shows where automation frees up staff time for higher-value work.</a:t>
+              <a:t>:</a:t>
+            </a:r>
+            <a:r>
+              <a:rPr sz="1100" b="0" dirty="0">
+                <a:solidFill>
+                  <a:srgbClr val="0B0B0B"/>
+                </a:solidFill>
+                <a:latin typeface="Consolas"/>
+              </a:rPr>
+              <a:t> Shows where automation frees up staff time for higher-value work.</a:t>
             </a:r>
             <a:endParaRPr lang="nl-BE" sz="1100" dirty="0">
               <a:solidFill>
@@ -8344,7 +8588,7 @@
               </a:spcAft>
             </a:pPr>
             <a:r>
-              <a:rPr sz="1100" b="1">
+              <a:rPr sz="1100" b="1" dirty="0">
                 <a:solidFill>
                   <a:srgbClr val="0B0B0B"/>
                 </a:solidFill>
@@ -8353,20 +8597,23 @@
               <a:t>Consistency check</a:t>
             </a:r>
             <a:r>
-              <a:rPr sz="1100" b="0">
+              <a:rPr lang="nl-BE" sz="1100" b="1" dirty="0">
                 <a:solidFill>
                   <a:srgbClr val="0B0B0B"/>
                 </a:solidFill>
                 <a:latin typeface="Consolas"/>
               </a:rPr>
-              <a:t>  Catches formatting and citation-style mismatches.</a:t>
-            </a:r>
-            <a:endParaRPr sz="1100" b="0" dirty="0">
-              <a:solidFill>
-                <a:srgbClr val="0B0B0B"/>
-              </a:solidFill>
-              <a:latin typeface="Consolas"/>
-            </a:endParaRPr>
+              <a:t>:</a:t>
+            </a:r>
+            <a:r>
+              <a:rPr sz="1100" b="0" dirty="0">
+                <a:solidFill>
+                  <a:srgbClr val="0B0B0B"/>
+                </a:solidFill>
+                <a:latin typeface="Consolas"/>
+              </a:rPr>
+              <a:t> Catches formatting and citation-style mismatches.</a:t>
+            </a:r>
           </a:p>
         </p:txBody>
       </p:sp>
@@ -9844,7 +10091,7 @@
           <p:nvPr/>
         </p:nvPicPr>
         <p:blipFill>
-          <a:blip r:embed="rId2"/>
+          <a:blip r:embed="rId3"/>
           <a:stretch>
             <a:fillRect/>
           </a:stretch>
@@ -11082,7 +11329,7 @@
           <p:nvPr/>
         </p:nvPicPr>
         <p:blipFill>
-          <a:blip r:embed="rId3"/>
+          <a:blip r:embed="rId4"/>
           <a:stretch>
             <a:fillRect/>
           </a:stretch>

</xml_diff>